<commit_message>
Mejorar legibilidad de botones MOVA y slide explicativa del inventario
Los botones teal del hub de documentos ahora muestran texto blanco legible
(con etiqueta encima) al excluir .mova-doc-btn del estilo de enlaces del portal.
Se añade slide y sección HTML «Inventario explicado» tras la tabla técnica,
con leyenda visual, diagrama de login fragmentado y chips de lectura rápida.
PPT y PDF regenerados (9 slides).

Co-authored-by: JosefaOgalde <JosefaOgalde@users.noreply.github.com>
</commit_message>
<xml_diff>
--- a/index/clientes/mkof/MOVA-D1-Inventario-Status.pptx
+++ b/index/clientes/mkof/MOVA-D1-Inventario-Status.pptx
@@ -12,6 +12,7 @@
     <p:sldId id="260" r:id="rId11"/>
     <p:sldId id="261" r:id="rId12"/>
     <p:sldId id="262" r:id="rId13"/>
+    <p:sldId id="263" r:id="rId14"/>
   </p:sldIdLst>
   <p:sldSz cx="12191695" cy="6858000" type="screen4x3"/>
   <p:notesSz cx="6858000" cy="9144000"/>
@@ -5823,7 +5824,7 @@
               </a:defRPr>
             </a:pPr>
             <a:r>
-              <a:t>Estructura cPanel</a:t>
+              <a:t>Inventario explicado</a:t>
             </a:r>
           </a:p>
         </p:txBody>
@@ -5858,107 +5859,1499 @@
               </a:defRPr>
             </a:pPr>
             <a:r>
-              <a:t>public_html/acme-chile.cl/</a:t>
-            </a:r>
-          </a:p>
-        </p:txBody>
-      </p:sp>
-      <p:sp>
-        <p:nvSpPr>
-          <p:cNvPr id="5" name="TextBox 4"/>
-          <p:cNvSpPr txBox="1"/>
-          <p:nvPr/>
-        </p:nvSpPr>
-        <p:spPr>
-          <a:xfrm>
-            <a:off x="685800" y="1280160"/>
-            <a:ext cx="10515600" cy="4754880"/>
-          </a:xfrm>
-          <a:prstGeom prst="rect">
-            <a:avLst/>
-          </a:prstGeom>
-          <a:noFill/>
-        </p:spPr>
-        <p:txBody>
-          <a:bodyPr wrap="square">
-            <a:spAutoFit/>
-          </a:bodyPr>
-          <a:lstStyle/>
-          <a:p>
-            <a:pPr algn="l">
-              <a:defRPr sz="1500" b="0">
+              <a:t>Para quienes no trabajan con código</a:t>
+            </a:r>
+          </a:p>
+        </p:txBody>
+      </p:sp>
+      <p:sp>
+        <p:nvSpPr>
+          <p:cNvPr id="5" name="Rounded Rectangle 4"/>
+          <p:cNvSpPr/>
+          <p:nvPr/>
+        </p:nvSpPr>
+        <p:spPr>
+          <a:xfrm>
+            <a:off x="502920" y="1234440"/>
+            <a:ext cx="2788920" cy="1417320"/>
+          </a:xfrm>
+          <a:prstGeom prst="roundRect">
+            <a:avLst/>
+          </a:prstGeom>
+          <a:solidFill>
+            <a:srgbClr val="FFFFFF"/>
+          </a:solidFill>
+          <a:ln>
+            <a:solidFill>
+              <a:srgbClr val="4A7A80"/>
+            </a:solidFill>
+          </a:ln>
+        </p:spPr>
+        <p:style>
+          <a:lnRef idx="1">
+            <a:schemeClr val="accent1"/>
+          </a:lnRef>
+          <a:fillRef idx="3">
+            <a:schemeClr val="accent1"/>
+          </a:fillRef>
+          <a:effectRef idx="2">
+            <a:schemeClr val="accent1"/>
+          </a:effectRef>
+          <a:fontRef idx="minor">
+            <a:schemeClr val="lt1"/>
+          </a:fontRef>
+        </p:style>
+        <p:txBody>
+          <a:bodyPr rtlCol="0" anchor="ctr"/>
+          <a:lstStyle/>
+          <a:p>
+            <a:pPr algn="ctr"/>
+          </a:p>
+        </p:txBody>
+      </p:sp>
+      <p:sp>
+        <p:nvSpPr>
+          <p:cNvPr id="6" name="TextBox 5"/>
+          <p:cNvSpPr txBox="1"/>
+          <p:nvPr/>
+        </p:nvSpPr>
+        <p:spPr>
+          <a:xfrm>
+            <a:off x="640080" y="1371600"/>
+            <a:ext cx="2514600" cy="320040"/>
+          </a:xfrm>
+          <a:prstGeom prst="rect">
+            <a:avLst/>
+          </a:prstGeom>
+          <a:noFill/>
+        </p:spPr>
+        <p:txBody>
+          <a:bodyPr wrap="square">
+            <a:spAutoFit/>
+          </a:bodyPr>
+          <a:lstStyle/>
+          <a:p>
+            <a:pPr algn="l">
+              <a:defRPr sz="1300" b="1">
+                <a:solidFill>
+                  <a:srgbClr val="2A4A4E"/>
+                </a:solidFill>
+              </a:defRPr>
+            </a:pPr>
+            <a:r>
+              <a:t>Módulo</a:t>
+            </a:r>
+          </a:p>
+        </p:txBody>
+      </p:sp>
+      <p:sp>
+        <p:nvSpPr>
+          <p:cNvPr id="7" name="TextBox 6"/>
+          <p:cNvSpPr txBox="1"/>
+          <p:nvPr/>
+        </p:nvSpPr>
+        <p:spPr>
+          <a:xfrm>
+            <a:off x="640080" y="1737360"/>
+            <a:ext cx="2514600" cy="822960"/>
+          </a:xfrm>
+          <a:prstGeom prst="rect">
+            <a:avLst/>
+          </a:prstGeom>
+          <a:noFill/>
+        </p:spPr>
+        <p:txBody>
+          <a:bodyPr wrap="square">
+            <a:spAutoFit/>
+          </a:bodyPr>
+          <a:lstStyle/>
+          <a:p>
+            <a:pPr algn="l">
+              <a:defRPr sz="1100" b="0">
                 <a:solidFill>
                   <a:srgbClr val="1F2328"/>
                 </a:solidFill>
               </a:defRPr>
             </a:pPr>
             <a:r>
-              <a:t>admin · axon · axon-news · Boletin_Axon · crm · documentos</a:t>
+              <a:t>Cada app o sección del sitio (portal, ERP, AXON…).</a:t>
+            </a:r>
+          </a:p>
+        </p:txBody>
+      </p:sp>
+      <p:sp>
+        <p:nvSpPr>
+          <p:cNvPr id="8" name="Rounded Rectangle 7"/>
+          <p:cNvSpPr/>
+          <p:nvPr/>
+        </p:nvSpPr>
+        <p:spPr>
+          <a:xfrm>
+            <a:off x="3383280" y="1234440"/>
+            <a:ext cx="2788920" cy="1417320"/>
+          </a:xfrm>
+          <a:prstGeom prst="roundRect">
+            <a:avLst/>
+          </a:prstGeom>
+          <a:solidFill>
+            <a:srgbClr val="FFFFFF"/>
+          </a:solidFill>
+          <a:ln>
+            <a:solidFill>
+              <a:srgbClr val="4A7A80"/>
+            </a:solidFill>
+          </a:ln>
+        </p:spPr>
+        <p:style>
+          <a:lnRef idx="1">
+            <a:schemeClr val="accent1"/>
+          </a:lnRef>
+          <a:fillRef idx="3">
+            <a:schemeClr val="accent1"/>
+          </a:fillRef>
+          <a:effectRef idx="2">
+            <a:schemeClr val="accent1"/>
+          </a:effectRef>
+          <a:fontRef idx="minor">
+            <a:schemeClr val="lt1"/>
+          </a:fontRef>
+        </p:style>
+        <p:txBody>
+          <a:bodyPr rtlCol="0" anchor="ctr"/>
+          <a:lstStyle/>
+          <a:p>
+            <a:pPr algn="ctr"/>
+          </a:p>
+        </p:txBody>
+      </p:sp>
+      <p:sp>
+        <p:nvSpPr>
+          <p:cNvPr id="9" name="TextBox 8"/>
+          <p:cNvSpPr txBox="1"/>
+          <p:nvPr/>
+        </p:nvSpPr>
+        <p:spPr>
+          <a:xfrm>
+            <a:off x="3520440" y="1371600"/>
+            <a:ext cx="2514600" cy="320040"/>
+          </a:xfrm>
+          <a:prstGeom prst="rect">
+            <a:avLst/>
+          </a:prstGeom>
+          <a:noFill/>
+        </p:spPr>
+        <p:txBody>
+          <a:bodyPr wrap="square">
+            <a:spAutoFit/>
+          </a:bodyPr>
+          <a:lstStyle/>
+          <a:p>
+            <a:pPr algn="l">
+              <a:defRPr sz="1300" b="1">
+                <a:solidFill>
+                  <a:srgbClr val="2A4A4E"/>
+                </a:solidFill>
+              </a:defRPr>
+            </a:pPr>
+            <a:r>
+              <a:t>Auth</a:t>
+            </a:r>
+          </a:p>
+        </p:txBody>
+      </p:sp>
+      <p:sp>
+        <p:nvSpPr>
+          <p:cNvPr id="10" name="TextBox 9"/>
+          <p:cNvSpPr txBox="1"/>
+          <p:nvPr/>
+        </p:nvSpPr>
+        <p:spPr>
+          <a:xfrm>
+            <a:off x="3520440" y="1737360"/>
+            <a:ext cx="2514600" cy="822960"/>
+          </a:xfrm>
+          <a:prstGeom prst="rect">
+            <a:avLst/>
+          </a:prstGeom>
+          <a:noFill/>
+        </p:spPr>
+        <p:txBody>
+          <a:bodyPr wrap="square">
+            <a:spAutoFit/>
+          </a:bodyPr>
+          <a:lstStyle/>
+          <a:p>
+            <a:pPr algn="l">
+              <a:defRPr sz="1100" b="0">
+                <a:solidFill>
+                  <a:srgbClr val="1F2328"/>
+                </a:solidFill>
+              </a:defRPr>
+            </a:pPr>
+            <a:r>
+              <a:t>Cómo entra el usuario: Google, clave, o sin login.</a:t>
+            </a:r>
+          </a:p>
+        </p:txBody>
+      </p:sp>
+      <p:sp>
+        <p:nvSpPr>
+          <p:cNvPr id="11" name="Rounded Rectangle 10"/>
+          <p:cNvSpPr/>
+          <p:nvPr/>
+        </p:nvSpPr>
+        <p:spPr>
+          <a:xfrm>
+            <a:off x="6263640" y="1234440"/>
+            <a:ext cx="2788920" cy="1417320"/>
+          </a:xfrm>
+          <a:prstGeom prst="roundRect">
+            <a:avLst/>
+          </a:prstGeom>
+          <a:solidFill>
+            <a:srgbClr val="FFFFFF"/>
+          </a:solidFill>
+          <a:ln>
+            <a:solidFill>
+              <a:srgbClr val="4A7A80"/>
+            </a:solidFill>
+          </a:ln>
+        </p:spPr>
+        <p:style>
+          <a:lnRef idx="1">
+            <a:schemeClr val="accent1"/>
+          </a:lnRef>
+          <a:fillRef idx="3">
+            <a:schemeClr val="accent1"/>
+          </a:fillRef>
+          <a:effectRef idx="2">
+            <a:schemeClr val="accent1"/>
+          </a:effectRef>
+          <a:fontRef idx="minor">
+            <a:schemeClr val="lt1"/>
+          </a:fontRef>
+        </p:style>
+        <p:txBody>
+          <a:bodyPr rtlCol="0" anchor="ctr"/>
+          <a:lstStyle/>
+          <a:p>
+            <a:pPr algn="ctr"/>
+          </a:p>
+        </p:txBody>
+      </p:sp>
+      <p:sp>
+        <p:nvSpPr>
+          <p:cNvPr id="12" name="TextBox 11"/>
+          <p:cNvSpPr txBox="1"/>
+          <p:nvPr/>
+        </p:nvSpPr>
+        <p:spPr>
+          <a:xfrm>
+            <a:off x="6400800" y="1371600"/>
+            <a:ext cx="2514600" cy="320040"/>
+          </a:xfrm>
+          <a:prstGeom prst="rect">
+            <a:avLst/>
+          </a:prstGeom>
+          <a:noFill/>
+        </p:spPr>
+        <p:txBody>
+          <a:bodyPr wrap="square">
+            <a:spAutoFit/>
+          </a:bodyPr>
+          <a:lstStyle/>
+          <a:p>
+            <a:pPr algn="l">
+              <a:defRPr sz="1300" b="1">
+                <a:solidFill>
+                  <a:srgbClr val="2A4A4E"/>
+                </a:solidFill>
+              </a:defRPr>
+            </a:pPr>
+            <a:r>
+              <a:t>localStorage</a:t>
+            </a:r>
+          </a:p>
+        </p:txBody>
+      </p:sp>
+      <p:sp>
+        <p:nvSpPr>
+          <p:cNvPr id="13" name="TextBox 12"/>
+          <p:cNvSpPr txBox="1"/>
+          <p:nvPr/>
+        </p:nvSpPr>
+        <p:spPr>
+          <a:xfrm>
+            <a:off x="6400800" y="1737360"/>
+            <a:ext cx="2514600" cy="822960"/>
+          </a:xfrm>
+          <a:prstGeom prst="rect">
+            <a:avLst/>
+          </a:prstGeom>
+          <a:noFill/>
+        </p:spPr>
+        <p:txBody>
+          <a:bodyPr wrap="square">
+            <a:spAutoFit/>
+          </a:bodyPr>
+          <a:lstStyle/>
+          <a:p>
+            <a:pPr algn="l">
+              <a:defRPr sz="1100" b="0">
+                <a:solidFill>
+                  <a:srgbClr val="1F2328"/>
+                </a:solidFill>
+              </a:defRPr>
+            </a:pPr>
+            <a:r>
+              <a:t>Datos guardados en el navegador del usuario.</a:t>
+            </a:r>
+          </a:p>
+        </p:txBody>
+      </p:sp>
+      <p:sp>
+        <p:nvSpPr>
+          <p:cNvPr id="14" name="Rounded Rectangle 13"/>
+          <p:cNvSpPr/>
+          <p:nvPr/>
+        </p:nvSpPr>
+        <p:spPr>
+          <a:xfrm>
+            <a:off x="9144000" y="1234440"/>
+            <a:ext cx="2788920" cy="1417320"/>
+          </a:xfrm>
+          <a:prstGeom prst="roundRect">
+            <a:avLst/>
+          </a:prstGeom>
+          <a:solidFill>
+            <a:srgbClr val="FFFFFF"/>
+          </a:solidFill>
+          <a:ln>
+            <a:solidFill>
+              <a:srgbClr val="4A7A80"/>
+            </a:solidFill>
+          </a:ln>
+        </p:spPr>
+        <p:style>
+          <a:lnRef idx="1">
+            <a:schemeClr val="accent1"/>
+          </a:lnRef>
+          <a:fillRef idx="3">
+            <a:schemeClr val="accent1"/>
+          </a:fillRef>
+          <a:effectRef idx="2">
+            <a:schemeClr val="accent1"/>
+          </a:effectRef>
+          <a:fontRef idx="minor">
+            <a:schemeClr val="lt1"/>
+          </a:fontRef>
+        </p:style>
+        <p:txBody>
+          <a:bodyPr rtlCol="0" anchor="ctr"/>
+          <a:lstStyle/>
+          <a:p>
+            <a:pPr algn="ctr"/>
+          </a:p>
+        </p:txBody>
+      </p:sp>
+      <p:sp>
+        <p:nvSpPr>
+          <p:cNvPr id="15" name="TextBox 14"/>
+          <p:cNvSpPr txBox="1"/>
+          <p:nvPr/>
+        </p:nvSpPr>
+        <p:spPr>
+          <a:xfrm>
+            <a:off x="9281160" y="1371600"/>
+            <a:ext cx="2514600" cy="320040"/>
+          </a:xfrm>
+          <a:prstGeom prst="rect">
+            <a:avLst/>
+          </a:prstGeom>
+          <a:noFill/>
+        </p:spPr>
+        <p:txBody>
+          <a:bodyPr wrap="square">
+            <a:spAutoFit/>
+          </a:bodyPr>
+          <a:lstStyle/>
+          <a:p>
+            <a:pPr algn="l">
+              <a:defRPr sz="1300" b="1">
+                <a:solidFill>
+                  <a:srgbClr val="2A4A4E"/>
+                </a:solidFill>
+              </a:defRPr>
+            </a:pPr>
+            <a:r>
+              <a:t>mova_auth</a:t>
+            </a:r>
+          </a:p>
+        </p:txBody>
+      </p:sp>
+      <p:sp>
+        <p:nvSpPr>
+          <p:cNvPr id="16" name="TextBox 15"/>
+          <p:cNvSpPr txBox="1"/>
+          <p:nvPr/>
+        </p:nvSpPr>
+        <p:spPr>
+          <a:xfrm>
+            <a:off x="9281160" y="1737360"/>
+            <a:ext cx="2514600" cy="822960"/>
+          </a:xfrm>
+          <a:prstGeom prst="rect">
+            <a:avLst/>
+          </a:prstGeom>
+          <a:noFill/>
+        </p:spPr>
+        <p:txBody>
+          <a:bodyPr wrap="square">
+            <a:spAutoFit/>
+          </a:bodyPr>
+          <a:lstStyle/>
+          <a:p>
+            <a:pPr algn="l">
+              <a:defRPr sz="1100" b="0">
+                <a:solidFill>
+                  <a:srgbClr val="1F2328"/>
+                </a:solidFill>
+              </a:defRPr>
+            </a:pPr>
+            <a:r>
+              <a:t>¿Pasa por el login unificado? sí · no · parcial</a:t>
+            </a:r>
+          </a:p>
+        </p:txBody>
+      </p:sp>
+      <p:sp>
+        <p:nvSpPr>
+          <p:cNvPr id="17" name="TextBox 16"/>
+          <p:cNvSpPr txBox="1"/>
+          <p:nvPr/>
+        </p:nvSpPr>
+        <p:spPr>
+          <a:xfrm>
+            <a:off x="502920" y="2880360"/>
+            <a:ext cx="5029200" cy="320040"/>
+          </a:xfrm>
+          <a:prstGeom prst="rect">
+            <a:avLst/>
+          </a:prstGeom>
+          <a:noFill/>
+        </p:spPr>
+        <p:txBody>
+          <a:bodyPr wrap="square">
+            <a:spAutoFit/>
+          </a:bodyPr>
+          <a:lstStyle/>
+          <a:p>
+            <a:pPr algn="l">
+              <a:defRPr sz="1400" b="1">
+                <a:solidFill>
+                  <a:srgbClr val="BF3F00"/>
+                </a:solidFill>
+              </a:defRPr>
+            </a:pPr>
+            <a:r>
+              <a:t>Hoy: varias puertas de entrada</a:t>
+            </a:r>
+          </a:p>
+        </p:txBody>
+      </p:sp>
+      <p:sp>
+        <p:nvSpPr>
+          <p:cNvPr id="18" name="Rounded Rectangle 17"/>
+          <p:cNvSpPr/>
+          <p:nvPr/>
+        </p:nvSpPr>
+        <p:spPr>
+          <a:xfrm>
+            <a:off x="502920" y="3246120"/>
+            <a:ext cx="1234440" cy="685800"/>
+          </a:xfrm>
+          <a:prstGeom prst="roundRect">
+            <a:avLst/>
+          </a:prstGeom>
+          <a:solidFill>
+            <a:srgbClr val="FFE8D6"/>
+          </a:solidFill>
+          <a:ln>
+            <a:solidFill>
+              <a:srgbClr val="BF3F00"/>
+            </a:solidFill>
+          </a:ln>
+        </p:spPr>
+        <p:style>
+          <a:lnRef idx="1">
+            <a:schemeClr val="accent1"/>
+          </a:lnRef>
+          <a:fillRef idx="3">
+            <a:schemeClr val="accent1"/>
+          </a:fillRef>
+          <a:effectRef idx="2">
+            <a:schemeClr val="accent1"/>
+          </a:effectRef>
+          <a:fontRef idx="minor">
+            <a:schemeClr val="lt1"/>
+          </a:fontRef>
+        </p:style>
+        <p:txBody>
+          <a:bodyPr rtlCol="0" anchor="ctr"/>
+          <a:lstStyle/>
+          <a:p>
+            <a:pPr algn="ctr"/>
+          </a:p>
+        </p:txBody>
+      </p:sp>
+      <p:sp>
+        <p:nvSpPr>
+          <p:cNvPr id="19" name="TextBox 18"/>
+          <p:cNvSpPr txBox="1"/>
+          <p:nvPr/>
+        </p:nvSpPr>
+        <p:spPr>
+          <a:xfrm>
+            <a:off x="502920" y="3401568"/>
+            <a:ext cx="1234440" cy="365760"/>
+          </a:xfrm>
+          <a:prstGeom prst="rect">
+            <a:avLst/>
+          </a:prstGeom>
+          <a:noFill/>
+        </p:spPr>
+        <p:txBody>
+          <a:bodyPr wrap="square">
+            <a:spAutoFit/>
+          </a:bodyPr>
+          <a:lstStyle/>
+          <a:p>
+            <a:pPr algn="ctr">
+              <a:defRPr sz="1000" b="1">
+                <a:solidFill>
+                  <a:srgbClr val="BF3F00"/>
+                </a:solidFill>
+              </a:defRPr>
+            </a:pPr>
+            <a:r>
+              <a:t>Google</a:t>
+            </a:r>
+          </a:p>
+        </p:txBody>
+      </p:sp>
+      <p:sp>
+        <p:nvSpPr>
+          <p:cNvPr id="20" name="Rounded Rectangle 19"/>
+          <p:cNvSpPr/>
+          <p:nvPr/>
+        </p:nvSpPr>
+        <p:spPr>
+          <a:xfrm>
+            <a:off x="1874519" y="3246120"/>
+            <a:ext cx="1234440" cy="685800"/>
+          </a:xfrm>
+          <a:prstGeom prst="roundRect">
+            <a:avLst/>
+          </a:prstGeom>
+          <a:solidFill>
+            <a:srgbClr val="FFE8D6"/>
+          </a:solidFill>
+          <a:ln>
+            <a:solidFill>
+              <a:srgbClr val="BF3F00"/>
+            </a:solidFill>
+          </a:ln>
+        </p:spPr>
+        <p:style>
+          <a:lnRef idx="1">
+            <a:schemeClr val="accent1"/>
+          </a:lnRef>
+          <a:fillRef idx="3">
+            <a:schemeClr val="accent1"/>
+          </a:fillRef>
+          <a:effectRef idx="2">
+            <a:schemeClr val="accent1"/>
+          </a:effectRef>
+          <a:fontRef idx="minor">
+            <a:schemeClr val="lt1"/>
+          </a:fontRef>
+        </p:style>
+        <p:txBody>
+          <a:bodyPr rtlCol="0" anchor="ctr"/>
+          <a:lstStyle/>
+          <a:p>
+            <a:pPr algn="ctr"/>
+          </a:p>
+        </p:txBody>
+      </p:sp>
+      <p:sp>
+        <p:nvSpPr>
+          <p:cNvPr id="21" name="TextBox 20"/>
+          <p:cNvSpPr txBox="1"/>
+          <p:nvPr/>
+        </p:nvSpPr>
+        <p:spPr>
+          <a:xfrm>
+            <a:off x="1874519" y="3401568"/>
+            <a:ext cx="1234440" cy="365760"/>
+          </a:xfrm>
+          <a:prstGeom prst="rect">
+            <a:avLst/>
+          </a:prstGeom>
+          <a:noFill/>
+        </p:spPr>
+        <p:txBody>
+          <a:bodyPr wrap="square">
+            <a:spAutoFit/>
+          </a:bodyPr>
+          <a:lstStyle/>
+          <a:p>
+            <a:pPr algn="ctr">
+              <a:defRPr sz="1000" b="1">
+                <a:solidFill>
+                  <a:srgbClr val="BF3F00"/>
+                </a:solidFill>
+              </a:defRPr>
+            </a:pPr>
+            <a:r>
+              <a:t>PHP clave</a:t>
+            </a:r>
+          </a:p>
+        </p:txBody>
+      </p:sp>
+      <p:sp>
+        <p:nvSpPr>
+          <p:cNvPr id="22" name="Rounded Rectangle 21"/>
+          <p:cNvSpPr/>
+          <p:nvPr/>
+        </p:nvSpPr>
+        <p:spPr>
+          <a:xfrm>
+            <a:off x="3246120" y="3246120"/>
+            <a:ext cx="1234440" cy="685800"/>
+          </a:xfrm>
+          <a:prstGeom prst="roundRect">
+            <a:avLst/>
+          </a:prstGeom>
+          <a:solidFill>
+            <a:srgbClr val="FFE8D6"/>
+          </a:solidFill>
+          <a:ln>
+            <a:solidFill>
+              <a:srgbClr val="BF3F00"/>
+            </a:solidFill>
+          </a:ln>
+        </p:spPr>
+        <p:style>
+          <a:lnRef idx="1">
+            <a:schemeClr val="accent1"/>
+          </a:lnRef>
+          <a:fillRef idx="3">
+            <a:schemeClr val="accent1"/>
+          </a:fillRef>
+          <a:effectRef idx="2">
+            <a:schemeClr val="accent1"/>
+          </a:effectRef>
+          <a:fontRef idx="minor">
+            <a:schemeClr val="lt1"/>
+          </a:fontRef>
+        </p:style>
+        <p:txBody>
+          <a:bodyPr rtlCol="0" anchor="ctr"/>
+          <a:lstStyle/>
+          <a:p>
+            <a:pPr algn="ctr"/>
+          </a:p>
+        </p:txBody>
+      </p:sp>
+      <p:sp>
+        <p:nvSpPr>
+          <p:cNvPr id="23" name="TextBox 22"/>
+          <p:cNvSpPr txBox="1"/>
+          <p:nvPr/>
+        </p:nvSpPr>
+        <p:spPr>
+          <a:xfrm>
+            <a:off x="3246120" y="3401568"/>
+            <a:ext cx="1234440" cy="365760"/>
+          </a:xfrm>
+          <a:prstGeom prst="rect">
+            <a:avLst/>
+          </a:prstGeom>
+          <a:noFill/>
+        </p:spPr>
+        <p:txBody>
+          <a:bodyPr wrap="square">
+            <a:spAutoFit/>
+          </a:bodyPr>
+          <a:lstStyle/>
+          <a:p>
+            <a:pPr algn="ctr">
+              <a:defRPr sz="1000" b="1">
+                <a:solidFill>
+                  <a:srgbClr val="BF3F00"/>
+                </a:solidFill>
+              </a:defRPr>
+            </a:pPr>
+            <a:r>
+              <a:t>Contraseña ERP</a:t>
+            </a:r>
+          </a:p>
+        </p:txBody>
+      </p:sp>
+      <p:sp>
+        <p:nvSpPr>
+          <p:cNvPr id="24" name="Rounded Rectangle 23"/>
+          <p:cNvSpPr/>
+          <p:nvPr/>
+        </p:nvSpPr>
+        <p:spPr>
+          <a:xfrm>
+            <a:off x="4617720" y="3246120"/>
+            <a:ext cx="1234440" cy="685800"/>
+          </a:xfrm>
+          <a:prstGeom prst="roundRect">
+            <a:avLst/>
+          </a:prstGeom>
+          <a:solidFill>
+            <a:srgbClr val="FFE8D6"/>
+          </a:solidFill>
+          <a:ln>
+            <a:solidFill>
+              <a:srgbClr val="BF3F00"/>
+            </a:solidFill>
+          </a:ln>
+        </p:spPr>
+        <p:style>
+          <a:lnRef idx="1">
+            <a:schemeClr val="accent1"/>
+          </a:lnRef>
+          <a:fillRef idx="3">
+            <a:schemeClr val="accent1"/>
+          </a:fillRef>
+          <a:effectRef idx="2">
+            <a:schemeClr val="accent1"/>
+          </a:effectRef>
+          <a:fontRef idx="minor">
+            <a:schemeClr val="lt1"/>
+          </a:fontRef>
+        </p:style>
+        <p:txBody>
+          <a:bodyPr rtlCol="0" anchor="ctr"/>
+          <a:lstStyle/>
+          <a:p>
+            <a:pPr algn="ctr"/>
+          </a:p>
+        </p:txBody>
+      </p:sp>
+      <p:sp>
+        <p:nvSpPr>
+          <p:cNvPr id="25" name="TextBox 24"/>
+          <p:cNvSpPr txBox="1"/>
+          <p:nvPr/>
+        </p:nvSpPr>
+        <p:spPr>
+          <a:xfrm>
+            <a:off x="4617720" y="3401568"/>
+            <a:ext cx="1234440" cy="365760"/>
+          </a:xfrm>
+          <a:prstGeom prst="rect">
+            <a:avLst/>
+          </a:prstGeom>
+          <a:noFill/>
+        </p:spPr>
+        <p:txBody>
+          <a:bodyPr wrap="square">
+            <a:spAutoFit/>
+          </a:bodyPr>
+          <a:lstStyle/>
+          <a:p>
+            <a:pPr algn="ctr">
+              <a:defRPr sz="1000" b="1">
+                <a:solidFill>
+                  <a:srgbClr val="BF3F00"/>
+                </a:solidFill>
+              </a:defRPr>
+            </a:pPr>
+            <a:r>
+              <a:t>Sin login</a:t>
+            </a:r>
+          </a:p>
+        </p:txBody>
+      </p:sp>
+      <p:sp>
+        <p:nvSpPr>
+          <p:cNvPr id="26" name="Right Arrow 25"/>
+          <p:cNvSpPr/>
+          <p:nvPr/>
+        </p:nvSpPr>
+        <p:spPr>
+          <a:xfrm>
+            <a:off x="5623560" y="3429000"/>
+            <a:ext cx="502920" cy="320040"/>
+          </a:xfrm>
+          <a:prstGeom prst="rightArrow">
+            <a:avLst/>
+          </a:prstGeom>
+          <a:solidFill>
+            <a:srgbClr val="4A7A80"/>
+          </a:solidFill>
+          <a:ln>
+            <a:noFill/>
+          </a:ln>
+        </p:spPr>
+        <p:style>
+          <a:lnRef idx="1">
+            <a:schemeClr val="accent1"/>
+          </a:lnRef>
+          <a:fillRef idx="3">
+            <a:schemeClr val="accent1"/>
+          </a:fillRef>
+          <a:effectRef idx="2">
+            <a:schemeClr val="accent1"/>
+          </a:effectRef>
+          <a:fontRef idx="minor">
+            <a:schemeClr val="lt1"/>
+          </a:fontRef>
+        </p:style>
+        <p:txBody>
+          <a:bodyPr rtlCol="0" anchor="ctr"/>
+          <a:lstStyle/>
+          <a:p>
+            <a:pPr algn="ctr"/>
+          </a:p>
+        </p:txBody>
+      </p:sp>
+      <p:sp>
+        <p:nvSpPr>
+          <p:cNvPr id="27" name="TextBox 26"/>
+          <p:cNvSpPr txBox="1"/>
+          <p:nvPr/>
+        </p:nvSpPr>
+        <p:spPr>
+          <a:xfrm>
+            <a:off x="6263640" y="2880360"/>
+            <a:ext cx="5303520" cy="320040"/>
+          </a:xfrm>
+          <a:prstGeom prst="rect">
+            <a:avLst/>
+          </a:prstGeom>
+          <a:noFill/>
+        </p:spPr>
+        <p:txBody>
+          <a:bodyPr wrap="square">
+            <a:spAutoFit/>
+          </a:bodyPr>
+          <a:lstStyle/>
+          <a:p>
+            <a:pPr algn="l">
+              <a:defRPr sz="1400" b="1">
+                <a:solidFill>
+                  <a:srgbClr val="1A7F37"/>
+                </a:solidFill>
+              </a:defRPr>
+            </a:pPr>
+            <a:r>
+              <a:t>Objetivo MOVA: una sola puerta</a:t>
+            </a:r>
+          </a:p>
+        </p:txBody>
+      </p:sp>
+      <p:sp>
+        <p:nvSpPr>
+          <p:cNvPr id="28" name="Rounded Rectangle 27"/>
+          <p:cNvSpPr/>
+          <p:nvPr/>
+        </p:nvSpPr>
+        <p:spPr>
+          <a:xfrm>
+            <a:off x="6583680" y="3246120"/>
+            <a:ext cx="4114800" cy="685800"/>
+          </a:xfrm>
+          <a:prstGeom prst="roundRect">
+            <a:avLst/>
+          </a:prstGeom>
+          <a:solidFill>
+            <a:srgbClr val="D4EDDA"/>
+          </a:solidFill>
+          <a:ln>
+            <a:solidFill>
+              <a:srgbClr val="1A7F37"/>
+            </a:solidFill>
+          </a:ln>
+        </p:spPr>
+        <p:style>
+          <a:lnRef idx="1">
+            <a:schemeClr val="accent1"/>
+          </a:lnRef>
+          <a:fillRef idx="3">
+            <a:schemeClr val="accent1"/>
+          </a:fillRef>
+          <a:effectRef idx="2">
+            <a:schemeClr val="accent1"/>
+          </a:effectRef>
+          <a:fontRef idx="minor">
+            <a:schemeClr val="lt1"/>
+          </a:fontRef>
+        </p:style>
+        <p:txBody>
+          <a:bodyPr rtlCol="0" anchor="ctr"/>
+          <a:lstStyle/>
+          <a:p>
+            <a:pPr algn="ctr"/>
+          </a:p>
+        </p:txBody>
+      </p:sp>
+      <p:sp>
+        <p:nvSpPr>
+          <p:cNvPr id="29" name="TextBox 28"/>
+          <p:cNvSpPr txBox="1"/>
+          <p:nvPr/>
+        </p:nvSpPr>
+        <p:spPr>
+          <a:xfrm>
+            <a:off x="6583680" y="3364992"/>
+            <a:ext cx="4114800" cy="457200"/>
+          </a:xfrm>
+          <a:prstGeom prst="rect">
+            <a:avLst/>
+          </a:prstGeom>
+          <a:noFill/>
+        </p:spPr>
+        <p:txBody>
+          <a:bodyPr wrap="square">
+            <a:spAutoFit/>
+          </a:bodyPr>
+          <a:lstStyle/>
+          <a:p>
+            <a:pPr algn="ctr">
+              <a:defRPr sz="1200" b="1">
+                <a:solidFill>
+                  <a:srgbClr val="1A7F37"/>
+                </a:solidFill>
+              </a:defRPr>
+            </a:pPr>
+            <a:r>
+              <a:t>mova_auth  →  todos los módulos M</a:t>
+            </a:r>
+          </a:p>
+        </p:txBody>
+      </p:sp>
+      <p:sp>
+        <p:nvSpPr>
+          <p:cNvPr id="30" name="Rounded Rectangle 29"/>
+          <p:cNvSpPr/>
+          <p:nvPr/>
+        </p:nvSpPr>
+        <p:spPr>
+          <a:xfrm>
+            <a:off x="502920" y="4251960"/>
+            <a:ext cx="11155680" cy="1051560"/>
+          </a:xfrm>
+          <a:prstGeom prst="roundRect">
+            <a:avLst/>
+          </a:prstGeom>
+          <a:solidFill>
+            <a:srgbClr val="FFF8C5"/>
+          </a:solidFill>
+          <a:ln>
+            <a:solidFill>
+              <a:srgbClr val="4A7A80"/>
+            </a:solidFill>
+          </a:ln>
+        </p:spPr>
+        <p:style>
+          <a:lnRef idx="1">
+            <a:schemeClr val="accent1"/>
+          </a:lnRef>
+          <a:fillRef idx="3">
+            <a:schemeClr val="accent1"/>
+          </a:fillRef>
+          <a:effectRef idx="2">
+            <a:schemeClr val="accent1"/>
+          </a:effectRef>
+          <a:fontRef idx="minor">
+            <a:schemeClr val="lt1"/>
+          </a:fontRef>
+        </p:style>
+        <p:txBody>
+          <a:bodyPr rtlCol="0" anchor="ctr"/>
+          <a:lstStyle/>
+          <a:p>
+            <a:pPr algn="ctr"/>
+          </a:p>
+        </p:txBody>
+      </p:sp>
+      <p:sp>
+        <p:nvSpPr>
+          <p:cNvPr id="31" name="TextBox 30"/>
+          <p:cNvSpPr txBox="1"/>
+          <p:nvPr/>
+        </p:nvSpPr>
+        <p:spPr>
+          <a:xfrm>
+            <a:off x="685800" y="4407408"/>
+            <a:ext cx="10789920" cy="777240"/>
+          </a:xfrm>
+          <a:prstGeom prst="rect">
+            <a:avLst/>
+          </a:prstGeom>
+          <a:noFill/>
+        </p:spPr>
+        <p:txBody>
+          <a:bodyPr wrap="square">
+            <a:spAutoFit/>
+          </a:bodyPr>
+          <a:lstStyle/>
+          <a:p>
+            <a:pPr algn="l">
+              <a:defRPr sz="1400" b="1">
+                <a:solidFill>
+                  <a:srgbClr val="2A4A4E"/>
+                </a:solidFill>
+              </a:defRPr>
+            </a:pPr>
+            <a:r>
+              <a:t>Hallazgo Día 1: ningún módulo revisado usa solo mova_auth.</a:t>
             </a:r>
             <a:br/>
             <a:r>
-              <a:t>gamkof · gestion/eerr · js · multimedia · mova/ · mova_auth/</a:t>
-            </a:r>
-            <a:br/>
-            <a:r>
-              <a:t>operaciones · rrhh · skill</a:t>
-            </a:r>
-            <a:br/>
-            <a:br/>
-            <a:r>
-              <a:t>mova/ → agencia · brief · cotizador · cuentas · doc · erp · estudios</a:t>
-            </a:r>
-            <a:br/>
-            <a:r>
-              <a:t>facturas · forecast · negocios · oc · operacion · restringido · seo</a:t>
-            </a:r>
-            <a:br/>
-            <a:r>
-              <a:t>strack · suscripciones · versiones_anteriores</a:t>
-            </a:r>
-            <a:br/>
-            <a:br/>
-            <a:r>
-              <a:t>mova_auth/ → auth.php · config.php · google_login.php · login.php</a:t>
-            </a:r>
-            <a:br/>
-            <a:r>
-              <a:t>logout.php · panel.php · setup.sql</a:t>
-            </a:r>
-          </a:p>
-        </p:txBody>
-      </p:sp>
-      <p:sp>
-        <p:nvSpPr>
-          <p:cNvPr id="6" name="TextBox 5"/>
-          <p:cNvSpPr txBox="1"/>
-          <p:nvPr/>
-        </p:nvSpPr>
-        <p:spPr>
-          <a:xfrm>
-            <a:off x="685800" y="5486400"/>
-            <a:ext cx="10515600" cy="411480"/>
-          </a:xfrm>
-          <a:prstGeom prst="rect">
-            <a:avLst/>
-          </a:prstGeom>
-          <a:noFill/>
-        </p:spPr>
-        <p:txBody>
-          <a:bodyPr wrap="square">
-            <a:spAutoFit/>
-          </a:bodyPr>
-          <a:lstStyle/>
-          <a:p>
-            <a:pPr algn="l">
-              <a:defRPr sz="1400" b="1">
-                <a:solidFill>
-                  <a:srgbClr val="4A7A80"/>
-                </a:solidFill>
-              </a:defRPr>
-            </a:pPr>
-            <a:r>
-              <a:t>No hay MAESTRO/INGRESOS/EGRESOS en raíz — ERP bajo mova/erp/</a:t>
+              <a:t>Eso confirma que el login está repartido y hay que unificarlo en los días 2–7.</a:t>
+            </a:r>
+          </a:p>
+        </p:txBody>
+      </p:sp>
+      <p:sp>
+        <p:nvSpPr>
+          <p:cNvPr id="32" name="TextBox 31"/>
+          <p:cNvSpPr txBox="1"/>
+          <p:nvPr/>
+        </p:nvSpPr>
+        <p:spPr>
+          <a:xfrm>
+            <a:off x="502920" y="5532120"/>
+            <a:ext cx="2286000" cy="274320"/>
+          </a:xfrm>
+          <a:prstGeom prst="rect">
+            <a:avLst/>
+          </a:prstGeom>
+          <a:noFill/>
+        </p:spPr>
+        <p:txBody>
+          <a:bodyPr wrap="square">
+            <a:spAutoFit/>
+          </a:bodyPr>
+          <a:lstStyle/>
+          <a:p>
+            <a:pPr algn="l">
+              <a:defRPr sz="1200" b="1">
+                <a:solidFill>
+                  <a:srgbClr val="2A4A4E"/>
+                </a:solidFill>
+              </a:defRPr>
+            </a:pPr>
+            <a:r>
+              <a:t>Lectura rápida:</a:t>
+            </a:r>
+          </a:p>
+        </p:txBody>
+      </p:sp>
+      <p:sp>
+        <p:nvSpPr>
+          <p:cNvPr id="33" name="Rounded Rectangle 32"/>
+          <p:cNvSpPr/>
+          <p:nvPr/>
+        </p:nvSpPr>
+        <p:spPr>
+          <a:xfrm>
+            <a:off x="2011680" y="5440680"/>
+            <a:ext cx="1234440" cy="384048"/>
+          </a:xfrm>
+          <a:prstGeom prst="roundRect">
+            <a:avLst/>
+          </a:prstGeom>
+          <a:solidFill>
+            <a:srgbClr val="FFFFFF"/>
+          </a:solidFill>
+          <a:ln>
+            <a:solidFill>
+              <a:srgbClr val="1A7F37"/>
+            </a:solidFill>
+          </a:ln>
+        </p:spPr>
+        <p:style>
+          <a:lnRef idx="1">
+            <a:schemeClr val="accent1"/>
+          </a:lnRef>
+          <a:fillRef idx="3">
+            <a:schemeClr val="accent1"/>
+          </a:fillRef>
+          <a:effectRef idx="2">
+            <a:schemeClr val="accent1"/>
+          </a:effectRef>
+          <a:fontRef idx="minor">
+            <a:schemeClr val="lt1"/>
+          </a:fontRef>
+        </p:style>
+        <p:txBody>
+          <a:bodyPr rtlCol="0" anchor="ctr"/>
+          <a:lstStyle/>
+          <a:p>
+            <a:pPr algn="ctr"/>
+          </a:p>
+        </p:txBody>
+      </p:sp>
+      <p:sp>
+        <p:nvSpPr>
+          <p:cNvPr id="34" name="TextBox 33"/>
+          <p:cNvSpPr txBox="1"/>
+          <p:nvPr/>
+        </p:nvSpPr>
+        <p:spPr>
+          <a:xfrm>
+            <a:off x="2011680" y="5504688"/>
+            <a:ext cx="1234440" cy="274320"/>
+          </a:xfrm>
+          <a:prstGeom prst="rect">
+            <a:avLst/>
+          </a:prstGeom>
+          <a:noFill/>
+        </p:spPr>
+        <p:txBody>
+          <a:bodyPr wrap="square">
+            <a:spAutoFit/>
+          </a:bodyPr>
+          <a:lstStyle/>
+          <a:p>
+            <a:pPr algn="ctr">
+              <a:defRPr sz="1100" b="1">
+                <a:solidFill>
+                  <a:srgbClr val="1A7F37"/>
+                </a:solidFill>
+              </a:defRPr>
+            </a:pPr>
+            <a:r>
+              <a:t>sí</a:t>
+            </a:r>
+          </a:p>
+        </p:txBody>
+      </p:sp>
+      <p:sp>
+        <p:nvSpPr>
+          <p:cNvPr id="35" name="Rounded Rectangle 34"/>
+          <p:cNvSpPr/>
+          <p:nvPr/>
+        </p:nvSpPr>
+        <p:spPr>
+          <a:xfrm>
+            <a:off x="3429000" y="5440680"/>
+            <a:ext cx="1234440" cy="384048"/>
+          </a:xfrm>
+          <a:prstGeom prst="roundRect">
+            <a:avLst/>
+          </a:prstGeom>
+          <a:solidFill>
+            <a:srgbClr val="FFFFFF"/>
+          </a:solidFill>
+          <a:ln>
+            <a:solidFill>
+              <a:srgbClr val="BF3F00"/>
+            </a:solidFill>
+          </a:ln>
+        </p:spPr>
+        <p:style>
+          <a:lnRef idx="1">
+            <a:schemeClr val="accent1"/>
+          </a:lnRef>
+          <a:fillRef idx="3">
+            <a:schemeClr val="accent1"/>
+          </a:fillRef>
+          <a:effectRef idx="2">
+            <a:schemeClr val="accent1"/>
+          </a:effectRef>
+          <a:fontRef idx="minor">
+            <a:schemeClr val="lt1"/>
+          </a:fontRef>
+        </p:style>
+        <p:txBody>
+          <a:bodyPr rtlCol="0" anchor="ctr"/>
+          <a:lstStyle/>
+          <a:p>
+            <a:pPr algn="ctr"/>
+          </a:p>
+        </p:txBody>
+      </p:sp>
+      <p:sp>
+        <p:nvSpPr>
+          <p:cNvPr id="36" name="TextBox 35"/>
+          <p:cNvSpPr txBox="1"/>
+          <p:nvPr/>
+        </p:nvSpPr>
+        <p:spPr>
+          <a:xfrm>
+            <a:off x="3429000" y="5504688"/>
+            <a:ext cx="1234440" cy="274320"/>
+          </a:xfrm>
+          <a:prstGeom prst="rect">
+            <a:avLst/>
+          </a:prstGeom>
+          <a:noFill/>
+        </p:spPr>
+        <p:txBody>
+          <a:bodyPr wrap="square">
+            <a:spAutoFit/>
+          </a:bodyPr>
+          <a:lstStyle/>
+          <a:p>
+            <a:pPr algn="ctr">
+              <a:defRPr sz="1100" b="1">
+                <a:solidFill>
+                  <a:srgbClr val="BF3F00"/>
+                </a:solidFill>
+              </a:defRPr>
+            </a:pPr>
+            <a:r>
+              <a:t>no</a:t>
+            </a:r>
+          </a:p>
+        </p:txBody>
+      </p:sp>
+      <p:sp>
+        <p:nvSpPr>
+          <p:cNvPr id="37" name="Rounded Rectangle 36"/>
+          <p:cNvSpPr/>
+          <p:nvPr/>
+        </p:nvSpPr>
+        <p:spPr>
+          <a:xfrm>
+            <a:off x="4846320" y="5440680"/>
+            <a:ext cx="1234440" cy="384048"/>
+          </a:xfrm>
+          <a:prstGeom prst="roundRect">
+            <a:avLst/>
+          </a:prstGeom>
+          <a:solidFill>
+            <a:srgbClr val="FFFFFF"/>
+          </a:solidFill>
+          <a:ln>
+            <a:solidFill>
+              <a:srgbClr val="BF3F00"/>
+            </a:solidFill>
+          </a:ln>
+        </p:spPr>
+        <p:style>
+          <a:lnRef idx="1">
+            <a:schemeClr val="accent1"/>
+          </a:lnRef>
+          <a:fillRef idx="3">
+            <a:schemeClr val="accent1"/>
+          </a:fillRef>
+          <a:effectRef idx="2">
+            <a:schemeClr val="accent1"/>
+          </a:effectRef>
+          <a:fontRef idx="minor">
+            <a:schemeClr val="lt1"/>
+          </a:fontRef>
+        </p:style>
+        <p:txBody>
+          <a:bodyPr rtlCol="0" anchor="ctr"/>
+          <a:lstStyle/>
+          <a:p>
+            <a:pPr algn="ctr"/>
+          </a:p>
+        </p:txBody>
+      </p:sp>
+      <p:sp>
+        <p:nvSpPr>
+          <p:cNvPr id="38" name="TextBox 37"/>
+          <p:cNvSpPr txBox="1"/>
+          <p:nvPr/>
+        </p:nvSpPr>
+        <p:spPr>
+          <a:xfrm>
+            <a:off x="4846320" y="5504688"/>
+            <a:ext cx="1234440" cy="274320"/>
+          </a:xfrm>
+          <a:prstGeom prst="rect">
+            <a:avLst/>
+          </a:prstGeom>
+          <a:noFill/>
+        </p:spPr>
+        <p:txBody>
+          <a:bodyPr wrap="square">
+            <a:spAutoFit/>
+          </a:bodyPr>
+          <a:lstStyle/>
+          <a:p>
+            <a:pPr algn="ctr">
+              <a:defRPr sz="1100" b="1">
+                <a:solidFill>
+                  <a:srgbClr val="BF3F00"/>
+                </a:solidFill>
+              </a:defRPr>
+            </a:pPr>
+            <a:r>
+              <a:t>parcial</a:t>
+            </a:r>
+          </a:p>
+        </p:txBody>
+      </p:sp>
+      <p:sp>
+        <p:nvSpPr>
+          <p:cNvPr id="39" name="Rounded Rectangle 38"/>
+          <p:cNvSpPr/>
+          <p:nvPr/>
+        </p:nvSpPr>
+        <p:spPr>
+          <a:xfrm>
+            <a:off x="6263640" y="5440680"/>
+            <a:ext cx="1234440" cy="384048"/>
+          </a:xfrm>
+          <a:prstGeom prst="roundRect">
+            <a:avLst/>
+          </a:prstGeom>
+          <a:solidFill>
+            <a:srgbClr val="FFFFFF"/>
+          </a:solidFill>
+          <a:ln>
+            <a:solidFill>
+              <a:srgbClr val="656D76"/>
+            </a:solidFill>
+          </a:ln>
+        </p:spPr>
+        <p:style>
+          <a:lnRef idx="1">
+            <a:schemeClr val="accent1"/>
+          </a:lnRef>
+          <a:fillRef idx="3">
+            <a:schemeClr val="accent1"/>
+          </a:fillRef>
+          <a:effectRef idx="2">
+            <a:schemeClr val="accent1"/>
+          </a:effectRef>
+          <a:fontRef idx="minor">
+            <a:schemeClr val="lt1"/>
+          </a:fontRef>
+        </p:style>
+        <p:txBody>
+          <a:bodyPr rtlCol="0" anchor="ctr"/>
+          <a:lstStyle/>
+          <a:p>
+            <a:pPr algn="ctr"/>
+          </a:p>
+        </p:txBody>
+      </p:sp>
+      <p:sp>
+        <p:nvSpPr>
+          <p:cNvPr id="40" name="TextBox 39"/>
+          <p:cNvSpPr txBox="1"/>
+          <p:nvPr/>
+        </p:nvSpPr>
+        <p:spPr>
+          <a:xfrm>
+            <a:off x="6263640" y="5504688"/>
+            <a:ext cx="1234440" cy="274320"/>
+          </a:xfrm>
+          <a:prstGeom prst="rect">
+            <a:avLst/>
+          </a:prstGeom>
+          <a:noFill/>
+        </p:spPr>
+        <p:txBody>
+          <a:bodyPr wrap="square">
+            <a:spAutoFit/>
+          </a:bodyPr>
+          <a:lstStyle/>
+          <a:p>
+            <a:pPr algn="ctr">
+              <a:defRPr sz="1100" b="1">
+                <a:solidFill>
+                  <a:srgbClr val="656D76"/>
+                </a:solidFill>
+              </a:defRPr>
+            </a:pPr>
+            <a:r>
+              <a:t>pendiente</a:t>
+            </a:r>
+          </a:p>
+        </p:txBody>
+      </p:sp>
+      <p:sp>
+        <p:nvSpPr>
+          <p:cNvPr id="41" name="Rounded Rectangle 40"/>
+          <p:cNvSpPr/>
+          <p:nvPr/>
+        </p:nvSpPr>
+        <p:spPr>
+          <a:xfrm>
+            <a:off x="7680960" y="5440680"/>
+            <a:ext cx="1234440" cy="384048"/>
+          </a:xfrm>
+          <a:prstGeom prst="roundRect">
+            <a:avLst/>
+          </a:prstGeom>
+          <a:solidFill>
+            <a:srgbClr val="FFFFFF"/>
+          </a:solidFill>
+          <a:ln>
+            <a:solidFill>
+              <a:srgbClr val="656D76"/>
+            </a:solidFill>
+          </a:ln>
+        </p:spPr>
+        <p:style>
+          <a:lnRef idx="1">
+            <a:schemeClr val="accent1"/>
+          </a:lnRef>
+          <a:fillRef idx="3">
+            <a:schemeClr val="accent1"/>
+          </a:fillRef>
+          <a:effectRef idx="2">
+            <a:schemeClr val="accent1"/>
+          </a:effectRef>
+          <a:fontRef idx="minor">
+            <a:schemeClr val="lt1"/>
+          </a:fontRef>
+        </p:style>
+        <p:txBody>
+          <a:bodyPr rtlCol="0" anchor="ctr"/>
+          <a:lstStyle/>
+          <a:p>
+            <a:pPr algn="ctr"/>
+          </a:p>
+        </p:txBody>
+      </p:sp>
+      <p:sp>
+        <p:nvSpPr>
+          <p:cNvPr id="42" name="TextBox 41"/>
+          <p:cNvSpPr txBox="1"/>
+          <p:nvPr/>
+        </p:nvSpPr>
+        <p:spPr>
+          <a:xfrm>
+            <a:off x="7680960" y="5504688"/>
+            <a:ext cx="1234440" cy="274320"/>
+          </a:xfrm>
+          <a:prstGeom prst="rect">
+            <a:avLst/>
+          </a:prstGeom>
+          <a:noFill/>
+        </p:spPr>
+        <p:txBody>
+          <a:bodyPr wrap="square">
+            <a:spAutoFit/>
+          </a:bodyPr>
+          <a:lstStyle/>
+          <a:p>
+            <a:pPr algn="ctr">
+              <a:defRPr sz="1100" b="1">
+                <a:solidFill>
+                  <a:srgbClr val="656D76"/>
+                </a:solidFill>
+              </a:defRPr>
+            </a:pPr>
+            <a:r>
+              <a:t>n/a</a:t>
             </a:r>
           </a:p>
         </p:txBody>
@@ -6062,7 +7455,7 @@
               </a:defRPr>
             </a:pPr>
             <a:r>
-              <a:t>DevTools · Local Storage</a:t>
+              <a:t>Estructura cPanel</a:t>
             </a:r>
           </a:p>
         </p:txBody>
@@ -6097,7 +7490,7 @@
               </a:defRPr>
             </a:pPr>
             <a:r>
-              <a:t>Sesión en https://acme-chile.cl/mova/</a:t>
+              <a:t>public_html/acme-chile.cl/</a:t>
             </a:r>
           </a:p>
         </p:txBody>
@@ -6110,29 +7503,59 @@
         </p:nvSpPr>
         <p:spPr>
           <a:xfrm>
-            <a:off x="731520" y="1371600"/>
-            <a:ext cx="10515600" cy="457200"/>
-          </a:xfrm>
-          <a:prstGeom prst="rect">
-            <a:avLst/>
-          </a:prstGeom>
-          <a:noFill/>
-        </p:spPr>
-        <p:txBody>
-          <a:bodyPr wrap="square">
-            <a:spAutoFit/>
-          </a:bodyPr>
-          <a:lstStyle/>
-          <a:p>
-            <a:pPr algn="l">
-              <a:defRPr sz="1800" b="1">
-                <a:solidFill>
-                  <a:srgbClr val="2A4A4E"/>
-                </a:solidFill>
-              </a:defRPr>
-            </a:pPr>
-            <a:r>
-              <a:t>Origen acme-chile.cl</a:t>
+            <a:off x="685800" y="1280160"/>
+            <a:ext cx="10515600" cy="4754880"/>
+          </a:xfrm>
+          <a:prstGeom prst="rect">
+            <a:avLst/>
+          </a:prstGeom>
+          <a:noFill/>
+        </p:spPr>
+        <p:txBody>
+          <a:bodyPr wrap="square">
+            <a:spAutoFit/>
+          </a:bodyPr>
+          <a:lstStyle/>
+          <a:p>
+            <a:pPr algn="l">
+              <a:defRPr sz="1500" b="0">
+                <a:solidFill>
+                  <a:srgbClr val="1F2328"/>
+                </a:solidFill>
+              </a:defRPr>
+            </a:pPr>
+            <a:r>
+              <a:t>admin · axon · axon-news · Boletin_Axon · crm · documentos</a:t>
+            </a:r>
+            <a:br/>
+            <a:r>
+              <a:t>gamkof · gestion/eerr · js · multimedia · mova/ · mova_auth/</a:t>
+            </a:r>
+            <a:br/>
+            <a:r>
+              <a:t>operaciones · rrhh · skill</a:t>
+            </a:r>
+            <a:br/>
+            <a:br/>
+            <a:r>
+              <a:t>mova/ → agencia · brief · cotizador · cuentas · doc · erp · estudios</a:t>
+            </a:r>
+            <a:br/>
+            <a:r>
+              <a:t>facturas · forecast · negocios · oc · operacion · restringido · seo</a:t>
+            </a:r>
+            <a:br/>
+            <a:r>
+              <a:t>strack · suscripciones · versiones_anteriores</a:t>
+            </a:r>
+            <a:br/>
+            <a:br/>
+            <a:r>
+              <a:t>mova_auth/ → auth.php · config.php · google_login.php · login.php</a:t>
+            </a:r>
+            <a:br/>
+            <a:r>
+              <a:t>logout.php · panel.php · setup.sql</a:t>
             </a:r>
           </a:p>
         </p:txBody>
@@ -6145,163 +7568,78 @@
         </p:nvSpPr>
         <p:spPr>
           <a:xfrm>
-            <a:off x="822960" y="1920240"/>
-            <a:ext cx="10058400" cy="411480"/>
-          </a:xfrm>
-          <a:prstGeom prst="rect">
-            <a:avLst/>
-          </a:prstGeom>
-          <a:noFill/>
-        </p:spPr>
-        <p:txBody>
-          <a:bodyPr wrap="square">
-            <a:spAutoFit/>
-          </a:bodyPr>
-          <a:lstStyle/>
-          <a:p>
-            <a:pPr algn="l">
-              <a:defRPr sz="1700" b="0">
-                <a:solidFill>
-                  <a:srgbClr val="1F2328"/>
-                </a:solidFill>
-              </a:defRPr>
-            </a:pPr>
-            <a:r>
-              <a:t>Clave: axon_chats  →  historial chats widget AXON</a:t>
-            </a:r>
-          </a:p>
-        </p:txBody>
-      </p:sp>
-      <p:sp>
-        <p:nvSpPr>
-          <p:cNvPr id="7" name="TextBox 6"/>
-          <p:cNvSpPr txBox="1"/>
-          <p:nvPr/>
-        </p:nvSpPr>
-        <p:spPr>
-          <a:xfrm>
-            <a:off x="731520" y="2651760"/>
-            <a:ext cx="10515600" cy="457200"/>
-          </a:xfrm>
-          <a:prstGeom prst="rect">
-            <a:avLst/>
-          </a:prstGeom>
-          <a:noFill/>
-        </p:spPr>
-        <p:txBody>
-          <a:bodyPr wrap="square">
-            <a:spAutoFit/>
-          </a:bodyPr>
-          <a:lstStyle/>
-          <a:p>
-            <a:pPr algn="l">
-              <a:defRPr sz="1800" b="1">
-                <a:solidFill>
-                  <a:srgbClr val="2A4A4E"/>
-                </a:solidFill>
-              </a:defRPr>
-            </a:pPr>
-            <a:r>
-              <a:t>Origen accounts.google.com (terceros)</a:t>
-            </a:r>
-          </a:p>
-        </p:txBody>
-      </p:sp>
-      <p:sp>
-        <p:nvSpPr>
-          <p:cNvPr id="8" name="TextBox 7"/>
-          <p:cNvSpPr txBox="1"/>
-          <p:nvPr/>
-        </p:nvSpPr>
-        <p:spPr>
-          <a:xfrm>
-            <a:off x="822960" y="3200400"/>
-            <a:ext cx="10058400" cy="411480"/>
-          </a:xfrm>
-          <a:prstGeom prst="rect">
-            <a:avLst/>
-          </a:prstGeom>
-          <a:noFill/>
-        </p:spPr>
-        <p:txBody>
-          <a:bodyPr wrap="square">
-            <a:spAutoFit/>
-          </a:bodyPr>
-          <a:lstStyle/>
-          <a:p>
-            <a:pPr algn="l">
-              <a:defRPr sz="1700" b="0">
-                <a:solidFill>
-                  <a:srgbClr val="1F2328"/>
-                </a:solidFill>
-              </a:defRPr>
-            </a:pPr>
-            <a:r>
-              <a:t>Sesión Google OAuth — fuera del top-level site</a:t>
-            </a:r>
-          </a:p>
-        </p:txBody>
-      </p:sp>
-      <p:sp>
-        <p:nvSpPr>
-          <p:cNvPr id="9" name="TextBox 8"/>
-          <p:cNvSpPr txBox="1"/>
-          <p:nvPr/>
-        </p:nvSpPr>
-        <p:spPr>
-          <a:xfrm>
-            <a:off x="731520" y="3931920"/>
-            <a:ext cx="10515600" cy="822960"/>
-          </a:xfrm>
-          <a:prstGeom prst="rect">
-            <a:avLst/>
-          </a:prstGeom>
-          <a:noFill/>
-        </p:spPr>
-        <p:txBody>
-          <a:bodyPr wrap="square">
-            <a:spAutoFit/>
-          </a:bodyPr>
-          <a:lstStyle/>
-          <a:p>
-            <a:pPr algn="l">
-              <a:defRPr sz="1600" b="0">
-                <a:solidFill>
-                  <a:srgbClr val="1F2328"/>
-                </a:solidFill>
-              </a:defRPr>
-            </a:pPr>
-            <a:r>
-              <a:t>No se detectó clave jwt / token / access_token en acme-chile.cl.</a:t>
-            </a:r>
-            <a:br/>
-            <a:r>
-              <a:t>Sesión principal: Google OAuth + cookies.</a:t>
-            </a:r>
-          </a:p>
-        </p:txBody>
-      </p:sp>
-      <p:sp>
-        <p:nvSpPr>
-          <p:cNvPr id="10" name="Rounded Rectangle 9"/>
+            <a:off x="685800" y="5486400"/>
+            <a:ext cx="10515600" cy="411480"/>
+          </a:xfrm>
+          <a:prstGeom prst="rect">
+            <a:avLst/>
+          </a:prstGeom>
+          <a:noFill/>
+        </p:spPr>
+        <p:txBody>
+          <a:bodyPr wrap="square">
+            <a:spAutoFit/>
+          </a:bodyPr>
+          <a:lstStyle/>
+          <a:p>
+            <a:pPr algn="l">
+              <a:defRPr sz="1400" b="1">
+                <a:solidFill>
+                  <a:srgbClr val="4A7A80"/>
+                </a:solidFill>
+              </a:defRPr>
+            </a:pPr>
+            <a:r>
+              <a:t>No hay MAESTRO/INGRESOS/EGRESOS en raíz — ERP bajo mova/erp/</a:t>
+            </a:r>
+          </a:p>
+        </p:txBody>
+      </p:sp>
+    </p:spTree>
+  </p:cSld>
+  <p:clrMapOvr>
+    <a:masterClrMapping/>
+  </p:clrMapOvr>
+</p:sld>
+</file>
+
+<file path=ppt/slides/slide7.xml><?xml version="1.0" encoding="utf-8"?>
+<p:sld xmlns:a="http://schemas.openxmlformats.org/drawingml/2006/main" xmlns:p="http://schemas.openxmlformats.org/presentationml/2006/main" xmlns:r="http://schemas.openxmlformats.org/officeDocument/2006/relationships">
+  <p:cSld>
+    <p:bg>
+      <p:bgPr>
+        <a:solidFill>
+          <a:srgbClr val="E8F6F8"/>
+        </a:solidFill>
+        <a:effectLst/>
+      </p:bgPr>
+    </p:bg>
+    <p:spTree>
+      <p:nvGrpSpPr>
+        <p:cNvPr id="1" name=""/>
+        <p:cNvGrpSpPr/>
+        <p:nvPr/>
+      </p:nvGrpSpPr>
+      <p:grpSpPr/>
+      <p:sp>
+        <p:nvSpPr>
+          <p:cNvPr id="2" name="Rectangle 1"/>
           <p:cNvSpPr/>
           <p:nvPr/>
         </p:nvSpPr>
         <p:spPr>
           <a:xfrm>
-            <a:off x="685800" y="5029200"/>
-            <a:ext cx="10789920" cy="914400"/>
-          </a:xfrm>
-          <a:prstGeom prst="roundRect">
+            <a:off x="0" y="0"/>
+            <a:ext cx="12191695" cy="960120"/>
+          </a:xfrm>
+          <a:prstGeom prst="rect">
             <a:avLst/>
           </a:prstGeom>
           <a:solidFill>
-            <a:srgbClr val="FFF8C5"/>
+            <a:srgbClr val="4A7A80"/>
           </a:solidFill>
           <a:ln>
-            <a:solidFill>
-              <a:srgbClr val="4A7A80"/>
-            </a:solidFill>
+            <a:noFill/>
           </a:ln>
         </p:spPr>
         <p:style>
@@ -6328,6 +7666,300 @@
       </p:sp>
       <p:sp>
         <p:nvSpPr>
+          <p:cNvPr id="3" name="TextBox 2"/>
+          <p:cNvSpPr txBox="1"/>
+          <p:nvPr/>
+        </p:nvSpPr>
+        <p:spPr>
+          <a:xfrm>
+            <a:off x="502920" y="164592"/>
+            <a:ext cx="10058400" cy="457200"/>
+          </a:xfrm>
+          <a:prstGeom prst="rect">
+            <a:avLst/>
+          </a:prstGeom>
+          <a:noFill/>
+        </p:spPr>
+        <p:txBody>
+          <a:bodyPr wrap="square">
+            <a:spAutoFit/>
+          </a:bodyPr>
+          <a:lstStyle/>
+          <a:p>
+            <a:pPr algn="l">
+              <a:defRPr sz="2400" b="1">
+                <a:solidFill>
+                  <a:srgbClr val="FFFFFF"/>
+                </a:solidFill>
+              </a:defRPr>
+            </a:pPr>
+            <a:r>
+              <a:t>DevTools · Local Storage</a:t>
+            </a:r>
+          </a:p>
+        </p:txBody>
+      </p:sp>
+      <p:sp>
+        <p:nvSpPr>
+          <p:cNvPr id="4" name="TextBox 3"/>
+          <p:cNvSpPr txBox="1"/>
+          <p:nvPr/>
+        </p:nvSpPr>
+        <p:spPr>
+          <a:xfrm>
+            <a:off x="502920" y="566928"/>
+            <a:ext cx="10058400" cy="320040"/>
+          </a:xfrm>
+          <a:prstGeom prst="rect">
+            <a:avLst/>
+          </a:prstGeom>
+          <a:noFill/>
+        </p:spPr>
+        <p:txBody>
+          <a:bodyPr wrap="square">
+            <a:spAutoFit/>
+          </a:bodyPr>
+          <a:lstStyle/>
+          <a:p>
+            <a:pPr algn="l">
+              <a:defRPr sz="1300" b="0">
+                <a:solidFill>
+                  <a:srgbClr val="E8F6F8"/>
+                </a:solidFill>
+              </a:defRPr>
+            </a:pPr>
+            <a:r>
+              <a:t>Sesión en https://acme-chile.cl/mova/</a:t>
+            </a:r>
+          </a:p>
+        </p:txBody>
+      </p:sp>
+      <p:sp>
+        <p:nvSpPr>
+          <p:cNvPr id="5" name="TextBox 4"/>
+          <p:cNvSpPr txBox="1"/>
+          <p:nvPr/>
+        </p:nvSpPr>
+        <p:spPr>
+          <a:xfrm>
+            <a:off x="731520" y="1371600"/>
+            <a:ext cx="10515600" cy="457200"/>
+          </a:xfrm>
+          <a:prstGeom prst="rect">
+            <a:avLst/>
+          </a:prstGeom>
+          <a:noFill/>
+        </p:spPr>
+        <p:txBody>
+          <a:bodyPr wrap="square">
+            <a:spAutoFit/>
+          </a:bodyPr>
+          <a:lstStyle/>
+          <a:p>
+            <a:pPr algn="l">
+              <a:defRPr sz="1800" b="1">
+                <a:solidFill>
+                  <a:srgbClr val="2A4A4E"/>
+                </a:solidFill>
+              </a:defRPr>
+            </a:pPr>
+            <a:r>
+              <a:t>Origen acme-chile.cl</a:t>
+            </a:r>
+          </a:p>
+        </p:txBody>
+      </p:sp>
+      <p:sp>
+        <p:nvSpPr>
+          <p:cNvPr id="6" name="TextBox 5"/>
+          <p:cNvSpPr txBox="1"/>
+          <p:nvPr/>
+        </p:nvSpPr>
+        <p:spPr>
+          <a:xfrm>
+            <a:off x="822960" y="1920240"/>
+            <a:ext cx="10058400" cy="411480"/>
+          </a:xfrm>
+          <a:prstGeom prst="rect">
+            <a:avLst/>
+          </a:prstGeom>
+          <a:noFill/>
+        </p:spPr>
+        <p:txBody>
+          <a:bodyPr wrap="square">
+            <a:spAutoFit/>
+          </a:bodyPr>
+          <a:lstStyle/>
+          <a:p>
+            <a:pPr algn="l">
+              <a:defRPr sz="1700" b="0">
+                <a:solidFill>
+                  <a:srgbClr val="1F2328"/>
+                </a:solidFill>
+              </a:defRPr>
+            </a:pPr>
+            <a:r>
+              <a:t>Clave: axon_chats  →  historial chats widget AXON</a:t>
+            </a:r>
+          </a:p>
+        </p:txBody>
+      </p:sp>
+      <p:sp>
+        <p:nvSpPr>
+          <p:cNvPr id="7" name="TextBox 6"/>
+          <p:cNvSpPr txBox="1"/>
+          <p:nvPr/>
+        </p:nvSpPr>
+        <p:spPr>
+          <a:xfrm>
+            <a:off x="731520" y="2651760"/>
+            <a:ext cx="10515600" cy="457200"/>
+          </a:xfrm>
+          <a:prstGeom prst="rect">
+            <a:avLst/>
+          </a:prstGeom>
+          <a:noFill/>
+        </p:spPr>
+        <p:txBody>
+          <a:bodyPr wrap="square">
+            <a:spAutoFit/>
+          </a:bodyPr>
+          <a:lstStyle/>
+          <a:p>
+            <a:pPr algn="l">
+              <a:defRPr sz="1800" b="1">
+                <a:solidFill>
+                  <a:srgbClr val="2A4A4E"/>
+                </a:solidFill>
+              </a:defRPr>
+            </a:pPr>
+            <a:r>
+              <a:t>Origen accounts.google.com (terceros)</a:t>
+            </a:r>
+          </a:p>
+        </p:txBody>
+      </p:sp>
+      <p:sp>
+        <p:nvSpPr>
+          <p:cNvPr id="8" name="TextBox 7"/>
+          <p:cNvSpPr txBox="1"/>
+          <p:nvPr/>
+        </p:nvSpPr>
+        <p:spPr>
+          <a:xfrm>
+            <a:off x="822960" y="3200400"/>
+            <a:ext cx="10058400" cy="411480"/>
+          </a:xfrm>
+          <a:prstGeom prst="rect">
+            <a:avLst/>
+          </a:prstGeom>
+          <a:noFill/>
+        </p:spPr>
+        <p:txBody>
+          <a:bodyPr wrap="square">
+            <a:spAutoFit/>
+          </a:bodyPr>
+          <a:lstStyle/>
+          <a:p>
+            <a:pPr algn="l">
+              <a:defRPr sz="1700" b="0">
+                <a:solidFill>
+                  <a:srgbClr val="1F2328"/>
+                </a:solidFill>
+              </a:defRPr>
+            </a:pPr>
+            <a:r>
+              <a:t>Sesión Google OAuth — fuera del top-level site</a:t>
+            </a:r>
+          </a:p>
+        </p:txBody>
+      </p:sp>
+      <p:sp>
+        <p:nvSpPr>
+          <p:cNvPr id="9" name="TextBox 8"/>
+          <p:cNvSpPr txBox="1"/>
+          <p:nvPr/>
+        </p:nvSpPr>
+        <p:spPr>
+          <a:xfrm>
+            <a:off x="731520" y="3931920"/>
+            <a:ext cx="10515600" cy="822960"/>
+          </a:xfrm>
+          <a:prstGeom prst="rect">
+            <a:avLst/>
+          </a:prstGeom>
+          <a:noFill/>
+        </p:spPr>
+        <p:txBody>
+          <a:bodyPr wrap="square">
+            <a:spAutoFit/>
+          </a:bodyPr>
+          <a:lstStyle/>
+          <a:p>
+            <a:pPr algn="l">
+              <a:defRPr sz="1600" b="0">
+                <a:solidFill>
+                  <a:srgbClr val="1F2328"/>
+                </a:solidFill>
+              </a:defRPr>
+            </a:pPr>
+            <a:r>
+              <a:t>No se detectó clave jwt / token / access_token en acme-chile.cl.</a:t>
+            </a:r>
+            <a:br/>
+            <a:r>
+              <a:t>Sesión principal: Google OAuth + cookies.</a:t>
+            </a:r>
+          </a:p>
+        </p:txBody>
+      </p:sp>
+      <p:sp>
+        <p:nvSpPr>
+          <p:cNvPr id="10" name="Rounded Rectangle 9"/>
+          <p:cNvSpPr/>
+          <p:nvPr/>
+        </p:nvSpPr>
+        <p:spPr>
+          <a:xfrm>
+            <a:off x="685800" y="5029200"/>
+            <a:ext cx="10789920" cy="914400"/>
+          </a:xfrm>
+          <a:prstGeom prst="roundRect">
+            <a:avLst/>
+          </a:prstGeom>
+          <a:solidFill>
+            <a:srgbClr val="FFF8C5"/>
+          </a:solidFill>
+          <a:ln>
+            <a:solidFill>
+              <a:srgbClr val="4A7A80"/>
+            </a:solidFill>
+          </a:ln>
+        </p:spPr>
+        <p:style>
+          <a:lnRef idx="1">
+            <a:schemeClr val="accent1"/>
+          </a:lnRef>
+          <a:fillRef idx="3">
+            <a:schemeClr val="accent1"/>
+          </a:fillRef>
+          <a:effectRef idx="2">
+            <a:schemeClr val="accent1"/>
+          </a:effectRef>
+          <a:fontRef idx="minor">
+            <a:schemeClr val="lt1"/>
+          </a:fontRef>
+        </p:style>
+        <p:txBody>
+          <a:bodyPr rtlCol="0" anchor="ctr"/>
+          <a:lstStyle/>
+          <a:p>
+            <a:pPr algn="ctr"/>
+          </a:p>
+        </p:txBody>
+      </p:sp>
+      <p:sp>
+        <p:nvSpPr>
           <p:cNvPr id="11" name="TextBox 10"/>
           <p:cNvSpPr txBox="1"/>
           <p:nvPr/>
@@ -6369,7 +8001,7 @@
 </p:sld>
 </file>
 
-<file path=ppt/slides/slide7.xml><?xml version="1.0" encoding="utf-8"?>
+<file path=ppt/slides/slide8.xml><?xml version="1.0" encoding="utf-8"?>
 <p:sld xmlns:a="http://schemas.openxmlformats.org/drawingml/2006/main" xmlns:p="http://schemas.openxmlformats.org/presentationml/2006/main" xmlns:r="http://schemas.openxmlformats.org/officeDocument/2006/relationships">
   <p:cSld>
     <p:bg>

</xml_diff>

<commit_message>
Rediseñar slide cPanel con mapa visual de carpetas
Reemplaza el bloque de texto plano por un diagrama con raíz del sitio,
chips de módulos en raíz, carpetas destacadas mova/ y mova_auth/, ERP
resaltado en amarillo y leyenda de colores. Misma estructura en HTML/PDF.

Co-authored-by: JosefaOgalde <JosefaOgalde@users.noreply.github.com>
</commit_message>
<xml_diff>
--- a/index/clientes/mkof/MOVA-D1-Inventario-Status.pptx
+++ b/index/clientes/mkof/MOVA-D1-Inventario-Status.pptx
@@ -7490,21 +7490,846 @@
               </a:defRPr>
             </a:pPr>
             <a:r>
-              <a:t>public_html/acme-chile.cl/</a:t>
-            </a:r>
-          </a:p>
-        </p:txBody>
-      </p:sp>
-      <p:sp>
-        <p:nvSpPr>
-          <p:cNvPr id="5" name="TextBox 4"/>
-          <p:cNvSpPr txBox="1"/>
-          <p:nvPr/>
-        </p:nvSpPr>
-        <p:spPr>
-          <a:xfrm>
-            <a:off x="685800" y="1280160"/>
-            <a:ext cx="10515600" cy="4754880"/>
+              <a:t>public_html/acme-chile.cl/ — mapa visual del hosting</a:t>
+            </a:r>
+          </a:p>
+        </p:txBody>
+      </p:sp>
+      <p:sp>
+        <p:nvSpPr>
+          <p:cNvPr id="5" name="Rounded Rectangle 4"/>
+          <p:cNvSpPr/>
+          <p:nvPr/>
+        </p:nvSpPr>
+        <p:spPr>
+          <a:xfrm>
+            <a:off x="3703320" y="1170432"/>
+            <a:ext cx="4754880" cy="530352"/>
+          </a:xfrm>
+          <a:prstGeom prst="roundRect">
+            <a:avLst/>
+          </a:prstGeom>
+          <a:solidFill>
+            <a:srgbClr val="2A4A4E"/>
+          </a:solidFill>
+          <a:ln w="12700">
+            <a:solidFill>
+              <a:srgbClr val="4A7A80"/>
+            </a:solidFill>
+          </a:ln>
+        </p:spPr>
+        <p:style>
+          <a:lnRef idx="1">
+            <a:schemeClr val="accent1"/>
+          </a:lnRef>
+          <a:fillRef idx="3">
+            <a:schemeClr val="accent1"/>
+          </a:fillRef>
+          <a:effectRef idx="2">
+            <a:schemeClr val="accent1"/>
+          </a:effectRef>
+          <a:fontRef idx="minor">
+            <a:schemeClr val="lt1"/>
+          </a:fontRef>
+        </p:style>
+        <p:txBody>
+          <a:bodyPr rtlCol="0" anchor="ctr"/>
+          <a:lstStyle/>
+          <a:p>
+            <a:pPr algn="ctr"/>
+          </a:p>
+        </p:txBody>
+      </p:sp>
+      <p:sp>
+        <p:nvSpPr>
+          <p:cNvPr id="6" name="TextBox 5"/>
+          <p:cNvSpPr txBox="1"/>
+          <p:nvPr/>
+        </p:nvSpPr>
+        <p:spPr>
+          <a:xfrm>
+            <a:off x="3703320" y="1280160"/>
+            <a:ext cx="4754880" cy="320040"/>
+          </a:xfrm>
+          <a:prstGeom prst="rect">
+            <a:avLst/>
+          </a:prstGeom>
+          <a:noFill/>
+        </p:spPr>
+        <p:txBody>
+          <a:bodyPr wrap="square">
+            <a:spAutoFit/>
+          </a:bodyPr>
+          <a:lstStyle/>
+          <a:p>
+            <a:pPr algn="ctr">
+              <a:defRPr sz="1400" b="1">
+                <a:solidFill>
+                  <a:srgbClr val="FFFFFF"/>
+                </a:solidFill>
+              </a:defRPr>
+            </a:pPr>
+            <a:r>
+              <a:t>public_html / acme-chile.cl /</a:t>
+            </a:r>
+          </a:p>
+        </p:txBody>
+      </p:sp>
+      <p:cxnSp>
+        <p:nvCxnSpPr>
+          <p:cNvPr id="7" name="Connector 6"/>
+          <p:cNvCxnSpPr/>
+          <p:nvPr/>
+        </p:nvCxnSpPr>
+        <p:spPr>
+          <a:xfrm flipH="1">
+            <a:off x="3108960" y="1700784"/>
+            <a:ext cx="2971800.0" cy="292608"/>
+          </a:xfrm>
+          <a:prstGeom prst="line">
+            <a:avLst/>
+          </a:prstGeom>
+          <a:ln w="19050">
+            <a:solidFill>
+              <a:srgbClr val="4A7A80"/>
+            </a:solidFill>
+          </a:ln>
+        </p:spPr>
+        <p:style>
+          <a:lnRef idx="2">
+            <a:schemeClr val="accent1"/>
+          </a:lnRef>
+          <a:fillRef idx="0">
+            <a:schemeClr val="accent1"/>
+          </a:fillRef>
+          <a:effectRef idx="1">
+            <a:schemeClr val="accent1"/>
+          </a:effectRef>
+          <a:fontRef idx="minor">
+            <a:schemeClr val="tx1"/>
+          </a:fontRef>
+        </p:style>
+      </p:cxnSp>
+      <p:cxnSp>
+        <p:nvCxnSpPr>
+          <p:cNvPr id="8" name="Connector 7"/>
+          <p:cNvCxnSpPr/>
+          <p:nvPr/>
+        </p:nvCxnSpPr>
+        <p:spPr>
+          <a:xfrm>
+            <a:off x="6080760.0" y="1700784"/>
+            <a:ext cx="2971800.0" cy="292608"/>
+          </a:xfrm>
+          <a:prstGeom prst="line">
+            <a:avLst/>
+          </a:prstGeom>
+          <a:ln w="19050">
+            <a:solidFill>
+              <a:srgbClr val="4A7A80"/>
+            </a:solidFill>
+          </a:ln>
+        </p:spPr>
+        <p:style>
+          <a:lnRef idx="2">
+            <a:schemeClr val="accent1"/>
+          </a:lnRef>
+          <a:fillRef idx="0">
+            <a:schemeClr val="accent1"/>
+          </a:fillRef>
+          <a:effectRef idx="1">
+            <a:schemeClr val="accent1"/>
+          </a:effectRef>
+          <a:fontRef idx="minor">
+            <a:schemeClr val="tx1"/>
+          </a:fontRef>
+        </p:style>
+      </p:cxnSp>
+      <p:cxnSp>
+        <p:nvCxnSpPr>
+          <p:cNvPr id="9" name="Connector 8"/>
+          <p:cNvCxnSpPr/>
+          <p:nvPr/>
+        </p:nvCxnSpPr>
+        <p:spPr>
+          <a:xfrm>
+            <a:off x="6080760.0" y="1700784"/>
+            <a:ext cx="0.0" cy="173735"/>
+          </a:xfrm>
+          <a:prstGeom prst="line">
+            <a:avLst/>
+          </a:prstGeom>
+          <a:ln w="19050">
+            <a:solidFill>
+              <a:srgbClr val="4A7A80"/>
+            </a:solidFill>
+          </a:ln>
+        </p:spPr>
+        <p:style>
+          <a:lnRef idx="2">
+            <a:schemeClr val="accent1"/>
+          </a:lnRef>
+          <a:fillRef idx="0">
+            <a:schemeClr val="accent1"/>
+          </a:fillRef>
+          <a:effectRef idx="1">
+            <a:schemeClr val="accent1"/>
+          </a:effectRef>
+          <a:fontRef idx="minor">
+            <a:schemeClr val="tx1"/>
+          </a:fontRef>
+        </p:style>
+      </p:cxnSp>
+      <p:sp>
+        <p:nvSpPr>
+          <p:cNvPr id="10" name="Rounded Rectangle 9"/>
+          <p:cNvSpPr/>
+          <p:nvPr/>
+        </p:nvSpPr>
+        <p:spPr>
+          <a:xfrm>
+            <a:off x="502920" y="1874519"/>
+            <a:ext cx="1051560" cy="310896"/>
+          </a:xfrm>
+          <a:prstGeom prst="roundRect">
+            <a:avLst/>
+          </a:prstGeom>
+          <a:solidFill>
+            <a:srgbClr val="F0F4F5"/>
+          </a:solidFill>
+          <a:ln w="12700">
+            <a:solidFill>
+              <a:srgbClr val="656D76"/>
+            </a:solidFill>
+          </a:ln>
+        </p:spPr>
+        <p:style>
+          <a:lnRef idx="1">
+            <a:schemeClr val="accent1"/>
+          </a:lnRef>
+          <a:fillRef idx="3">
+            <a:schemeClr val="accent1"/>
+          </a:fillRef>
+          <a:effectRef idx="2">
+            <a:schemeClr val="accent1"/>
+          </a:effectRef>
+          <a:fontRef idx="minor">
+            <a:schemeClr val="lt1"/>
+          </a:fontRef>
+        </p:style>
+        <p:txBody>
+          <a:bodyPr rtlCol="0" anchor="ctr"/>
+          <a:lstStyle/>
+          <a:p>
+            <a:pPr algn="ctr"/>
+          </a:p>
+        </p:txBody>
+      </p:sp>
+      <p:sp>
+        <p:nvSpPr>
+          <p:cNvPr id="11" name="TextBox 10"/>
+          <p:cNvSpPr txBox="1"/>
+          <p:nvPr/>
+        </p:nvSpPr>
+        <p:spPr>
+          <a:xfrm>
+            <a:off x="502920" y="1920239"/>
+            <a:ext cx="1051560" cy="237744"/>
+          </a:xfrm>
+          <a:prstGeom prst="rect">
+            <a:avLst/>
+          </a:prstGeom>
+          <a:noFill/>
+        </p:spPr>
+        <p:txBody>
+          <a:bodyPr wrap="square">
+            <a:spAutoFit/>
+          </a:bodyPr>
+          <a:lstStyle/>
+          <a:p>
+            <a:pPr algn="ctr">
+              <a:defRPr sz="800" b="0">
+                <a:solidFill>
+                  <a:srgbClr val="656D76"/>
+                </a:solidFill>
+              </a:defRPr>
+            </a:pPr>
+            <a:r>
+              <a:t>admin</a:t>
+            </a:r>
+          </a:p>
+        </p:txBody>
+      </p:sp>
+      <p:sp>
+        <p:nvSpPr>
+          <p:cNvPr id="12" name="Rounded Rectangle 11"/>
+          <p:cNvSpPr/>
+          <p:nvPr/>
+        </p:nvSpPr>
+        <p:spPr>
+          <a:xfrm>
+            <a:off x="1618488" y="1874519"/>
+            <a:ext cx="1051560" cy="310896"/>
+          </a:xfrm>
+          <a:prstGeom prst="roundRect">
+            <a:avLst/>
+          </a:prstGeom>
+          <a:solidFill>
+            <a:srgbClr val="F0F4F5"/>
+          </a:solidFill>
+          <a:ln w="12700">
+            <a:solidFill>
+              <a:srgbClr val="656D76"/>
+            </a:solidFill>
+          </a:ln>
+        </p:spPr>
+        <p:style>
+          <a:lnRef idx="1">
+            <a:schemeClr val="accent1"/>
+          </a:lnRef>
+          <a:fillRef idx="3">
+            <a:schemeClr val="accent1"/>
+          </a:fillRef>
+          <a:effectRef idx="2">
+            <a:schemeClr val="accent1"/>
+          </a:effectRef>
+          <a:fontRef idx="minor">
+            <a:schemeClr val="lt1"/>
+          </a:fontRef>
+        </p:style>
+        <p:txBody>
+          <a:bodyPr rtlCol="0" anchor="ctr"/>
+          <a:lstStyle/>
+          <a:p>
+            <a:pPr algn="ctr"/>
+          </a:p>
+        </p:txBody>
+      </p:sp>
+      <p:sp>
+        <p:nvSpPr>
+          <p:cNvPr id="13" name="TextBox 12"/>
+          <p:cNvSpPr txBox="1"/>
+          <p:nvPr/>
+        </p:nvSpPr>
+        <p:spPr>
+          <a:xfrm>
+            <a:off x="1618488" y="1920239"/>
+            <a:ext cx="1051560" cy="237744"/>
+          </a:xfrm>
+          <a:prstGeom prst="rect">
+            <a:avLst/>
+          </a:prstGeom>
+          <a:noFill/>
+        </p:spPr>
+        <p:txBody>
+          <a:bodyPr wrap="square">
+            <a:spAutoFit/>
+          </a:bodyPr>
+          <a:lstStyle/>
+          <a:p>
+            <a:pPr algn="ctr">
+              <a:defRPr sz="800" b="0">
+                <a:solidFill>
+                  <a:srgbClr val="656D76"/>
+                </a:solidFill>
+              </a:defRPr>
+            </a:pPr>
+            <a:r>
+              <a:t>axon</a:t>
+            </a:r>
+          </a:p>
+        </p:txBody>
+      </p:sp>
+      <p:sp>
+        <p:nvSpPr>
+          <p:cNvPr id="14" name="Rounded Rectangle 13"/>
+          <p:cNvSpPr/>
+          <p:nvPr/>
+        </p:nvSpPr>
+        <p:spPr>
+          <a:xfrm>
+            <a:off x="2734056" y="1874519"/>
+            <a:ext cx="1051560" cy="310896"/>
+          </a:xfrm>
+          <a:prstGeom prst="roundRect">
+            <a:avLst/>
+          </a:prstGeom>
+          <a:solidFill>
+            <a:srgbClr val="F0F4F5"/>
+          </a:solidFill>
+          <a:ln w="12700">
+            <a:solidFill>
+              <a:srgbClr val="656D76"/>
+            </a:solidFill>
+          </a:ln>
+        </p:spPr>
+        <p:style>
+          <a:lnRef idx="1">
+            <a:schemeClr val="accent1"/>
+          </a:lnRef>
+          <a:fillRef idx="3">
+            <a:schemeClr val="accent1"/>
+          </a:fillRef>
+          <a:effectRef idx="2">
+            <a:schemeClr val="accent1"/>
+          </a:effectRef>
+          <a:fontRef idx="minor">
+            <a:schemeClr val="lt1"/>
+          </a:fontRef>
+        </p:style>
+        <p:txBody>
+          <a:bodyPr rtlCol="0" anchor="ctr"/>
+          <a:lstStyle/>
+          <a:p>
+            <a:pPr algn="ctr"/>
+          </a:p>
+        </p:txBody>
+      </p:sp>
+      <p:sp>
+        <p:nvSpPr>
+          <p:cNvPr id="15" name="TextBox 14"/>
+          <p:cNvSpPr txBox="1"/>
+          <p:nvPr/>
+        </p:nvSpPr>
+        <p:spPr>
+          <a:xfrm>
+            <a:off x="2734056" y="1920239"/>
+            <a:ext cx="1051560" cy="237744"/>
+          </a:xfrm>
+          <a:prstGeom prst="rect">
+            <a:avLst/>
+          </a:prstGeom>
+          <a:noFill/>
+        </p:spPr>
+        <p:txBody>
+          <a:bodyPr wrap="square">
+            <a:spAutoFit/>
+          </a:bodyPr>
+          <a:lstStyle/>
+          <a:p>
+            <a:pPr algn="ctr">
+              <a:defRPr sz="800" b="0">
+                <a:solidFill>
+                  <a:srgbClr val="656D76"/>
+                </a:solidFill>
+              </a:defRPr>
+            </a:pPr>
+            <a:r>
+              <a:t>documentos</a:t>
+            </a:r>
+          </a:p>
+        </p:txBody>
+      </p:sp>
+      <p:sp>
+        <p:nvSpPr>
+          <p:cNvPr id="16" name="Rounded Rectangle 15"/>
+          <p:cNvSpPr/>
+          <p:nvPr/>
+        </p:nvSpPr>
+        <p:spPr>
+          <a:xfrm>
+            <a:off x="3849624" y="1874519"/>
+            <a:ext cx="1051560" cy="310896"/>
+          </a:xfrm>
+          <a:prstGeom prst="roundRect">
+            <a:avLst/>
+          </a:prstGeom>
+          <a:solidFill>
+            <a:srgbClr val="F0F4F5"/>
+          </a:solidFill>
+          <a:ln w="12700">
+            <a:solidFill>
+              <a:srgbClr val="656D76"/>
+            </a:solidFill>
+          </a:ln>
+        </p:spPr>
+        <p:style>
+          <a:lnRef idx="1">
+            <a:schemeClr val="accent1"/>
+          </a:lnRef>
+          <a:fillRef idx="3">
+            <a:schemeClr val="accent1"/>
+          </a:fillRef>
+          <a:effectRef idx="2">
+            <a:schemeClr val="accent1"/>
+          </a:effectRef>
+          <a:fontRef idx="minor">
+            <a:schemeClr val="lt1"/>
+          </a:fontRef>
+        </p:style>
+        <p:txBody>
+          <a:bodyPr rtlCol="0" anchor="ctr"/>
+          <a:lstStyle/>
+          <a:p>
+            <a:pPr algn="ctr"/>
+          </a:p>
+        </p:txBody>
+      </p:sp>
+      <p:sp>
+        <p:nvSpPr>
+          <p:cNvPr id="17" name="TextBox 16"/>
+          <p:cNvSpPr txBox="1"/>
+          <p:nvPr/>
+        </p:nvSpPr>
+        <p:spPr>
+          <a:xfrm>
+            <a:off x="3849624" y="1920239"/>
+            <a:ext cx="1051560" cy="237744"/>
+          </a:xfrm>
+          <a:prstGeom prst="rect">
+            <a:avLst/>
+          </a:prstGeom>
+          <a:noFill/>
+        </p:spPr>
+        <p:txBody>
+          <a:bodyPr wrap="square">
+            <a:spAutoFit/>
+          </a:bodyPr>
+          <a:lstStyle/>
+          <a:p>
+            <a:pPr algn="ctr">
+              <a:defRPr sz="800" b="0">
+                <a:solidFill>
+                  <a:srgbClr val="656D76"/>
+                </a:solidFill>
+              </a:defRPr>
+            </a:pPr>
+            <a:r>
+              <a:t>rrhh</a:t>
+            </a:r>
+          </a:p>
+        </p:txBody>
+      </p:sp>
+      <p:sp>
+        <p:nvSpPr>
+          <p:cNvPr id="18" name="Rounded Rectangle 17"/>
+          <p:cNvSpPr/>
+          <p:nvPr/>
+        </p:nvSpPr>
+        <p:spPr>
+          <a:xfrm>
+            <a:off x="4965192" y="1874519"/>
+            <a:ext cx="1051560" cy="310896"/>
+          </a:xfrm>
+          <a:prstGeom prst="roundRect">
+            <a:avLst/>
+          </a:prstGeom>
+          <a:solidFill>
+            <a:srgbClr val="F0F4F5"/>
+          </a:solidFill>
+          <a:ln w="12700">
+            <a:solidFill>
+              <a:srgbClr val="656D76"/>
+            </a:solidFill>
+          </a:ln>
+        </p:spPr>
+        <p:style>
+          <a:lnRef idx="1">
+            <a:schemeClr val="accent1"/>
+          </a:lnRef>
+          <a:fillRef idx="3">
+            <a:schemeClr val="accent1"/>
+          </a:fillRef>
+          <a:effectRef idx="2">
+            <a:schemeClr val="accent1"/>
+          </a:effectRef>
+          <a:fontRef idx="minor">
+            <a:schemeClr val="lt1"/>
+          </a:fontRef>
+        </p:style>
+        <p:txBody>
+          <a:bodyPr rtlCol="0" anchor="ctr"/>
+          <a:lstStyle/>
+          <a:p>
+            <a:pPr algn="ctr"/>
+          </a:p>
+        </p:txBody>
+      </p:sp>
+      <p:sp>
+        <p:nvSpPr>
+          <p:cNvPr id="19" name="TextBox 18"/>
+          <p:cNvSpPr txBox="1"/>
+          <p:nvPr/>
+        </p:nvSpPr>
+        <p:spPr>
+          <a:xfrm>
+            <a:off x="4965192" y="1920239"/>
+            <a:ext cx="1051560" cy="237744"/>
+          </a:xfrm>
+          <a:prstGeom prst="rect">
+            <a:avLst/>
+          </a:prstGeom>
+          <a:noFill/>
+        </p:spPr>
+        <p:txBody>
+          <a:bodyPr wrap="square">
+            <a:spAutoFit/>
+          </a:bodyPr>
+          <a:lstStyle/>
+          <a:p>
+            <a:pPr algn="ctr">
+              <a:defRPr sz="800" b="0">
+                <a:solidFill>
+                  <a:srgbClr val="656D76"/>
+                </a:solidFill>
+              </a:defRPr>
+            </a:pPr>
+            <a:r>
+              <a:t>crm</a:t>
+            </a:r>
+          </a:p>
+        </p:txBody>
+      </p:sp>
+      <p:sp>
+        <p:nvSpPr>
+          <p:cNvPr id="20" name="Rounded Rectangle 19"/>
+          <p:cNvSpPr/>
+          <p:nvPr/>
+        </p:nvSpPr>
+        <p:spPr>
+          <a:xfrm>
+            <a:off x="6080760" y="1874519"/>
+            <a:ext cx="1051560" cy="310896"/>
+          </a:xfrm>
+          <a:prstGeom prst="roundRect">
+            <a:avLst/>
+          </a:prstGeom>
+          <a:solidFill>
+            <a:srgbClr val="F0F4F5"/>
+          </a:solidFill>
+          <a:ln w="12700">
+            <a:solidFill>
+              <a:srgbClr val="656D76"/>
+            </a:solidFill>
+          </a:ln>
+        </p:spPr>
+        <p:style>
+          <a:lnRef idx="1">
+            <a:schemeClr val="accent1"/>
+          </a:lnRef>
+          <a:fillRef idx="3">
+            <a:schemeClr val="accent1"/>
+          </a:fillRef>
+          <a:effectRef idx="2">
+            <a:schemeClr val="accent1"/>
+          </a:effectRef>
+          <a:fontRef idx="minor">
+            <a:schemeClr val="lt1"/>
+          </a:fontRef>
+        </p:style>
+        <p:txBody>
+          <a:bodyPr rtlCol="0" anchor="ctr"/>
+          <a:lstStyle/>
+          <a:p>
+            <a:pPr algn="ctr"/>
+          </a:p>
+        </p:txBody>
+      </p:sp>
+      <p:sp>
+        <p:nvSpPr>
+          <p:cNvPr id="21" name="TextBox 20"/>
+          <p:cNvSpPr txBox="1"/>
+          <p:nvPr/>
+        </p:nvSpPr>
+        <p:spPr>
+          <a:xfrm>
+            <a:off x="6080760" y="1920239"/>
+            <a:ext cx="1051560" cy="237744"/>
+          </a:xfrm>
+          <a:prstGeom prst="rect">
+            <a:avLst/>
+          </a:prstGeom>
+          <a:noFill/>
+        </p:spPr>
+        <p:txBody>
+          <a:bodyPr wrap="square">
+            <a:spAutoFit/>
+          </a:bodyPr>
+          <a:lstStyle/>
+          <a:p>
+            <a:pPr algn="ctr">
+              <a:defRPr sz="800" b="0">
+                <a:solidFill>
+                  <a:srgbClr val="656D76"/>
+                </a:solidFill>
+              </a:defRPr>
+            </a:pPr>
+            <a:r>
+              <a:t>skill</a:t>
+            </a:r>
+          </a:p>
+        </p:txBody>
+      </p:sp>
+      <p:sp>
+        <p:nvSpPr>
+          <p:cNvPr id="22" name="Rounded Rectangle 21"/>
+          <p:cNvSpPr/>
+          <p:nvPr/>
+        </p:nvSpPr>
+        <p:spPr>
+          <a:xfrm>
+            <a:off x="7196328" y="1874519"/>
+            <a:ext cx="1051560" cy="310896"/>
+          </a:xfrm>
+          <a:prstGeom prst="roundRect">
+            <a:avLst/>
+          </a:prstGeom>
+          <a:solidFill>
+            <a:srgbClr val="F0F4F5"/>
+          </a:solidFill>
+          <a:ln w="12700">
+            <a:solidFill>
+              <a:srgbClr val="656D76"/>
+            </a:solidFill>
+          </a:ln>
+        </p:spPr>
+        <p:style>
+          <a:lnRef idx="1">
+            <a:schemeClr val="accent1"/>
+          </a:lnRef>
+          <a:fillRef idx="3">
+            <a:schemeClr val="accent1"/>
+          </a:fillRef>
+          <a:effectRef idx="2">
+            <a:schemeClr val="accent1"/>
+          </a:effectRef>
+          <a:fontRef idx="minor">
+            <a:schemeClr val="lt1"/>
+          </a:fontRef>
+        </p:style>
+        <p:txBody>
+          <a:bodyPr rtlCol="0" anchor="ctr"/>
+          <a:lstStyle/>
+          <a:p>
+            <a:pPr algn="ctr"/>
+          </a:p>
+        </p:txBody>
+      </p:sp>
+      <p:sp>
+        <p:nvSpPr>
+          <p:cNvPr id="23" name="TextBox 22"/>
+          <p:cNvSpPr txBox="1"/>
+          <p:nvPr/>
+        </p:nvSpPr>
+        <p:spPr>
+          <a:xfrm>
+            <a:off x="7196328" y="1920239"/>
+            <a:ext cx="1051560" cy="237744"/>
+          </a:xfrm>
+          <a:prstGeom prst="rect">
+            <a:avLst/>
+          </a:prstGeom>
+          <a:noFill/>
+        </p:spPr>
+        <p:txBody>
+          <a:bodyPr wrap="square">
+            <a:spAutoFit/>
+          </a:bodyPr>
+          <a:lstStyle/>
+          <a:p>
+            <a:pPr algn="ctr">
+              <a:defRPr sz="800" b="0">
+                <a:solidFill>
+                  <a:srgbClr val="656D76"/>
+                </a:solidFill>
+              </a:defRPr>
+            </a:pPr>
+            <a:r>
+              <a:t>operaciones</a:t>
+            </a:r>
+          </a:p>
+        </p:txBody>
+      </p:sp>
+      <p:sp>
+        <p:nvSpPr>
+          <p:cNvPr id="24" name="Rounded Rectangle 23"/>
+          <p:cNvSpPr/>
+          <p:nvPr/>
+        </p:nvSpPr>
+        <p:spPr>
+          <a:xfrm>
+            <a:off x="8311896" y="1874519"/>
+            <a:ext cx="1051560" cy="310896"/>
+          </a:xfrm>
+          <a:prstGeom prst="roundRect">
+            <a:avLst/>
+          </a:prstGeom>
+          <a:solidFill>
+            <a:srgbClr val="F0F4F5"/>
+          </a:solidFill>
+          <a:ln w="12700">
+            <a:solidFill>
+              <a:srgbClr val="656D76"/>
+            </a:solidFill>
+          </a:ln>
+        </p:spPr>
+        <p:style>
+          <a:lnRef idx="1">
+            <a:schemeClr val="accent1"/>
+          </a:lnRef>
+          <a:fillRef idx="3">
+            <a:schemeClr val="accent1"/>
+          </a:fillRef>
+          <a:effectRef idx="2">
+            <a:schemeClr val="accent1"/>
+          </a:effectRef>
+          <a:fontRef idx="minor">
+            <a:schemeClr val="lt1"/>
+          </a:fontRef>
+        </p:style>
+        <p:txBody>
+          <a:bodyPr rtlCol="0" anchor="ctr"/>
+          <a:lstStyle/>
+          <a:p>
+            <a:pPr algn="ctr"/>
+          </a:p>
+        </p:txBody>
+      </p:sp>
+      <p:sp>
+        <p:nvSpPr>
+          <p:cNvPr id="25" name="TextBox 24"/>
+          <p:cNvSpPr txBox="1"/>
+          <p:nvPr/>
+        </p:nvSpPr>
+        <p:spPr>
+          <a:xfrm>
+            <a:off x="8311896" y="1920239"/>
+            <a:ext cx="1051560" cy="237744"/>
+          </a:xfrm>
+          <a:prstGeom prst="rect">
+            <a:avLst/>
+          </a:prstGeom>
+          <a:noFill/>
+        </p:spPr>
+        <p:txBody>
+          <a:bodyPr wrap="square">
+            <a:spAutoFit/>
+          </a:bodyPr>
+          <a:lstStyle/>
+          <a:p>
+            <a:pPr algn="ctr">
+              <a:defRPr sz="800" b="0">
+                <a:solidFill>
+                  <a:srgbClr val="656D76"/>
+                </a:solidFill>
+              </a:defRPr>
+            </a:pPr>
+            <a:r>
+              <a:t>multimedia</a:t>
+            </a:r>
+          </a:p>
+        </p:txBody>
+      </p:sp>
+      <p:sp>
+        <p:nvSpPr>
+          <p:cNvPr id="26" name="TextBox 25"/>
+          <p:cNvSpPr txBox="1"/>
+          <p:nvPr/>
+        </p:nvSpPr>
+        <p:spPr>
+          <a:xfrm>
+            <a:off x="502920" y="2212848"/>
+            <a:ext cx="11155680" cy="228600"/>
           </a:xfrm>
           <a:prstGeom prst="rect">
             <a:avLst/>
@@ -7518,58 +8343,2032 @@
           <a:lstStyle/>
           <a:p>
             <a:pPr algn="l">
-              <a:defRPr sz="1500" b="0">
-                <a:solidFill>
-                  <a:srgbClr val="1F2328"/>
-                </a:solidFill>
-              </a:defRPr>
-            </a:pPr>
-            <a:r>
-              <a:t>admin · axon · axon-news · Boletin_Axon · crm · documentos</a:t>
+              <a:defRPr sz="900" b="0">
+                <a:solidFill>
+                  <a:srgbClr val="656D76"/>
+                </a:solidFill>
+              </a:defRPr>
+            </a:pPr>
+            <a:r>
+              <a:t>Otros módulos en la raíz del sitio</a:t>
+            </a:r>
+          </a:p>
+        </p:txBody>
+      </p:sp>
+      <p:sp>
+        <p:nvSpPr>
+          <p:cNvPr id="27" name="Rounded Rectangle 26"/>
+          <p:cNvSpPr/>
+          <p:nvPr/>
+        </p:nvSpPr>
+        <p:spPr>
+          <a:xfrm>
+            <a:off x="502920" y="2514600"/>
+            <a:ext cx="5440680" cy="3246120"/>
+          </a:xfrm>
+          <a:prstGeom prst="roundRect">
+            <a:avLst/>
+          </a:prstGeom>
+          <a:solidFill>
+            <a:srgbClr val="E8F6F8"/>
+          </a:solidFill>
+          <a:ln w="25400">
+            <a:solidFill>
+              <a:srgbClr val="4A7A80"/>
+            </a:solidFill>
+          </a:ln>
+        </p:spPr>
+        <p:style>
+          <a:lnRef idx="1">
+            <a:schemeClr val="accent1"/>
+          </a:lnRef>
+          <a:fillRef idx="3">
+            <a:schemeClr val="accent1"/>
+          </a:fillRef>
+          <a:effectRef idx="2">
+            <a:schemeClr val="accent1"/>
+          </a:effectRef>
+          <a:fontRef idx="minor">
+            <a:schemeClr val="lt1"/>
+          </a:fontRef>
+        </p:style>
+        <p:txBody>
+          <a:bodyPr rtlCol="0" anchor="ctr"/>
+          <a:lstStyle/>
+          <a:p>
+            <a:pPr algn="ctr"/>
+          </a:p>
+        </p:txBody>
+      </p:sp>
+      <p:sp>
+        <p:nvSpPr>
+          <p:cNvPr id="28" name="Rounded Rectangle 27"/>
+          <p:cNvSpPr/>
+          <p:nvPr/>
+        </p:nvSpPr>
+        <p:spPr>
+          <a:xfrm>
+            <a:off x="612648" y="2624328"/>
+            <a:ext cx="5221224" cy="438912"/>
+          </a:xfrm>
+          <a:prstGeom prst="roundRect">
+            <a:avLst/>
+          </a:prstGeom>
+          <a:solidFill>
+            <a:srgbClr val="4A7A80"/>
+          </a:solidFill>
+          <a:ln>
+            <a:noFill/>
+          </a:ln>
+        </p:spPr>
+        <p:style>
+          <a:lnRef idx="1">
+            <a:schemeClr val="accent1"/>
+          </a:lnRef>
+          <a:fillRef idx="3">
+            <a:schemeClr val="accent1"/>
+          </a:fillRef>
+          <a:effectRef idx="2">
+            <a:schemeClr val="accent1"/>
+          </a:effectRef>
+          <a:fontRef idx="minor">
+            <a:schemeClr val="lt1"/>
+          </a:fontRef>
+        </p:style>
+        <p:txBody>
+          <a:bodyPr rtlCol="0" anchor="ctr"/>
+          <a:lstStyle/>
+          <a:p>
+            <a:pPr algn="ctr"/>
+          </a:p>
+        </p:txBody>
+      </p:sp>
+      <p:sp>
+        <p:nvSpPr>
+          <p:cNvPr id="29" name="TextBox 28"/>
+          <p:cNvSpPr txBox="1"/>
+          <p:nvPr/>
+        </p:nvSpPr>
+        <p:spPr>
+          <a:xfrm>
+            <a:off x="685800" y="2679192"/>
+            <a:ext cx="5074920" cy="320040"/>
+          </a:xfrm>
+          <a:prstGeom prst="rect">
+            <a:avLst/>
+          </a:prstGeom>
+          <a:noFill/>
+        </p:spPr>
+        <p:txBody>
+          <a:bodyPr wrap="square">
+            <a:spAutoFit/>
+          </a:bodyPr>
+          <a:lstStyle/>
+          <a:p>
+            <a:pPr algn="l">
+              <a:defRPr sz="1300" b="1">
+                <a:solidFill>
+                  <a:srgbClr val="FFFFFF"/>
+                </a:solidFill>
+              </a:defRPr>
+            </a:pPr>
+            <a:r>
+              <a:t>mova/  ·  Portal y apps MOVA</a:t>
+            </a:r>
+          </a:p>
+        </p:txBody>
+      </p:sp>
+      <p:sp>
+        <p:nvSpPr>
+          <p:cNvPr id="30" name="Rounded Rectangle 29"/>
+          <p:cNvSpPr/>
+          <p:nvPr/>
+        </p:nvSpPr>
+        <p:spPr>
+          <a:xfrm>
+            <a:off x="685800" y="3227832"/>
+            <a:ext cx="960120" cy="310896"/>
+          </a:xfrm>
+          <a:prstGeom prst="roundRect">
+            <a:avLst/>
+          </a:prstGeom>
+          <a:solidFill>
+            <a:srgbClr val="FFFFFF"/>
+          </a:solidFill>
+          <a:ln w="12700">
+            <a:solidFill>
+              <a:srgbClr val="4A7A80"/>
+            </a:solidFill>
+          </a:ln>
+        </p:spPr>
+        <p:style>
+          <a:lnRef idx="1">
+            <a:schemeClr val="accent1"/>
+          </a:lnRef>
+          <a:fillRef idx="3">
+            <a:schemeClr val="accent1"/>
+          </a:fillRef>
+          <a:effectRef idx="2">
+            <a:schemeClr val="accent1"/>
+          </a:effectRef>
+          <a:fontRef idx="minor">
+            <a:schemeClr val="lt1"/>
+          </a:fontRef>
+        </p:style>
+        <p:txBody>
+          <a:bodyPr rtlCol="0" anchor="ctr"/>
+          <a:lstStyle/>
+          <a:p>
+            <a:pPr algn="ctr"/>
+          </a:p>
+        </p:txBody>
+      </p:sp>
+      <p:sp>
+        <p:nvSpPr>
+          <p:cNvPr id="31" name="TextBox 30"/>
+          <p:cNvSpPr txBox="1"/>
+          <p:nvPr/>
+        </p:nvSpPr>
+        <p:spPr>
+          <a:xfrm>
+            <a:off x="685800" y="3273552"/>
+            <a:ext cx="960120" cy="237744"/>
+          </a:xfrm>
+          <a:prstGeom prst="rect">
+            <a:avLst/>
+          </a:prstGeom>
+          <a:noFill/>
+        </p:spPr>
+        <p:txBody>
+          <a:bodyPr wrap="square">
+            <a:spAutoFit/>
+          </a:bodyPr>
+          <a:lstStyle/>
+          <a:p>
+            <a:pPr algn="ctr">
+              <a:defRPr sz="800" b="0">
+                <a:solidFill>
+                  <a:srgbClr val="2A4A4E"/>
+                </a:solidFill>
+              </a:defRPr>
+            </a:pPr>
+            <a:r>
+              <a:t>agencia</a:t>
+            </a:r>
+          </a:p>
+        </p:txBody>
+      </p:sp>
+      <p:sp>
+        <p:nvSpPr>
+          <p:cNvPr id="32" name="Rounded Rectangle 31"/>
+          <p:cNvSpPr/>
+          <p:nvPr/>
+        </p:nvSpPr>
+        <p:spPr>
+          <a:xfrm>
+            <a:off x="1709928" y="3227832"/>
+            <a:ext cx="960120" cy="310896"/>
+          </a:xfrm>
+          <a:prstGeom prst="roundRect">
+            <a:avLst/>
+          </a:prstGeom>
+          <a:solidFill>
+            <a:srgbClr val="FFFFFF"/>
+          </a:solidFill>
+          <a:ln w="12700">
+            <a:solidFill>
+              <a:srgbClr val="4A7A80"/>
+            </a:solidFill>
+          </a:ln>
+        </p:spPr>
+        <p:style>
+          <a:lnRef idx="1">
+            <a:schemeClr val="accent1"/>
+          </a:lnRef>
+          <a:fillRef idx="3">
+            <a:schemeClr val="accent1"/>
+          </a:fillRef>
+          <a:effectRef idx="2">
+            <a:schemeClr val="accent1"/>
+          </a:effectRef>
+          <a:fontRef idx="minor">
+            <a:schemeClr val="lt1"/>
+          </a:fontRef>
+        </p:style>
+        <p:txBody>
+          <a:bodyPr rtlCol="0" anchor="ctr"/>
+          <a:lstStyle/>
+          <a:p>
+            <a:pPr algn="ctr"/>
+          </a:p>
+        </p:txBody>
+      </p:sp>
+      <p:sp>
+        <p:nvSpPr>
+          <p:cNvPr id="33" name="TextBox 32"/>
+          <p:cNvSpPr txBox="1"/>
+          <p:nvPr/>
+        </p:nvSpPr>
+        <p:spPr>
+          <a:xfrm>
+            <a:off x="1709928" y="3273552"/>
+            <a:ext cx="960120" cy="237744"/>
+          </a:xfrm>
+          <a:prstGeom prst="rect">
+            <a:avLst/>
+          </a:prstGeom>
+          <a:noFill/>
+        </p:spPr>
+        <p:txBody>
+          <a:bodyPr wrap="square">
+            <a:spAutoFit/>
+          </a:bodyPr>
+          <a:lstStyle/>
+          <a:p>
+            <a:pPr algn="ctr">
+              <a:defRPr sz="800" b="0">
+                <a:solidFill>
+                  <a:srgbClr val="2A4A4E"/>
+                </a:solidFill>
+              </a:defRPr>
+            </a:pPr>
+            <a:r>
+              <a:t>brief</a:t>
+            </a:r>
+          </a:p>
+        </p:txBody>
+      </p:sp>
+      <p:sp>
+        <p:nvSpPr>
+          <p:cNvPr id="34" name="Rounded Rectangle 33"/>
+          <p:cNvSpPr/>
+          <p:nvPr/>
+        </p:nvSpPr>
+        <p:spPr>
+          <a:xfrm>
+            <a:off x="2734056" y="3227832"/>
+            <a:ext cx="960120" cy="310896"/>
+          </a:xfrm>
+          <a:prstGeom prst="roundRect">
+            <a:avLst/>
+          </a:prstGeom>
+          <a:solidFill>
+            <a:srgbClr val="FFFFFF"/>
+          </a:solidFill>
+          <a:ln w="12700">
+            <a:solidFill>
+              <a:srgbClr val="4A7A80"/>
+            </a:solidFill>
+          </a:ln>
+        </p:spPr>
+        <p:style>
+          <a:lnRef idx="1">
+            <a:schemeClr val="accent1"/>
+          </a:lnRef>
+          <a:fillRef idx="3">
+            <a:schemeClr val="accent1"/>
+          </a:fillRef>
+          <a:effectRef idx="2">
+            <a:schemeClr val="accent1"/>
+          </a:effectRef>
+          <a:fontRef idx="minor">
+            <a:schemeClr val="lt1"/>
+          </a:fontRef>
+        </p:style>
+        <p:txBody>
+          <a:bodyPr rtlCol="0" anchor="ctr"/>
+          <a:lstStyle/>
+          <a:p>
+            <a:pPr algn="ctr"/>
+          </a:p>
+        </p:txBody>
+      </p:sp>
+      <p:sp>
+        <p:nvSpPr>
+          <p:cNvPr id="35" name="TextBox 34"/>
+          <p:cNvSpPr txBox="1"/>
+          <p:nvPr/>
+        </p:nvSpPr>
+        <p:spPr>
+          <a:xfrm>
+            <a:off x="2734056" y="3273552"/>
+            <a:ext cx="960120" cy="237744"/>
+          </a:xfrm>
+          <a:prstGeom prst="rect">
+            <a:avLst/>
+          </a:prstGeom>
+          <a:noFill/>
+        </p:spPr>
+        <p:txBody>
+          <a:bodyPr wrap="square">
+            <a:spAutoFit/>
+          </a:bodyPr>
+          <a:lstStyle/>
+          <a:p>
+            <a:pPr algn="ctr">
+              <a:defRPr sz="800" b="0">
+                <a:solidFill>
+                  <a:srgbClr val="2A4A4E"/>
+                </a:solidFill>
+              </a:defRPr>
+            </a:pPr>
+            <a:r>
+              <a:t>cotizador</a:t>
+            </a:r>
+          </a:p>
+        </p:txBody>
+      </p:sp>
+      <p:sp>
+        <p:nvSpPr>
+          <p:cNvPr id="36" name="Rounded Rectangle 35"/>
+          <p:cNvSpPr/>
+          <p:nvPr/>
+        </p:nvSpPr>
+        <p:spPr>
+          <a:xfrm>
+            <a:off x="3758184" y="3227832"/>
+            <a:ext cx="960120" cy="310896"/>
+          </a:xfrm>
+          <a:prstGeom prst="roundRect">
+            <a:avLst/>
+          </a:prstGeom>
+          <a:solidFill>
+            <a:srgbClr val="FFFFFF"/>
+          </a:solidFill>
+          <a:ln w="12700">
+            <a:solidFill>
+              <a:srgbClr val="4A7A80"/>
+            </a:solidFill>
+          </a:ln>
+        </p:spPr>
+        <p:style>
+          <a:lnRef idx="1">
+            <a:schemeClr val="accent1"/>
+          </a:lnRef>
+          <a:fillRef idx="3">
+            <a:schemeClr val="accent1"/>
+          </a:fillRef>
+          <a:effectRef idx="2">
+            <a:schemeClr val="accent1"/>
+          </a:effectRef>
+          <a:fontRef idx="minor">
+            <a:schemeClr val="lt1"/>
+          </a:fontRef>
+        </p:style>
+        <p:txBody>
+          <a:bodyPr rtlCol="0" anchor="ctr"/>
+          <a:lstStyle/>
+          <a:p>
+            <a:pPr algn="ctr"/>
+          </a:p>
+        </p:txBody>
+      </p:sp>
+      <p:sp>
+        <p:nvSpPr>
+          <p:cNvPr id="37" name="TextBox 36"/>
+          <p:cNvSpPr txBox="1"/>
+          <p:nvPr/>
+        </p:nvSpPr>
+        <p:spPr>
+          <a:xfrm>
+            <a:off x="3758184" y="3273552"/>
+            <a:ext cx="960120" cy="237744"/>
+          </a:xfrm>
+          <a:prstGeom prst="rect">
+            <a:avLst/>
+          </a:prstGeom>
+          <a:noFill/>
+        </p:spPr>
+        <p:txBody>
+          <a:bodyPr wrap="square">
+            <a:spAutoFit/>
+          </a:bodyPr>
+          <a:lstStyle/>
+          <a:p>
+            <a:pPr algn="ctr">
+              <a:defRPr sz="800" b="0">
+                <a:solidFill>
+                  <a:srgbClr val="2A4A4E"/>
+                </a:solidFill>
+              </a:defRPr>
+            </a:pPr>
+            <a:r>
+              <a:t>cuentas</a:t>
+            </a:r>
+          </a:p>
+        </p:txBody>
+      </p:sp>
+      <p:sp>
+        <p:nvSpPr>
+          <p:cNvPr id="38" name="Rounded Rectangle 37"/>
+          <p:cNvSpPr/>
+          <p:nvPr/>
+        </p:nvSpPr>
+        <p:spPr>
+          <a:xfrm>
+            <a:off x="4782312" y="3227832"/>
+            <a:ext cx="960120" cy="310896"/>
+          </a:xfrm>
+          <a:prstGeom prst="roundRect">
+            <a:avLst/>
+          </a:prstGeom>
+          <a:solidFill>
+            <a:srgbClr val="FFFFFF"/>
+          </a:solidFill>
+          <a:ln w="12700">
+            <a:solidFill>
+              <a:srgbClr val="4A7A80"/>
+            </a:solidFill>
+          </a:ln>
+        </p:spPr>
+        <p:style>
+          <a:lnRef idx="1">
+            <a:schemeClr val="accent1"/>
+          </a:lnRef>
+          <a:fillRef idx="3">
+            <a:schemeClr val="accent1"/>
+          </a:fillRef>
+          <a:effectRef idx="2">
+            <a:schemeClr val="accent1"/>
+          </a:effectRef>
+          <a:fontRef idx="minor">
+            <a:schemeClr val="lt1"/>
+          </a:fontRef>
+        </p:style>
+        <p:txBody>
+          <a:bodyPr rtlCol="0" anchor="ctr"/>
+          <a:lstStyle/>
+          <a:p>
+            <a:pPr algn="ctr"/>
+          </a:p>
+        </p:txBody>
+      </p:sp>
+      <p:sp>
+        <p:nvSpPr>
+          <p:cNvPr id="39" name="TextBox 38"/>
+          <p:cNvSpPr txBox="1"/>
+          <p:nvPr/>
+        </p:nvSpPr>
+        <p:spPr>
+          <a:xfrm>
+            <a:off x="4782312" y="3273552"/>
+            <a:ext cx="960120" cy="237744"/>
+          </a:xfrm>
+          <a:prstGeom prst="rect">
+            <a:avLst/>
+          </a:prstGeom>
+          <a:noFill/>
+        </p:spPr>
+        <p:txBody>
+          <a:bodyPr wrap="square">
+            <a:spAutoFit/>
+          </a:bodyPr>
+          <a:lstStyle/>
+          <a:p>
+            <a:pPr algn="ctr">
+              <a:defRPr sz="800" b="0">
+                <a:solidFill>
+                  <a:srgbClr val="2A4A4E"/>
+                </a:solidFill>
+              </a:defRPr>
+            </a:pPr>
+            <a:r>
+              <a:t>doc</a:t>
+            </a:r>
+          </a:p>
+        </p:txBody>
+      </p:sp>
+      <p:sp>
+        <p:nvSpPr>
+          <p:cNvPr id="40" name="Rounded Rectangle 39"/>
+          <p:cNvSpPr/>
+          <p:nvPr/>
+        </p:nvSpPr>
+        <p:spPr>
+          <a:xfrm>
+            <a:off x="685800" y="3611880"/>
+            <a:ext cx="960120" cy="310896"/>
+          </a:xfrm>
+          <a:prstGeom prst="roundRect">
+            <a:avLst/>
+          </a:prstGeom>
+          <a:solidFill>
+            <a:srgbClr val="FFF8C5"/>
+          </a:solidFill>
+          <a:ln w="12700">
+            <a:solidFill>
+              <a:srgbClr val="BF3F00"/>
+            </a:solidFill>
+          </a:ln>
+        </p:spPr>
+        <p:style>
+          <a:lnRef idx="1">
+            <a:schemeClr val="accent1"/>
+          </a:lnRef>
+          <a:fillRef idx="3">
+            <a:schemeClr val="accent1"/>
+          </a:fillRef>
+          <a:effectRef idx="2">
+            <a:schemeClr val="accent1"/>
+          </a:effectRef>
+          <a:fontRef idx="minor">
+            <a:schemeClr val="lt1"/>
+          </a:fontRef>
+        </p:style>
+        <p:txBody>
+          <a:bodyPr rtlCol="0" anchor="ctr"/>
+          <a:lstStyle/>
+          <a:p>
+            <a:pPr algn="ctr"/>
+          </a:p>
+        </p:txBody>
+      </p:sp>
+      <p:sp>
+        <p:nvSpPr>
+          <p:cNvPr id="41" name="TextBox 40"/>
+          <p:cNvSpPr txBox="1"/>
+          <p:nvPr/>
+        </p:nvSpPr>
+        <p:spPr>
+          <a:xfrm>
+            <a:off x="685800" y="3657600"/>
+            <a:ext cx="960120" cy="237744"/>
+          </a:xfrm>
+          <a:prstGeom prst="rect">
+            <a:avLst/>
+          </a:prstGeom>
+          <a:noFill/>
+        </p:spPr>
+        <p:txBody>
+          <a:bodyPr wrap="square">
+            <a:spAutoFit/>
+          </a:bodyPr>
+          <a:lstStyle/>
+          <a:p>
+            <a:pPr algn="ctr">
+              <a:defRPr sz="800" b="1">
+                <a:solidFill>
+                  <a:srgbClr val="BF3F00"/>
+                </a:solidFill>
+              </a:defRPr>
+            </a:pPr>
+            <a:r>
+              <a:t>erp</a:t>
+            </a:r>
+          </a:p>
+        </p:txBody>
+      </p:sp>
+      <p:sp>
+        <p:nvSpPr>
+          <p:cNvPr id="42" name="Rounded Rectangle 41"/>
+          <p:cNvSpPr/>
+          <p:nvPr/>
+        </p:nvSpPr>
+        <p:spPr>
+          <a:xfrm>
+            <a:off x="1709928" y="3611880"/>
+            <a:ext cx="960120" cy="310896"/>
+          </a:xfrm>
+          <a:prstGeom prst="roundRect">
+            <a:avLst/>
+          </a:prstGeom>
+          <a:solidFill>
+            <a:srgbClr val="FFFFFF"/>
+          </a:solidFill>
+          <a:ln w="12700">
+            <a:solidFill>
+              <a:srgbClr val="4A7A80"/>
+            </a:solidFill>
+          </a:ln>
+        </p:spPr>
+        <p:style>
+          <a:lnRef idx="1">
+            <a:schemeClr val="accent1"/>
+          </a:lnRef>
+          <a:fillRef idx="3">
+            <a:schemeClr val="accent1"/>
+          </a:fillRef>
+          <a:effectRef idx="2">
+            <a:schemeClr val="accent1"/>
+          </a:effectRef>
+          <a:fontRef idx="minor">
+            <a:schemeClr val="lt1"/>
+          </a:fontRef>
+        </p:style>
+        <p:txBody>
+          <a:bodyPr rtlCol="0" anchor="ctr"/>
+          <a:lstStyle/>
+          <a:p>
+            <a:pPr algn="ctr"/>
+          </a:p>
+        </p:txBody>
+      </p:sp>
+      <p:sp>
+        <p:nvSpPr>
+          <p:cNvPr id="43" name="TextBox 42"/>
+          <p:cNvSpPr txBox="1"/>
+          <p:nvPr/>
+        </p:nvSpPr>
+        <p:spPr>
+          <a:xfrm>
+            <a:off x="1709928" y="3657600"/>
+            <a:ext cx="960120" cy="237744"/>
+          </a:xfrm>
+          <a:prstGeom prst="rect">
+            <a:avLst/>
+          </a:prstGeom>
+          <a:noFill/>
+        </p:spPr>
+        <p:txBody>
+          <a:bodyPr wrap="square">
+            <a:spAutoFit/>
+          </a:bodyPr>
+          <a:lstStyle/>
+          <a:p>
+            <a:pPr algn="ctr">
+              <a:defRPr sz="800" b="0">
+                <a:solidFill>
+                  <a:srgbClr val="2A4A4E"/>
+                </a:solidFill>
+              </a:defRPr>
+            </a:pPr>
+            <a:r>
+              <a:t>estudios</a:t>
+            </a:r>
+          </a:p>
+        </p:txBody>
+      </p:sp>
+      <p:sp>
+        <p:nvSpPr>
+          <p:cNvPr id="44" name="Rounded Rectangle 43"/>
+          <p:cNvSpPr/>
+          <p:nvPr/>
+        </p:nvSpPr>
+        <p:spPr>
+          <a:xfrm>
+            <a:off x="2734056" y="3611880"/>
+            <a:ext cx="960120" cy="310896"/>
+          </a:xfrm>
+          <a:prstGeom prst="roundRect">
+            <a:avLst/>
+          </a:prstGeom>
+          <a:solidFill>
+            <a:srgbClr val="FFFFFF"/>
+          </a:solidFill>
+          <a:ln w="12700">
+            <a:solidFill>
+              <a:srgbClr val="4A7A80"/>
+            </a:solidFill>
+          </a:ln>
+        </p:spPr>
+        <p:style>
+          <a:lnRef idx="1">
+            <a:schemeClr val="accent1"/>
+          </a:lnRef>
+          <a:fillRef idx="3">
+            <a:schemeClr val="accent1"/>
+          </a:fillRef>
+          <a:effectRef idx="2">
+            <a:schemeClr val="accent1"/>
+          </a:effectRef>
+          <a:fontRef idx="minor">
+            <a:schemeClr val="lt1"/>
+          </a:fontRef>
+        </p:style>
+        <p:txBody>
+          <a:bodyPr rtlCol="0" anchor="ctr"/>
+          <a:lstStyle/>
+          <a:p>
+            <a:pPr algn="ctr"/>
+          </a:p>
+        </p:txBody>
+      </p:sp>
+      <p:sp>
+        <p:nvSpPr>
+          <p:cNvPr id="45" name="TextBox 44"/>
+          <p:cNvSpPr txBox="1"/>
+          <p:nvPr/>
+        </p:nvSpPr>
+        <p:spPr>
+          <a:xfrm>
+            <a:off x="2734056" y="3657600"/>
+            <a:ext cx="960120" cy="237744"/>
+          </a:xfrm>
+          <a:prstGeom prst="rect">
+            <a:avLst/>
+          </a:prstGeom>
+          <a:noFill/>
+        </p:spPr>
+        <p:txBody>
+          <a:bodyPr wrap="square">
+            <a:spAutoFit/>
+          </a:bodyPr>
+          <a:lstStyle/>
+          <a:p>
+            <a:pPr algn="ctr">
+              <a:defRPr sz="800" b="0">
+                <a:solidFill>
+                  <a:srgbClr val="2A4A4E"/>
+                </a:solidFill>
+              </a:defRPr>
+            </a:pPr>
+            <a:r>
+              <a:t>facturas</a:t>
+            </a:r>
+          </a:p>
+        </p:txBody>
+      </p:sp>
+      <p:sp>
+        <p:nvSpPr>
+          <p:cNvPr id="46" name="Rounded Rectangle 45"/>
+          <p:cNvSpPr/>
+          <p:nvPr/>
+        </p:nvSpPr>
+        <p:spPr>
+          <a:xfrm>
+            <a:off x="3758184" y="3611880"/>
+            <a:ext cx="960120" cy="310896"/>
+          </a:xfrm>
+          <a:prstGeom prst="roundRect">
+            <a:avLst/>
+          </a:prstGeom>
+          <a:solidFill>
+            <a:srgbClr val="FFFFFF"/>
+          </a:solidFill>
+          <a:ln w="12700">
+            <a:solidFill>
+              <a:srgbClr val="4A7A80"/>
+            </a:solidFill>
+          </a:ln>
+        </p:spPr>
+        <p:style>
+          <a:lnRef idx="1">
+            <a:schemeClr val="accent1"/>
+          </a:lnRef>
+          <a:fillRef idx="3">
+            <a:schemeClr val="accent1"/>
+          </a:fillRef>
+          <a:effectRef idx="2">
+            <a:schemeClr val="accent1"/>
+          </a:effectRef>
+          <a:fontRef idx="minor">
+            <a:schemeClr val="lt1"/>
+          </a:fontRef>
+        </p:style>
+        <p:txBody>
+          <a:bodyPr rtlCol="0" anchor="ctr"/>
+          <a:lstStyle/>
+          <a:p>
+            <a:pPr algn="ctr"/>
+          </a:p>
+        </p:txBody>
+      </p:sp>
+      <p:sp>
+        <p:nvSpPr>
+          <p:cNvPr id="47" name="TextBox 46"/>
+          <p:cNvSpPr txBox="1"/>
+          <p:nvPr/>
+        </p:nvSpPr>
+        <p:spPr>
+          <a:xfrm>
+            <a:off x="3758184" y="3657600"/>
+            <a:ext cx="960120" cy="237744"/>
+          </a:xfrm>
+          <a:prstGeom prst="rect">
+            <a:avLst/>
+          </a:prstGeom>
+          <a:noFill/>
+        </p:spPr>
+        <p:txBody>
+          <a:bodyPr wrap="square">
+            <a:spAutoFit/>
+          </a:bodyPr>
+          <a:lstStyle/>
+          <a:p>
+            <a:pPr algn="ctr">
+              <a:defRPr sz="800" b="0">
+                <a:solidFill>
+                  <a:srgbClr val="2A4A4E"/>
+                </a:solidFill>
+              </a:defRPr>
+            </a:pPr>
+            <a:r>
+              <a:t>forecast</a:t>
+            </a:r>
+          </a:p>
+        </p:txBody>
+      </p:sp>
+      <p:sp>
+        <p:nvSpPr>
+          <p:cNvPr id="48" name="Rounded Rectangle 47"/>
+          <p:cNvSpPr/>
+          <p:nvPr/>
+        </p:nvSpPr>
+        <p:spPr>
+          <a:xfrm>
+            <a:off x="4782312" y="3611880"/>
+            <a:ext cx="960120" cy="310896"/>
+          </a:xfrm>
+          <a:prstGeom prst="roundRect">
+            <a:avLst/>
+          </a:prstGeom>
+          <a:solidFill>
+            <a:srgbClr val="FFFFFF"/>
+          </a:solidFill>
+          <a:ln w="12700">
+            <a:solidFill>
+              <a:srgbClr val="4A7A80"/>
+            </a:solidFill>
+          </a:ln>
+        </p:spPr>
+        <p:style>
+          <a:lnRef idx="1">
+            <a:schemeClr val="accent1"/>
+          </a:lnRef>
+          <a:fillRef idx="3">
+            <a:schemeClr val="accent1"/>
+          </a:fillRef>
+          <a:effectRef idx="2">
+            <a:schemeClr val="accent1"/>
+          </a:effectRef>
+          <a:fontRef idx="minor">
+            <a:schemeClr val="lt1"/>
+          </a:fontRef>
+        </p:style>
+        <p:txBody>
+          <a:bodyPr rtlCol="0" anchor="ctr"/>
+          <a:lstStyle/>
+          <a:p>
+            <a:pPr algn="ctr"/>
+          </a:p>
+        </p:txBody>
+      </p:sp>
+      <p:sp>
+        <p:nvSpPr>
+          <p:cNvPr id="49" name="TextBox 48"/>
+          <p:cNvSpPr txBox="1"/>
+          <p:nvPr/>
+        </p:nvSpPr>
+        <p:spPr>
+          <a:xfrm>
+            <a:off x="4782312" y="3657600"/>
+            <a:ext cx="960120" cy="237744"/>
+          </a:xfrm>
+          <a:prstGeom prst="rect">
+            <a:avLst/>
+          </a:prstGeom>
+          <a:noFill/>
+        </p:spPr>
+        <p:txBody>
+          <a:bodyPr wrap="square">
+            <a:spAutoFit/>
+          </a:bodyPr>
+          <a:lstStyle/>
+          <a:p>
+            <a:pPr algn="ctr">
+              <a:defRPr sz="800" b="0">
+                <a:solidFill>
+                  <a:srgbClr val="2A4A4E"/>
+                </a:solidFill>
+              </a:defRPr>
+            </a:pPr>
+            <a:r>
+              <a:t>negocios</a:t>
+            </a:r>
+          </a:p>
+        </p:txBody>
+      </p:sp>
+      <p:sp>
+        <p:nvSpPr>
+          <p:cNvPr id="50" name="Rounded Rectangle 49"/>
+          <p:cNvSpPr/>
+          <p:nvPr/>
+        </p:nvSpPr>
+        <p:spPr>
+          <a:xfrm>
+            <a:off x="685800" y="3995928"/>
+            <a:ext cx="960120" cy="310896"/>
+          </a:xfrm>
+          <a:prstGeom prst="roundRect">
+            <a:avLst/>
+          </a:prstGeom>
+          <a:solidFill>
+            <a:srgbClr val="FFFFFF"/>
+          </a:solidFill>
+          <a:ln w="12700">
+            <a:solidFill>
+              <a:srgbClr val="4A7A80"/>
+            </a:solidFill>
+          </a:ln>
+        </p:spPr>
+        <p:style>
+          <a:lnRef idx="1">
+            <a:schemeClr val="accent1"/>
+          </a:lnRef>
+          <a:fillRef idx="3">
+            <a:schemeClr val="accent1"/>
+          </a:fillRef>
+          <a:effectRef idx="2">
+            <a:schemeClr val="accent1"/>
+          </a:effectRef>
+          <a:fontRef idx="minor">
+            <a:schemeClr val="lt1"/>
+          </a:fontRef>
+        </p:style>
+        <p:txBody>
+          <a:bodyPr rtlCol="0" anchor="ctr"/>
+          <a:lstStyle/>
+          <a:p>
+            <a:pPr algn="ctr"/>
+          </a:p>
+        </p:txBody>
+      </p:sp>
+      <p:sp>
+        <p:nvSpPr>
+          <p:cNvPr id="51" name="TextBox 50"/>
+          <p:cNvSpPr txBox="1"/>
+          <p:nvPr/>
+        </p:nvSpPr>
+        <p:spPr>
+          <a:xfrm>
+            <a:off x="685800" y="4041648"/>
+            <a:ext cx="960120" cy="237744"/>
+          </a:xfrm>
+          <a:prstGeom prst="rect">
+            <a:avLst/>
+          </a:prstGeom>
+          <a:noFill/>
+        </p:spPr>
+        <p:txBody>
+          <a:bodyPr wrap="square">
+            <a:spAutoFit/>
+          </a:bodyPr>
+          <a:lstStyle/>
+          <a:p>
+            <a:pPr algn="ctr">
+              <a:defRPr sz="800" b="0">
+                <a:solidFill>
+                  <a:srgbClr val="2A4A4E"/>
+                </a:solidFill>
+              </a:defRPr>
+            </a:pPr>
+            <a:r>
+              <a:t>oc</a:t>
+            </a:r>
+          </a:p>
+        </p:txBody>
+      </p:sp>
+      <p:sp>
+        <p:nvSpPr>
+          <p:cNvPr id="52" name="Rounded Rectangle 51"/>
+          <p:cNvSpPr/>
+          <p:nvPr/>
+        </p:nvSpPr>
+        <p:spPr>
+          <a:xfrm>
+            <a:off x="1709928" y="3995928"/>
+            <a:ext cx="960120" cy="310896"/>
+          </a:xfrm>
+          <a:prstGeom prst="roundRect">
+            <a:avLst/>
+          </a:prstGeom>
+          <a:solidFill>
+            <a:srgbClr val="FFFFFF"/>
+          </a:solidFill>
+          <a:ln w="12700">
+            <a:solidFill>
+              <a:srgbClr val="4A7A80"/>
+            </a:solidFill>
+          </a:ln>
+        </p:spPr>
+        <p:style>
+          <a:lnRef idx="1">
+            <a:schemeClr val="accent1"/>
+          </a:lnRef>
+          <a:fillRef idx="3">
+            <a:schemeClr val="accent1"/>
+          </a:fillRef>
+          <a:effectRef idx="2">
+            <a:schemeClr val="accent1"/>
+          </a:effectRef>
+          <a:fontRef idx="minor">
+            <a:schemeClr val="lt1"/>
+          </a:fontRef>
+        </p:style>
+        <p:txBody>
+          <a:bodyPr rtlCol="0" anchor="ctr"/>
+          <a:lstStyle/>
+          <a:p>
+            <a:pPr algn="ctr"/>
+          </a:p>
+        </p:txBody>
+      </p:sp>
+      <p:sp>
+        <p:nvSpPr>
+          <p:cNvPr id="53" name="TextBox 52"/>
+          <p:cNvSpPr txBox="1"/>
+          <p:nvPr/>
+        </p:nvSpPr>
+        <p:spPr>
+          <a:xfrm>
+            <a:off x="1709928" y="4041648"/>
+            <a:ext cx="960120" cy="237744"/>
+          </a:xfrm>
+          <a:prstGeom prst="rect">
+            <a:avLst/>
+          </a:prstGeom>
+          <a:noFill/>
+        </p:spPr>
+        <p:txBody>
+          <a:bodyPr wrap="square">
+            <a:spAutoFit/>
+          </a:bodyPr>
+          <a:lstStyle/>
+          <a:p>
+            <a:pPr algn="ctr">
+              <a:defRPr sz="800" b="0">
+                <a:solidFill>
+                  <a:srgbClr val="2A4A4E"/>
+                </a:solidFill>
+              </a:defRPr>
+            </a:pPr>
+            <a:r>
+              <a:t>operacion</a:t>
+            </a:r>
+          </a:p>
+        </p:txBody>
+      </p:sp>
+      <p:sp>
+        <p:nvSpPr>
+          <p:cNvPr id="54" name="Rounded Rectangle 53"/>
+          <p:cNvSpPr/>
+          <p:nvPr/>
+        </p:nvSpPr>
+        <p:spPr>
+          <a:xfrm>
+            <a:off x="2734056" y="3995928"/>
+            <a:ext cx="960120" cy="310896"/>
+          </a:xfrm>
+          <a:prstGeom prst="roundRect">
+            <a:avLst/>
+          </a:prstGeom>
+          <a:solidFill>
+            <a:srgbClr val="FFFFFF"/>
+          </a:solidFill>
+          <a:ln w="12700">
+            <a:solidFill>
+              <a:srgbClr val="4A7A80"/>
+            </a:solidFill>
+          </a:ln>
+        </p:spPr>
+        <p:style>
+          <a:lnRef idx="1">
+            <a:schemeClr val="accent1"/>
+          </a:lnRef>
+          <a:fillRef idx="3">
+            <a:schemeClr val="accent1"/>
+          </a:fillRef>
+          <a:effectRef idx="2">
+            <a:schemeClr val="accent1"/>
+          </a:effectRef>
+          <a:fontRef idx="minor">
+            <a:schemeClr val="lt1"/>
+          </a:fontRef>
+        </p:style>
+        <p:txBody>
+          <a:bodyPr rtlCol="0" anchor="ctr"/>
+          <a:lstStyle/>
+          <a:p>
+            <a:pPr algn="ctr"/>
+          </a:p>
+        </p:txBody>
+      </p:sp>
+      <p:sp>
+        <p:nvSpPr>
+          <p:cNvPr id="55" name="TextBox 54"/>
+          <p:cNvSpPr txBox="1"/>
+          <p:nvPr/>
+        </p:nvSpPr>
+        <p:spPr>
+          <a:xfrm>
+            <a:off x="2734056" y="4041648"/>
+            <a:ext cx="960120" cy="237744"/>
+          </a:xfrm>
+          <a:prstGeom prst="rect">
+            <a:avLst/>
+          </a:prstGeom>
+          <a:noFill/>
+        </p:spPr>
+        <p:txBody>
+          <a:bodyPr wrap="square">
+            <a:spAutoFit/>
+          </a:bodyPr>
+          <a:lstStyle/>
+          <a:p>
+            <a:pPr algn="ctr">
+              <a:defRPr sz="800" b="0">
+                <a:solidFill>
+                  <a:srgbClr val="2A4A4E"/>
+                </a:solidFill>
+              </a:defRPr>
+            </a:pPr>
+            <a:r>
+              <a:t>seo</a:t>
+            </a:r>
+          </a:p>
+        </p:txBody>
+      </p:sp>
+      <p:sp>
+        <p:nvSpPr>
+          <p:cNvPr id="56" name="Rounded Rectangle 55"/>
+          <p:cNvSpPr/>
+          <p:nvPr/>
+        </p:nvSpPr>
+        <p:spPr>
+          <a:xfrm>
+            <a:off x="3758184" y="3995928"/>
+            <a:ext cx="960120" cy="310896"/>
+          </a:xfrm>
+          <a:prstGeom prst="roundRect">
+            <a:avLst/>
+          </a:prstGeom>
+          <a:solidFill>
+            <a:srgbClr val="FFFFFF"/>
+          </a:solidFill>
+          <a:ln w="12700">
+            <a:solidFill>
+              <a:srgbClr val="4A7A80"/>
+            </a:solidFill>
+          </a:ln>
+        </p:spPr>
+        <p:style>
+          <a:lnRef idx="1">
+            <a:schemeClr val="accent1"/>
+          </a:lnRef>
+          <a:fillRef idx="3">
+            <a:schemeClr val="accent1"/>
+          </a:fillRef>
+          <a:effectRef idx="2">
+            <a:schemeClr val="accent1"/>
+          </a:effectRef>
+          <a:fontRef idx="minor">
+            <a:schemeClr val="lt1"/>
+          </a:fontRef>
+        </p:style>
+        <p:txBody>
+          <a:bodyPr rtlCol="0" anchor="ctr"/>
+          <a:lstStyle/>
+          <a:p>
+            <a:pPr algn="ctr"/>
+          </a:p>
+        </p:txBody>
+      </p:sp>
+      <p:sp>
+        <p:nvSpPr>
+          <p:cNvPr id="57" name="TextBox 56"/>
+          <p:cNvSpPr txBox="1"/>
+          <p:nvPr/>
+        </p:nvSpPr>
+        <p:spPr>
+          <a:xfrm>
+            <a:off x="3758184" y="4041648"/>
+            <a:ext cx="960120" cy="237744"/>
+          </a:xfrm>
+          <a:prstGeom prst="rect">
+            <a:avLst/>
+          </a:prstGeom>
+          <a:noFill/>
+        </p:spPr>
+        <p:txBody>
+          <a:bodyPr wrap="square">
+            <a:spAutoFit/>
+          </a:bodyPr>
+          <a:lstStyle/>
+          <a:p>
+            <a:pPr algn="ctr">
+              <a:defRPr sz="800" b="0">
+                <a:solidFill>
+                  <a:srgbClr val="2A4A4E"/>
+                </a:solidFill>
+              </a:defRPr>
+            </a:pPr>
+            <a:r>
+              <a:t>strack</a:t>
+            </a:r>
+          </a:p>
+        </p:txBody>
+      </p:sp>
+      <p:sp>
+        <p:nvSpPr>
+          <p:cNvPr id="58" name="TextBox 57"/>
+          <p:cNvSpPr txBox="1"/>
+          <p:nvPr/>
+        </p:nvSpPr>
+        <p:spPr>
+          <a:xfrm>
+            <a:off x="685800" y="5212080"/>
+            <a:ext cx="5074920" cy="411480"/>
+          </a:xfrm>
+          <a:prstGeom prst="rect">
+            <a:avLst/>
+          </a:prstGeom>
+          <a:noFill/>
+        </p:spPr>
+        <p:txBody>
+          <a:bodyPr wrap="square">
+            <a:spAutoFit/>
+          </a:bodyPr>
+          <a:lstStyle/>
+          <a:p>
+            <a:pPr algn="l">
+              <a:defRPr sz="1000" b="1">
+                <a:solidFill>
+                  <a:srgbClr val="BF3F00"/>
+                </a:solidFill>
+              </a:defRPr>
+            </a:pPr>
+            <a:r>
+              <a:t>El ERP no está en la raíz del sitio.</a:t>
             </a:r>
             <a:br/>
             <a:r>
-              <a:t>gamkof · gestion/eerr · js · multimedia · mova/ · mova_auth/</a:t>
+              <a:t>Está dentro de mova/erp/</a:t>
+            </a:r>
+          </a:p>
+        </p:txBody>
+      </p:sp>
+      <p:sp>
+        <p:nvSpPr>
+          <p:cNvPr id="59" name="Rounded Rectangle 58"/>
+          <p:cNvSpPr/>
+          <p:nvPr/>
+        </p:nvSpPr>
+        <p:spPr>
+          <a:xfrm>
+            <a:off x="6263640" y="2514600"/>
+            <a:ext cx="5440680" cy="3246120"/>
+          </a:xfrm>
+          <a:prstGeom prst="roundRect">
+            <a:avLst/>
+          </a:prstGeom>
+          <a:solidFill>
+            <a:srgbClr val="F3EEF8"/>
+          </a:solidFill>
+          <a:ln w="25400">
+            <a:solidFill>
+              <a:srgbClr val="9A7AB8"/>
+            </a:solidFill>
+          </a:ln>
+        </p:spPr>
+        <p:style>
+          <a:lnRef idx="1">
+            <a:schemeClr val="accent1"/>
+          </a:lnRef>
+          <a:fillRef idx="3">
+            <a:schemeClr val="accent1"/>
+          </a:fillRef>
+          <a:effectRef idx="2">
+            <a:schemeClr val="accent1"/>
+          </a:effectRef>
+          <a:fontRef idx="minor">
+            <a:schemeClr val="lt1"/>
+          </a:fontRef>
+        </p:style>
+        <p:txBody>
+          <a:bodyPr rtlCol="0" anchor="ctr"/>
+          <a:lstStyle/>
+          <a:p>
+            <a:pPr algn="ctr"/>
+          </a:p>
+        </p:txBody>
+      </p:sp>
+      <p:sp>
+        <p:nvSpPr>
+          <p:cNvPr id="60" name="Rounded Rectangle 59"/>
+          <p:cNvSpPr/>
+          <p:nvPr/>
+        </p:nvSpPr>
+        <p:spPr>
+          <a:xfrm>
+            <a:off x="6373368" y="2624328"/>
+            <a:ext cx="5221224" cy="438912"/>
+          </a:xfrm>
+          <a:prstGeom prst="roundRect">
+            <a:avLst/>
+          </a:prstGeom>
+          <a:solidFill>
+            <a:srgbClr val="9A7AB8"/>
+          </a:solidFill>
+          <a:ln>
+            <a:noFill/>
+          </a:ln>
+        </p:spPr>
+        <p:style>
+          <a:lnRef idx="1">
+            <a:schemeClr val="accent1"/>
+          </a:lnRef>
+          <a:fillRef idx="3">
+            <a:schemeClr val="accent1"/>
+          </a:fillRef>
+          <a:effectRef idx="2">
+            <a:schemeClr val="accent1"/>
+          </a:effectRef>
+          <a:fontRef idx="minor">
+            <a:schemeClr val="lt1"/>
+          </a:fontRef>
+        </p:style>
+        <p:txBody>
+          <a:bodyPr rtlCol="0" anchor="ctr"/>
+          <a:lstStyle/>
+          <a:p>
+            <a:pPr algn="ctr"/>
+          </a:p>
+        </p:txBody>
+      </p:sp>
+      <p:sp>
+        <p:nvSpPr>
+          <p:cNvPr id="61" name="TextBox 60"/>
+          <p:cNvSpPr txBox="1"/>
+          <p:nvPr/>
+        </p:nvSpPr>
+        <p:spPr>
+          <a:xfrm>
+            <a:off x="6446520" y="2679192"/>
+            <a:ext cx="5074920" cy="320040"/>
+          </a:xfrm>
+          <a:prstGeom prst="rect">
+            <a:avLst/>
+          </a:prstGeom>
+          <a:noFill/>
+        </p:spPr>
+        <p:txBody>
+          <a:bodyPr wrap="square">
+            <a:spAutoFit/>
+          </a:bodyPr>
+          <a:lstStyle/>
+          <a:p>
+            <a:pPr algn="l">
+              <a:defRPr sz="1300" b="1">
+                <a:solidFill>
+                  <a:srgbClr val="FFFFFF"/>
+                </a:solidFill>
+              </a:defRPr>
+            </a:pPr>
+            <a:r>
+              <a:t>mova_auth/  ·  Login unificado (objetivo MOVA)</a:t>
+            </a:r>
+          </a:p>
+        </p:txBody>
+      </p:sp>
+      <p:sp>
+        <p:nvSpPr>
+          <p:cNvPr id="62" name="Rounded Rectangle 61"/>
+          <p:cNvSpPr/>
+          <p:nvPr/>
+        </p:nvSpPr>
+        <p:spPr>
+          <a:xfrm>
+            <a:off x="6492240" y="3291840"/>
+            <a:ext cx="1417320" cy="310896"/>
+          </a:xfrm>
+          <a:prstGeom prst="roundRect">
+            <a:avLst/>
+          </a:prstGeom>
+          <a:solidFill>
+            <a:srgbClr val="FFFFFF"/>
+          </a:solidFill>
+          <a:ln w="12700">
+            <a:solidFill>
+              <a:srgbClr val="9A7AB8"/>
+            </a:solidFill>
+          </a:ln>
+        </p:spPr>
+        <p:style>
+          <a:lnRef idx="1">
+            <a:schemeClr val="accent1"/>
+          </a:lnRef>
+          <a:fillRef idx="3">
+            <a:schemeClr val="accent1"/>
+          </a:fillRef>
+          <a:effectRef idx="2">
+            <a:schemeClr val="accent1"/>
+          </a:effectRef>
+          <a:fontRef idx="minor">
+            <a:schemeClr val="lt1"/>
+          </a:fontRef>
+        </p:style>
+        <p:txBody>
+          <a:bodyPr rtlCol="0" anchor="ctr"/>
+          <a:lstStyle/>
+          <a:p>
+            <a:pPr algn="ctr"/>
+          </a:p>
+        </p:txBody>
+      </p:sp>
+      <p:sp>
+        <p:nvSpPr>
+          <p:cNvPr id="63" name="TextBox 62"/>
+          <p:cNvSpPr txBox="1"/>
+          <p:nvPr/>
+        </p:nvSpPr>
+        <p:spPr>
+          <a:xfrm>
+            <a:off x="6492240" y="3337560"/>
+            <a:ext cx="1417320" cy="237744"/>
+          </a:xfrm>
+          <a:prstGeom prst="rect">
+            <a:avLst/>
+          </a:prstGeom>
+          <a:noFill/>
+        </p:spPr>
+        <p:txBody>
+          <a:bodyPr wrap="square">
+            <a:spAutoFit/>
+          </a:bodyPr>
+          <a:lstStyle/>
+          <a:p>
+            <a:pPr algn="ctr">
+              <a:defRPr sz="800" b="0">
+                <a:solidFill>
+                  <a:srgbClr val="5A4080"/>
+                </a:solidFill>
+              </a:defRPr>
+            </a:pPr>
+            <a:r>
+              <a:t>login.php</a:t>
+            </a:r>
+          </a:p>
+        </p:txBody>
+      </p:sp>
+      <p:sp>
+        <p:nvSpPr>
+          <p:cNvPr id="64" name="Rounded Rectangle 63"/>
+          <p:cNvSpPr/>
+          <p:nvPr/>
+        </p:nvSpPr>
+        <p:spPr>
+          <a:xfrm>
+            <a:off x="7973568" y="3291840"/>
+            <a:ext cx="1417320" cy="310896"/>
+          </a:xfrm>
+          <a:prstGeom prst="roundRect">
+            <a:avLst/>
+          </a:prstGeom>
+          <a:solidFill>
+            <a:srgbClr val="FFFFFF"/>
+          </a:solidFill>
+          <a:ln w="12700">
+            <a:solidFill>
+              <a:srgbClr val="9A7AB8"/>
+            </a:solidFill>
+          </a:ln>
+        </p:spPr>
+        <p:style>
+          <a:lnRef idx="1">
+            <a:schemeClr val="accent1"/>
+          </a:lnRef>
+          <a:fillRef idx="3">
+            <a:schemeClr val="accent1"/>
+          </a:fillRef>
+          <a:effectRef idx="2">
+            <a:schemeClr val="accent1"/>
+          </a:effectRef>
+          <a:fontRef idx="minor">
+            <a:schemeClr val="lt1"/>
+          </a:fontRef>
+        </p:style>
+        <p:txBody>
+          <a:bodyPr rtlCol="0" anchor="ctr"/>
+          <a:lstStyle/>
+          <a:p>
+            <a:pPr algn="ctr"/>
+          </a:p>
+        </p:txBody>
+      </p:sp>
+      <p:sp>
+        <p:nvSpPr>
+          <p:cNvPr id="65" name="TextBox 64"/>
+          <p:cNvSpPr txBox="1"/>
+          <p:nvPr/>
+        </p:nvSpPr>
+        <p:spPr>
+          <a:xfrm>
+            <a:off x="7973568" y="3337560"/>
+            <a:ext cx="1417320" cy="237744"/>
+          </a:xfrm>
+          <a:prstGeom prst="rect">
+            <a:avLst/>
+          </a:prstGeom>
+          <a:noFill/>
+        </p:spPr>
+        <p:txBody>
+          <a:bodyPr wrap="square">
+            <a:spAutoFit/>
+          </a:bodyPr>
+          <a:lstStyle/>
+          <a:p>
+            <a:pPr algn="ctr">
+              <a:defRPr sz="800" b="0">
+                <a:solidFill>
+                  <a:srgbClr val="5A4080"/>
+                </a:solidFill>
+              </a:defRPr>
+            </a:pPr>
+            <a:r>
+              <a:t>auth.php</a:t>
+            </a:r>
+          </a:p>
+        </p:txBody>
+      </p:sp>
+      <p:sp>
+        <p:nvSpPr>
+          <p:cNvPr id="66" name="Rounded Rectangle 65"/>
+          <p:cNvSpPr/>
+          <p:nvPr/>
+        </p:nvSpPr>
+        <p:spPr>
+          <a:xfrm>
+            <a:off x="9454896" y="3291840"/>
+            <a:ext cx="1417320" cy="310896"/>
+          </a:xfrm>
+          <a:prstGeom prst="roundRect">
+            <a:avLst/>
+          </a:prstGeom>
+          <a:solidFill>
+            <a:srgbClr val="FFFFFF"/>
+          </a:solidFill>
+          <a:ln w="12700">
+            <a:solidFill>
+              <a:srgbClr val="9A7AB8"/>
+            </a:solidFill>
+          </a:ln>
+        </p:spPr>
+        <p:style>
+          <a:lnRef idx="1">
+            <a:schemeClr val="accent1"/>
+          </a:lnRef>
+          <a:fillRef idx="3">
+            <a:schemeClr val="accent1"/>
+          </a:fillRef>
+          <a:effectRef idx="2">
+            <a:schemeClr val="accent1"/>
+          </a:effectRef>
+          <a:fontRef idx="minor">
+            <a:schemeClr val="lt1"/>
+          </a:fontRef>
+        </p:style>
+        <p:txBody>
+          <a:bodyPr rtlCol="0" anchor="ctr"/>
+          <a:lstStyle/>
+          <a:p>
+            <a:pPr algn="ctr"/>
+          </a:p>
+        </p:txBody>
+      </p:sp>
+      <p:sp>
+        <p:nvSpPr>
+          <p:cNvPr id="67" name="TextBox 66"/>
+          <p:cNvSpPr txBox="1"/>
+          <p:nvPr/>
+        </p:nvSpPr>
+        <p:spPr>
+          <a:xfrm>
+            <a:off x="9454896" y="3337560"/>
+            <a:ext cx="1417320" cy="237744"/>
+          </a:xfrm>
+          <a:prstGeom prst="rect">
+            <a:avLst/>
+          </a:prstGeom>
+          <a:noFill/>
+        </p:spPr>
+        <p:txBody>
+          <a:bodyPr wrap="square">
+            <a:spAutoFit/>
+          </a:bodyPr>
+          <a:lstStyle/>
+          <a:p>
+            <a:pPr algn="ctr">
+              <a:defRPr sz="800" b="0">
+                <a:solidFill>
+                  <a:srgbClr val="5A4080"/>
+                </a:solidFill>
+              </a:defRPr>
+            </a:pPr>
+            <a:r>
+              <a:t>config.php</a:t>
+            </a:r>
+          </a:p>
+        </p:txBody>
+      </p:sp>
+      <p:sp>
+        <p:nvSpPr>
+          <p:cNvPr id="68" name="Rounded Rectangle 67"/>
+          <p:cNvSpPr/>
+          <p:nvPr/>
+        </p:nvSpPr>
+        <p:spPr>
+          <a:xfrm>
+            <a:off x="6492240" y="3675888"/>
+            <a:ext cx="1417320" cy="310896"/>
+          </a:xfrm>
+          <a:prstGeom prst="roundRect">
+            <a:avLst/>
+          </a:prstGeom>
+          <a:solidFill>
+            <a:srgbClr val="FFFFFF"/>
+          </a:solidFill>
+          <a:ln w="12700">
+            <a:solidFill>
+              <a:srgbClr val="9A7AB8"/>
+            </a:solidFill>
+          </a:ln>
+        </p:spPr>
+        <p:style>
+          <a:lnRef idx="1">
+            <a:schemeClr val="accent1"/>
+          </a:lnRef>
+          <a:fillRef idx="3">
+            <a:schemeClr val="accent1"/>
+          </a:fillRef>
+          <a:effectRef idx="2">
+            <a:schemeClr val="accent1"/>
+          </a:effectRef>
+          <a:fontRef idx="minor">
+            <a:schemeClr val="lt1"/>
+          </a:fontRef>
+        </p:style>
+        <p:txBody>
+          <a:bodyPr rtlCol="0" anchor="ctr"/>
+          <a:lstStyle/>
+          <a:p>
+            <a:pPr algn="ctr"/>
+          </a:p>
+        </p:txBody>
+      </p:sp>
+      <p:sp>
+        <p:nvSpPr>
+          <p:cNvPr id="69" name="TextBox 68"/>
+          <p:cNvSpPr txBox="1"/>
+          <p:nvPr/>
+        </p:nvSpPr>
+        <p:spPr>
+          <a:xfrm>
+            <a:off x="6492240" y="3721608"/>
+            <a:ext cx="1417320" cy="237744"/>
+          </a:xfrm>
+          <a:prstGeom prst="rect">
+            <a:avLst/>
+          </a:prstGeom>
+          <a:noFill/>
+        </p:spPr>
+        <p:txBody>
+          <a:bodyPr wrap="square">
+            <a:spAutoFit/>
+          </a:bodyPr>
+          <a:lstStyle/>
+          <a:p>
+            <a:pPr algn="ctr">
+              <a:defRPr sz="800" b="0">
+                <a:solidFill>
+                  <a:srgbClr val="5A4080"/>
+                </a:solidFill>
+              </a:defRPr>
+            </a:pPr>
+            <a:r>
+              <a:t>google_login.php</a:t>
+            </a:r>
+          </a:p>
+        </p:txBody>
+      </p:sp>
+      <p:sp>
+        <p:nvSpPr>
+          <p:cNvPr id="70" name="Rounded Rectangle 69"/>
+          <p:cNvSpPr/>
+          <p:nvPr/>
+        </p:nvSpPr>
+        <p:spPr>
+          <a:xfrm>
+            <a:off x="7973568" y="3675888"/>
+            <a:ext cx="1417320" cy="310896"/>
+          </a:xfrm>
+          <a:prstGeom prst="roundRect">
+            <a:avLst/>
+          </a:prstGeom>
+          <a:solidFill>
+            <a:srgbClr val="FFFFFF"/>
+          </a:solidFill>
+          <a:ln w="12700">
+            <a:solidFill>
+              <a:srgbClr val="9A7AB8"/>
+            </a:solidFill>
+          </a:ln>
+        </p:spPr>
+        <p:style>
+          <a:lnRef idx="1">
+            <a:schemeClr val="accent1"/>
+          </a:lnRef>
+          <a:fillRef idx="3">
+            <a:schemeClr val="accent1"/>
+          </a:fillRef>
+          <a:effectRef idx="2">
+            <a:schemeClr val="accent1"/>
+          </a:effectRef>
+          <a:fontRef idx="minor">
+            <a:schemeClr val="lt1"/>
+          </a:fontRef>
+        </p:style>
+        <p:txBody>
+          <a:bodyPr rtlCol="0" anchor="ctr"/>
+          <a:lstStyle/>
+          <a:p>
+            <a:pPr algn="ctr"/>
+          </a:p>
+        </p:txBody>
+      </p:sp>
+      <p:sp>
+        <p:nvSpPr>
+          <p:cNvPr id="71" name="TextBox 70"/>
+          <p:cNvSpPr txBox="1"/>
+          <p:nvPr/>
+        </p:nvSpPr>
+        <p:spPr>
+          <a:xfrm>
+            <a:off x="7973568" y="3721608"/>
+            <a:ext cx="1417320" cy="237744"/>
+          </a:xfrm>
+          <a:prstGeom prst="rect">
+            <a:avLst/>
+          </a:prstGeom>
+          <a:noFill/>
+        </p:spPr>
+        <p:txBody>
+          <a:bodyPr wrap="square">
+            <a:spAutoFit/>
+          </a:bodyPr>
+          <a:lstStyle/>
+          <a:p>
+            <a:pPr algn="ctr">
+              <a:defRPr sz="800" b="0">
+                <a:solidFill>
+                  <a:srgbClr val="5A4080"/>
+                </a:solidFill>
+              </a:defRPr>
+            </a:pPr>
+            <a:r>
+              <a:t>logout.php</a:t>
+            </a:r>
+          </a:p>
+        </p:txBody>
+      </p:sp>
+      <p:sp>
+        <p:nvSpPr>
+          <p:cNvPr id="72" name="Rounded Rectangle 71"/>
+          <p:cNvSpPr/>
+          <p:nvPr/>
+        </p:nvSpPr>
+        <p:spPr>
+          <a:xfrm>
+            <a:off x="9454896" y="3675888"/>
+            <a:ext cx="1417320" cy="310896"/>
+          </a:xfrm>
+          <a:prstGeom prst="roundRect">
+            <a:avLst/>
+          </a:prstGeom>
+          <a:solidFill>
+            <a:srgbClr val="FFFFFF"/>
+          </a:solidFill>
+          <a:ln w="12700">
+            <a:solidFill>
+              <a:srgbClr val="9A7AB8"/>
+            </a:solidFill>
+          </a:ln>
+        </p:spPr>
+        <p:style>
+          <a:lnRef idx="1">
+            <a:schemeClr val="accent1"/>
+          </a:lnRef>
+          <a:fillRef idx="3">
+            <a:schemeClr val="accent1"/>
+          </a:fillRef>
+          <a:effectRef idx="2">
+            <a:schemeClr val="accent1"/>
+          </a:effectRef>
+          <a:fontRef idx="minor">
+            <a:schemeClr val="lt1"/>
+          </a:fontRef>
+        </p:style>
+        <p:txBody>
+          <a:bodyPr rtlCol="0" anchor="ctr"/>
+          <a:lstStyle/>
+          <a:p>
+            <a:pPr algn="ctr"/>
+          </a:p>
+        </p:txBody>
+      </p:sp>
+      <p:sp>
+        <p:nvSpPr>
+          <p:cNvPr id="73" name="TextBox 72"/>
+          <p:cNvSpPr txBox="1"/>
+          <p:nvPr/>
+        </p:nvSpPr>
+        <p:spPr>
+          <a:xfrm>
+            <a:off x="9454896" y="3721608"/>
+            <a:ext cx="1417320" cy="237744"/>
+          </a:xfrm>
+          <a:prstGeom prst="rect">
+            <a:avLst/>
+          </a:prstGeom>
+          <a:noFill/>
+        </p:spPr>
+        <p:txBody>
+          <a:bodyPr wrap="square">
+            <a:spAutoFit/>
+          </a:bodyPr>
+          <a:lstStyle/>
+          <a:p>
+            <a:pPr algn="ctr">
+              <a:defRPr sz="800" b="0">
+                <a:solidFill>
+                  <a:srgbClr val="5A4080"/>
+                </a:solidFill>
+              </a:defRPr>
+            </a:pPr>
+            <a:r>
+              <a:t>panel.php</a:t>
+            </a:r>
+          </a:p>
+        </p:txBody>
+      </p:sp>
+      <p:sp>
+        <p:nvSpPr>
+          <p:cNvPr id="74" name="Rounded Rectangle 73"/>
+          <p:cNvSpPr/>
+          <p:nvPr/>
+        </p:nvSpPr>
+        <p:spPr>
+          <a:xfrm>
+            <a:off x="6492240" y="4059936"/>
+            <a:ext cx="1417320" cy="310896"/>
+          </a:xfrm>
+          <a:prstGeom prst="roundRect">
+            <a:avLst/>
+          </a:prstGeom>
+          <a:solidFill>
+            <a:srgbClr val="FFFFFF"/>
+          </a:solidFill>
+          <a:ln w="12700">
+            <a:solidFill>
+              <a:srgbClr val="9A7AB8"/>
+            </a:solidFill>
+          </a:ln>
+        </p:spPr>
+        <p:style>
+          <a:lnRef idx="1">
+            <a:schemeClr val="accent1"/>
+          </a:lnRef>
+          <a:fillRef idx="3">
+            <a:schemeClr val="accent1"/>
+          </a:fillRef>
+          <a:effectRef idx="2">
+            <a:schemeClr val="accent1"/>
+          </a:effectRef>
+          <a:fontRef idx="minor">
+            <a:schemeClr val="lt1"/>
+          </a:fontRef>
+        </p:style>
+        <p:txBody>
+          <a:bodyPr rtlCol="0" anchor="ctr"/>
+          <a:lstStyle/>
+          <a:p>
+            <a:pPr algn="ctr"/>
+          </a:p>
+        </p:txBody>
+      </p:sp>
+      <p:sp>
+        <p:nvSpPr>
+          <p:cNvPr id="75" name="TextBox 74"/>
+          <p:cNvSpPr txBox="1"/>
+          <p:nvPr/>
+        </p:nvSpPr>
+        <p:spPr>
+          <a:xfrm>
+            <a:off x="6492240" y="4105656"/>
+            <a:ext cx="1417320" cy="237744"/>
+          </a:xfrm>
+          <a:prstGeom prst="rect">
+            <a:avLst/>
+          </a:prstGeom>
+          <a:noFill/>
+        </p:spPr>
+        <p:txBody>
+          <a:bodyPr wrap="square">
+            <a:spAutoFit/>
+          </a:bodyPr>
+          <a:lstStyle/>
+          <a:p>
+            <a:pPr algn="ctr">
+              <a:defRPr sz="800" b="0">
+                <a:solidFill>
+                  <a:srgbClr val="5A4080"/>
+                </a:solidFill>
+              </a:defRPr>
+            </a:pPr>
+            <a:r>
+              <a:t>setup.sql</a:t>
+            </a:r>
+          </a:p>
+        </p:txBody>
+      </p:sp>
+      <p:sp>
+        <p:nvSpPr>
+          <p:cNvPr id="76" name="TextBox 75"/>
+          <p:cNvSpPr txBox="1"/>
+          <p:nvPr/>
+        </p:nvSpPr>
+        <p:spPr>
+          <a:xfrm>
+            <a:off x="6492240" y="4846320"/>
+            <a:ext cx="4983480" cy="731520"/>
+          </a:xfrm>
+          <a:prstGeom prst="rect">
+            <a:avLst/>
+          </a:prstGeom>
+          <a:noFill/>
+        </p:spPr>
+        <p:txBody>
+          <a:bodyPr wrap="square">
+            <a:spAutoFit/>
+          </a:bodyPr>
+          <a:lstStyle/>
+          <a:p>
+            <a:pPr algn="l">
+              <a:defRPr sz="1100" b="1">
+                <a:solidFill>
+                  <a:srgbClr val="5A4080"/>
+                </a:solidFill>
+              </a:defRPr>
+            </a:pPr>
+            <a:r>
+              <a:t>Aquí vivirá el único login</a:t>
             </a:r>
             <a:br/>
             <a:r>
-              <a:t>operaciones · rrhh · skill</a:t>
-            </a:r>
-            <a:br/>
-            <a:br/>
-            <a:r>
-              <a:t>mova/ → agencia · brief · cotizador · cuentas · doc · erp · estudios</a:t>
-            </a:r>
-            <a:br/>
-            <a:r>
-              <a:t>facturas · forecast · negocios · oc · operacion · restringido · seo</a:t>
-            </a:r>
-            <a:br/>
-            <a:r>
-              <a:t>strack · suscripciones · versiones_anteriores</a:t>
-            </a:r>
-            <a:br/>
-            <a:br/>
-            <a:r>
-              <a:t>mova_auth/ → auth.php · config.php · google_login.php · login.php</a:t>
-            </a:r>
-            <a:br/>
-            <a:r>
-              <a:t>logout.php · panel.php · setup.sql</a:t>
-            </a:r>
-          </a:p>
-        </p:txBody>
-      </p:sp>
-      <p:sp>
-        <p:nvSpPr>
-          <p:cNvPr id="6" name="TextBox 5"/>
-          <p:cNvSpPr txBox="1"/>
-          <p:nvPr/>
-        </p:nvSpPr>
-        <p:spPr>
-          <a:xfrm>
-            <a:off x="685800" y="5486400"/>
-            <a:ext cx="10515600" cy="411480"/>
+              <a:t>para todos los módulos M.</a:t>
+            </a:r>
+          </a:p>
+        </p:txBody>
+      </p:sp>
+      <p:sp>
+        <p:nvSpPr>
+          <p:cNvPr id="77" name="TextBox 76"/>
+          <p:cNvSpPr txBox="1"/>
+          <p:nvPr/>
+        </p:nvSpPr>
+        <p:spPr>
+          <a:xfrm>
+            <a:off x="502920" y="5897880"/>
+            <a:ext cx="11155680" cy="320040"/>
           </a:xfrm>
           <a:prstGeom prst="rect">
             <a:avLst/>
@@ -7583,14 +10382,14 @@
           <a:lstStyle/>
           <a:p>
             <a:pPr algn="l">
-              <a:defRPr sz="1400" b="1">
-                <a:solidFill>
-                  <a:srgbClr val="4A7A80"/>
-                </a:solidFill>
-              </a:defRPr>
-            </a:pPr>
-            <a:r>
-              <a:t>No hay MAESTRO/INGRESOS/EGRESOS en raíz — ERP bajo mova/erp/</a:t>
+              <a:defRPr sz="1100" b="1">
+                <a:solidFill>
+                  <a:srgbClr val="2A4A4E"/>
+                </a:solidFill>
+              </a:defRPr>
+            </a:pPr>
+            <a:r>
+              <a:t>Lectura rápida:  teal = MOVA  ·  violeta = login unificado  ·  amarillo = ERP (ubicación clave)</a:t>
             </a:r>
           </a:p>
         </p:txBody>

</xml_diff>

<commit_message>
Agregar slide final con solicitud visual al equipo n8n
Nueva slide «Qué necesitamos de n8n» con 5 pasos numerados, diagrama
de flujo módulos→webhooks→respuesta, plantilla de tabla y nota de que
no bloquea Día 1. Misma sección en HTML/PDF. Entregables regenerados.

Co-authored-by: JosefaOgalde <JosefaOgalde@users.noreply.github.com>
</commit_message>
<xml_diff>
--- a/index/clientes/mkof/MOVA-D1-Inventario-Status.pptx
+++ b/index/clientes/mkof/MOVA-D1-Inventario-Status.pptx
@@ -13,6 +13,7 @@
     <p:sldId id="261" r:id="rId12"/>
     <p:sldId id="262" r:id="rId13"/>
     <p:sldId id="263" r:id="rId14"/>
+    <p:sldId id="264" r:id="rId15"/>
   </p:sldIdLst>
   <p:sldSz cx="12191695" cy="6858000" type="screen4x3"/>
   <p:notesSz cx="6858000" cy="9144000"/>
@@ -11137,6 +11138,2895 @@
             </a:pPr>
             <a:r>
               <a:t>Entregables: MOVA-D1-Inventario-Status.pptx · MOVA-D1-Inventario-Status.pdf</a:t>
+            </a:r>
+          </a:p>
+        </p:txBody>
+      </p:sp>
+    </p:spTree>
+  </p:cSld>
+  <p:clrMapOvr>
+    <a:masterClrMapping/>
+  </p:clrMapOvr>
+</p:sld>
+</file>
+
+<file path=ppt/slides/slide9.xml><?xml version="1.0" encoding="utf-8"?>
+<p:sld xmlns:a="http://schemas.openxmlformats.org/drawingml/2006/main" xmlns:p="http://schemas.openxmlformats.org/presentationml/2006/main" xmlns:r="http://schemas.openxmlformats.org/officeDocument/2006/relationships">
+  <p:cSld>
+    <p:bg>
+      <p:bgPr>
+        <a:solidFill>
+          <a:srgbClr val="E8F6F8"/>
+        </a:solidFill>
+        <a:effectLst/>
+      </p:bgPr>
+    </p:bg>
+    <p:spTree>
+      <p:nvGrpSpPr>
+        <p:cNvPr id="1" name=""/>
+        <p:cNvGrpSpPr/>
+        <p:nvPr/>
+      </p:nvGrpSpPr>
+      <p:grpSpPr/>
+      <p:sp>
+        <p:nvSpPr>
+          <p:cNvPr id="2" name="Rectangle 1"/>
+          <p:cNvSpPr/>
+          <p:nvPr/>
+        </p:nvSpPr>
+        <p:spPr>
+          <a:xfrm>
+            <a:off x="0" y="0"/>
+            <a:ext cx="12191695" cy="960120"/>
+          </a:xfrm>
+          <a:prstGeom prst="rect">
+            <a:avLst/>
+          </a:prstGeom>
+          <a:solidFill>
+            <a:srgbClr val="4A7A80"/>
+          </a:solidFill>
+          <a:ln>
+            <a:noFill/>
+          </a:ln>
+        </p:spPr>
+        <p:style>
+          <a:lnRef idx="1">
+            <a:schemeClr val="accent1"/>
+          </a:lnRef>
+          <a:fillRef idx="3">
+            <a:schemeClr val="accent1"/>
+          </a:fillRef>
+          <a:effectRef idx="2">
+            <a:schemeClr val="accent1"/>
+          </a:effectRef>
+          <a:fontRef idx="minor">
+            <a:schemeClr val="lt1"/>
+          </a:fontRef>
+        </p:style>
+        <p:txBody>
+          <a:bodyPr rtlCol="0" anchor="ctr"/>
+          <a:lstStyle/>
+          <a:p>
+            <a:pPr algn="ctr"/>
+          </a:p>
+        </p:txBody>
+      </p:sp>
+      <p:sp>
+        <p:nvSpPr>
+          <p:cNvPr id="3" name="TextBox 2"/>
+          <p:cNvSpPr txBox="1"/>
+          <p:nvPr/>
+        </p:nvSpPr>
+        <p:spPr>
+          <a:xfrm>
+            <a:off x="502920" y="164592"/>
+            <a:ext cx="10058400" cy="457200"/>
+          </a:xfrm>
+          <a:prstGeom prst="rect">
+            <a:avLst/>
+          </a:prstGeom>
+          <a:noFill/>
+        </p:spPr>
+        <p:txBody>
+          <a:bodyPr wrap="square">
+            <a:spAutoFit/>
+          </a:bodyPr>
+          <a:lstStyle/>
+          <a:p>
+            <a:pPr algn="l">
+              <a:defRPr sz="2400" b="1">
+                <a:solidFill>
+                  <a:srgbClr val="FFFFFF"/>
+                </a:solidFill>
+              </a:defRPr>
+            </a:pPr>
+            <a:r>
+              <a:t>Qué necesitamos de n8n</a:t>
+            </a:r>
+          </a:p>
+        </p:txBody>
+      </p:sp>
+      <p:sp>
+        <p:nvSpPr>
+          <p:cNvPr id="4" name="TextBox 3"/>
+          <p:cNvSpPr txBox="1"/>
+          <p:nvPr/>
+        </p:nvSpPr>
+        <p:spPr>
+          <a:xfrm>
+            <a:off x="502920" y="566928"/>
+            <a:ext cx="10058400" cy="320040"/>
+          </a:xfrm>
+          <a:prstGeom prst="rect">
+            <a:avLst/>
+          </a:prstGeom>
+          <a:noFill/>
+        </p:spPr>
+        <p:txBody>
+          <a:bodyPr wrap="square">
+            <a:spAutoFit/>
+          </a:bodyPr>
+          <a:lstStyle/>
+          <a:p>
+            <a:pPr algn="l">
+              <a:defRPr sz="1300" b="0">
+                <a:solidFill>
+                  <a:srgbClr val="E8F6F8"/>
+                </a:solidFill>
+              </a:defRPr>
+            </a:pPr>
+            <a:r>
+              <a:t>Para el equipo que administra n8n · complemento al inventario</a:t>
+            </a:r>
+          </a:p>
+        </p:txBody>
+      </p:sp>
+      <p:sp>
+        <p:nvSpPr>
+          <p:cNvPr id="5" name="Rounded Rectangle 4"/>
+          <p:cNvSpPr/>
+          <p:nvPr/>
+        </p:nvSpPr>
+        <p:spPr>
+          <a:xfrm>
+            <a:off x="9326880" y="1024128"/>
+            <a:ext cx="2331720" cy="384048"/>
+          </a:xfrm>
+          <a:prstGeom prst="roundRect">
+            <a:avLst/>
+          </a:prstGeom>
+          <a:solidFill>
+            <a:srgbClr val="E8E0F8"/>
+          </a:solidFill>
+          <a:ln w="12700">
+            <a:solidFill>
+              <a:srgbClr val="6F42C1"/>
+            </a:solidFill>
+          </a:ln>
+        </p:spPr>
+        <p:style>
+          <a:lnRef idx="1">
+            <a:schemeClr val="accent1"/>
+          </a:lnRef>
+          <a:fillRef idx="3">
+            <a:schemeClr val="accent1"/>
+          </a:fillRef>
+          <a:effectRef idx="2">
+            <a:schemeClr val="accent1"/>
+          </a:effectRef>
+          <a:fontRef idx="minor">
+            <a:schemeClr val="lt1"/>
+          </a:fontRef>
+        </p:style>
+        <p:txBody>
+          <a:bodyPr rtlCol="0" anchor="ctr"/>
+          <a:lstStyle/>
+          <a:p>
+            <a:pPr algn="ctr"/>
+          </a:p>
+        </p:txBody>
+      </p:sp>
+      <p:sp>
+        <p:nvSpPr>
+          <p:cNvPr id="6" name="TextBox 5"/>
+          <p:cNvSpPr txBox="1"/>
+          <p:nvPr/>
+        </p:nvSpPr>
+        <p:spPr>
+          <a:xfrm>
+            <a:off x="9326880" y="1069848"/>
+            <a:ext cx="2331720" cy="292608"/>
+          </a:xfrm>
+          <a:prstGeom prst="rect">
+            <a:avLst/>
+          </a:prstGeom>
+          <a:noFill/>
+        </p:spPr>
+        <p:txBody>
+          <a:bodyPr wrap="square">
+            <a:spAutoFit/>
+          </a:bodyPr>
+          <a:lstStyle/>
+          <a:p>
+            <a:pPr algn="ctr">
+              <a:defRPr sz="1000" b="1">
+                <a:solidFill>
+                  <a:srgbClr val="6F42C1"/>
+                </a:solidFill>
+              </a:defRPr>
+            </a:pPr>
+            <a:r>
+              <a:t>No bloquea Día 1</a:t>
+            </a:r>
+          </a:p>
+        </p:txBody>
+      </p:sp>
+      <p:sp>
+        <p:nvSpPr>
+          <p:cNvPr id="7" name="Oval 6"/>
+          <p:cNvSpPr/>
+          <p:nvPr/>
+        </p:nvSpPr>
+        <p:spPr>
+          <a:xfrm>
+            <a:off x="548640" y="1335024"/>
+            <a:ext cx="347472" cy="347472"/>
+          </a:xfrm>
+          <a:prstGeom prst="ellipse">
+            <a:avLst/>
+          </a:prstGeom>
+          <a:solidFill>
+            <a:srgbClr val="6F42C1"/>
+          </a:solidFill>
+          <a:ln>
+            <a:noFill/>
+          </a:ln>
+        </p:spPr>
+        <p:style>
+          <a:lnRef idx="1">
+            <a:schemeClr val="accent1"/>
+          </a:lnRef>
+          <a:fillRef idx="3">
+            <a:schemeClr val="accent1"/>
+          </a:fillRef>
+          <a:effectRef idx="2">
+            <a:schemeClr val="accent1"/>
+          </a:effectRef>
+          <a:fontRef idx="minor">
+            <a:schemeClr val="lt1"/>
+          </a:fontRef>
+        </p:style>
+        <p:txBody>
+          <a:bodyPr rtlCol="0" anchor="ctr"/>
+          <a:lstStyle/>
+          <a:p>
+            <a:pPr algn="ctr"/>
+          </a:p>
+        </p:txBody>
+      </p:sp>
+      <p:sp>
+        <p:nvSpPr>
+          <p:cNvPr id="8" name="TextBox 7"/>
+          <p:cNvSpPr txBox="1"/>
+          <p:nvPr/>
+        </p:nvSpPr>
+        <p:spPr>
+          <a:xfrm>
+            <a:off x="548640" y="1371600"/>
+            <a:ext cx="347472" cy="274320"/>
+          </a:xfrm>
+          <a:prstGeom prst="rect">
+            <a:avLst/>
+          </a:prstGeom>
+          <a:noFill/>
+        </p:spPr>
+        <p:txBody>
+          <a:bodyPr wrap="square">
+            <a:spAutoFit/>
+          </a:bodyPr>
+          <a:lstStyle/>
+          <a:p>
+            <a:pPr algn="ctr">
+              <a:defRPr sz="1200" b="1">
+                <a:solidFill>
+                  <a:srgbClr val="FFFFFF"/>
+                </a:solidFill>
+              </a:defRPr>
+            </a:pPr>
+            <a:r>
+              <a:t>1</a:t>
+            </a:r>
+          </a:p>
+        </p:txBody>
+      </p:sp>
+      <p:sp>
+        <p:nvSpPr>
+          <p:cNvPr id="9" name="Rounded Rectangle 8"/>
+          <p:cNvSpPr/>
+          <p:nvPr/>
+        </p:nvSpPr>
+        <p:spPr>
+          <a:xfrm>
+            <a:off x="1005840" y="1298448"/>
+            <a:ext cx="4892040" cy="658368"/>
+          </a:xfrm>
+          <a:prstGeom prst="roundRect">
+            <a:avLst/>
+          </a:prstGeom>
+          <a:solidFill>
+            <a:srgbClr val="FFFFFF"/>
+          </a:solidFill>
+          <a:ln w="12700">
+            <a:solidFill>
+              <a:srgbClr val="6F42C1"/>
+            </a:solidFill>
+          </a:ln>
+        </p:spPr>
+        <p:style>
+          <a:lnRef idx="1">
+            <a:schemeClr val="accent1"/>
+          </a:lnRef>
+          <a:fillRef idx="3">
+            <a:schemeClr val="accent1"/>
+          </a:fillRef>
+          <a:effectRef idx="2">
+            <a:schemeClr val="accent1"/>
+          </a:effectRef>
+          <a:fontRef idx="minor">
+            <a:schemeClr val="lt1"/>
+          </a:fontRef>
+        </p:style>
+        <p:txBody>
+          <a:bodyPr rtlCol="0" anchor="ctr"/>
+          <a:lstStyle/>
+          <a:p>
+            <a:pPr algn="ctr"/>
+          </a:p>
+        </p:txBody>
+      </p:sp>
+      <p:sp>
+        <p:nvSpPr>
+          <p:cNvPr id="10" name="TextBox 9"/>
+          <p:cNvSpPr txBox="1"/>
+          <p:nvPr/>
+        </p:nvSpPr>
+        <p:spPr>
+          <a:xfrm>
+            <a:off x="1143000" y="1353312"/>
+            <a:ext cx="4663440" cy="256032"/>
+          </a:xfrm>
+          <a:prstGeom prst="rect">
+            <a:avLst/>
+          </a:prstGeom>
+          <a:noFill/>
+        </p:spPr>
+        <p:txBody>
+          <a:bodyPr wrap="square">
+            <a:spAutoFit/>
+          </a:bodyPr>
+          <a:lstStyle/>
+          <a:p>
+            <a:pPr algn="l">
+              <a:defRPr sz="1200" b="1">
+                <a:solidFill>
+                  <a:srgbClr val="6F42C1"/>
+                </a:solidFill>
+              </a:defRPr>
+            </a:pPr>
+            <a:r>
+              <a:t>Listar workflows activos</a:t>
+            </a:r>
+          </a:p>
+        </p:txBody>
+      </p:sp>
+      <p:sp>
+        <p:nvSpPr>
+          <p:cNvPr id="11" name="TextBox 10"/>
+          <p:cNvSpPr txBox="1"/>
+          <p:nvPr/>
+        </p:nvSpPr>
+        <p:spPr>
+          <a:xfrm>
+            <a:off x="1143000" y="1591056"/>
+            <a:ext cx="4663440" cy="320040"/>
+          </a:xfrm>
+          <a:prstGeom prst="rect">
+            <a:avLst/>
+          </a:prstGeom>
+          <a:noFill/>
+        </p:spPr>
+        <p:txBody>
+          <a:bodyPr wrap="square">
+            <a:spAutoFit/>
+          </a:bodyPr>
+          <a:lstStyle/>
+          <a:p>
+            <a:pPr algn="l">
+              <a:defRPr sz="1000" b="0">
+                <a:solidFill>
+                  <a:srgbClr val="1F2328"/>
+                </a:solidFill>
+              </a:defRPr>
+            </a:pPr>
+            <a:r>
+              <a:t>Todos los que sirven a acme-chile.cl o módulos M.</a:t>
+            </a:r>
+          </a:p>
+        </p:txBody>
+      </p:sp>
+      <p:sp>
+        <p:nvSpPr>
+          <p:cNvPr id="12" name="Oval 11"/>
+          <p:cNvSpPr/>
+          <p:nvPr/>
+        </p:nvSpPr>
+        <p:spPr>
+          <a:xfrm>
+            <a:off x="548640" y="2084832"/>
+            <a:ext cx="347472" cy="347472"/>
+          </a:xfrm>
+          <a:prstGeom prst="ellipse">
+            <a:avLst/>
+          </a:prstGeom>
+          <a:solidFill>
+            <a:srgbClr val="6F42C1"/>
+          </a:solidFill>
+          <a:ln>
+            <a:noFill/>
+          </a:ln>
+        </p:spPr>
+        <p:style>
+          <a:lnRef idx="1">
+            <a:schemeClr val="accent1"/>
+          </a:lnRef>
+          <a:fillRef idx="3">
+            <a:schemeClr val="accent1"/>
+          </a:fillRef>
+          <a:effectRef idx="2">
+            <a:schemeClr val="accent1"/>
+          </a:effectRef>
+          <a:fontRef idx="minor">
+            <a:schemeClr val="lt1"/>
+          </a:fontRef>
+        </p:style>
+        <p:txBody>
+          <a:bodyPr rtlCol="0" anchor="ctr"/>
+          <a:lstStyle/>
+          <a:p>
+            <a:pPr algn="ctr"/>
+          </a:p>
+        </p:txBody>
+      </p:sp>
+      <p:sp>
+        <p:nvSpPr>
+          <p:cNvPr id="13" name="TextBox 12"/>
+          <p:cNvSpPr txBox="1"/>
+          <p:nvPr/>
+        </p:nvSpPr>
+        <p:spPr>
+          <a:xfrm>
+            <a:off x="548640" y="2121408"/>
+            <a:ext cx="347472" cy="274320"/>
+          </a:xfrm>
+          <a:prstGeom prst="rect">
+            <a:avLst/>
+          </a:prstGeom>
+          <a:noFill/>
+        </p:spPr>
+        <p:txBody>
+          <a:bodyPr wrap="square">
+            <a:spAutoFit/>
+          </a:bodyPr>
+          <a:lstStyle/>
+          <a:p>
+            <a:pPr algn="ctr">
+              <a:defRPr sz="1200" b="1">
+                <a:solidFill>
+                  <a:srgbClr val="FFFFFF"/>
+                </a:solidFill>
+              </a:defRPr>
+            </a:pPr>
+            <a:r>
+              <a:t>2</a:t>
+            </a:r>
+          </a:p>
+        </p:txBody>
+      </p:sp>
+      <p:sp>
+        <p:nvSpPr>
+          <p:cNvPr id="14" name="Rounded Rectangle 13"/>
+          <p:cNvSpPr/>
+          <p:nvPr/>
+        </p:nvSpPr>
+        <p:spPr>
+          <a:xfrm>
+            <a:off x="1005840" y="2048256"/>
+            <a:ext cx="4892040" cy="658368"/>
+          </a:xfrm>
+          <a:prstGeom prst="roundRect">
+            <a:avLst/>
+          </a:prstGeom>
+          <a:solidFill>
+            <a:srgbClr val="FFFFFF"/>
+          </a:solidFill>
+          <a:ln w="12700">
+            <a:solidFill>
+              <a:srgbClr val="6F42C1"/>
+            </a:solidFill>
+          </a:ln>
+        </p:spPr>
+        <p:style>
+          <a:lnRef idx="1">
+            <a:schemeClr val="accent1"/>
+          </a:lnRef>
+          <a:fillRef idx="3">
+            <a:schemeClr val="accent1"/>
+          </a:fillRef>
+          <a:effectRef idx="2">
+            <a:schemeClr val="accent1"/>
+          </a:effectRef>
+          <a:fontRef idx="minor">
+            <a:schemeClr val="lt1"/>
+          </a:fontRef>
+        </p:style>
+        <p:txBody>
+          <a:bodyPr rtlCol="0" anchor="ctr"/>
+          <a:lstStyle/>
+          <a:p>
+            <a:pPr algn="ctr"/>
+          </a:p>
+        </p:txBody>
+      </p:sp>
+      <p:sp>
+        <p:nvSpPr>
+          <p:cNvPr id="15" name="TextBox 14"/>
+          <p:cNvSpPr txBox="1"/>
+          <p:nvPr/>
+        </p:nvSpPr>
+        <p:spPr>
+          <a:xfrm>
+            <a:off x="1143000" y="2103120"/>
+            <a:ext cx="4663440" cy="256032"/>
+          </a:xfrm>
+          <a:prstGeom prst="rect">
+            <a:avLst/>
+          </a:prstGeom>
+          <a:noFill/>
+        </p:spPr>
+        <p:txBody>
+          <a:bodyPr wrap="square">
+            <a:spAutoFit/>
+          </a:bodyPr>
+          <a:lstStyle/>
+          <a:p>
+            <a:pPr algn="l">
+              <a:defRPr sz="1200" b="1">
+                <a:solidFill>
+                  <a:srgbClr val="6F42C1"/>
+                </a:solidFill>
+              </a:defRPr>
+            </a:pPr>
+            <a:r>
+              <a:t>URL de cada webhook</a:t>
+            </a:r>
+          </a:p>
+        </p:txBody>
+      </p:sp>
+      <p:sp>
+        <p:nvSpPr>
+          <p:cNvPr id="16" name="TextBox 15"/>
+          <p:cNvSpPr txBox="1"/>
+          <p:nvPr/>
+        </p:nvSpPr>
+        <p:spPr>
+          <a:xfrm>
+            <a:off x="1143000" y="2340864"/>
+            <a:ext cx="4663440" cy="320040"/>
+          </a:xfrm>
+          <a:prstGeom prst="rect">
+            <a:avLst/>
+          </a:prstGeom>
+          <a:noFill/>
+        </p:spPr>
+        <p:txBody>
+          <a:bodyPr wrap="square">
+            <a:spAutoFit/>
+          </a:bodyPr>
+          <a:lstStyle/>
+          <a:p>
+            <a:pPr algn="l">
+              <a:defRPr sz="1000" b="0">
+                <a:solidFill>
+                  <a:srgbClr val="1F2328"/>
+                </a:solidFill>
+              </a:defRPr>
+            </a:pPr>
+            <a:r>
+              <a:t>Copiar la URL completa del endpoint (producción).</a:t>
+            </a:r>
+          </a:p>
+        </p:txBody>
+      </p:sp>
+      <p:sp>
+        <p:nvSpPr>
+          <p:cNvPr id="17" name="Oval 16"/>
+          <p:cNvSpPr/>
+          <p:nvPr/>
+        </p:nvSpPr>
+        <p:spPr>
+          <a:xfrm>
+            <a:off x="548640" y="2834640"/>
+            <a:ext cx="347472" cy="347472"/>
+          </a:xfrm>
+          <a:prstGeom prst="ellipse">
+            <a:avLst/>
+          </a:prstGeom>
+          <a:solidFill>
+            <a:srgbClr val="6F42C1"/>
+          </a:solidFill>
+          <a:ln>
+            <a:noFill/>
+          </a:ln>
+        </p:spPr>
+        <p:style>
+          <a:lnRef idx="1">
+            <a:schemeClr val="accent1"/>
+          </a:lnRef>
+          <a:fillRef idx="3">
+            <a:schemeClr val="accent1"/>
+          </a:fillRef>
+          <a:effectRef idx="2">
+            <a:schemeClr val="accent1"/>
+          </a:effectRef>
+          <a:fontRef idx="minor">
+            <a:schemeClr val="lt1"/>
+          </a:fontRef>
+        </p:style>
+        <p:txBody>
+          <a:bodyPr rtlCol="0" anchor="ctr"/>
+          <a:lstStyle/>
+          <a:p>
+            <a:pPr algn="ctr"/>
+          </a:p>
+        </p:txBody>
+      </p:sp>
+      <p:sp>
+        <p:nvSpPr>
+          <p:cNvPr id="18" name="TextBox 17"/>
+          <p:cNvSpPr txBox="1"/>
+          <p:nvPr/>
+        </p:nvSpPr>
+        <p:spPr>
+          <a:xfrm>
+            <a:off x="548640" y="2871216"/>
+            <a:ext cx="347472" cy="274320"/>
+          </a:xfrm>
+          <a:prstGeom prst="rect">
+            <a:avLst/>
+          </a:prstGeom>
+          <a:noFill/>
+        </p:spPr>
+        <p:txBody>
+          <a:bodyPr wrap="square">
+            <a:spAutoFit/>
+          </a:bodyPr>
+          <a:lstStyle/>
+          <a:p>
+            <a:pPr algn="ctr">
+              <a:defRPr sz="1200" b="1">
+                <a:solidFill>
+                  <a:srgbClr val="FFFFFF"/>
+                </a:solidFill>
+              </a:defRPr>
+            </a:pPr>
+            <a:r>
+              <a:t>3</a:t>
+            </a:r>
+          </a:p>
+        </p:txBody>
+      </p:sp>
+      <p:sp>
+        <p:nvSpPr>
+          <p:cNvPr id="19" name="Rounded Rectangle 18"/>
+          <p:cNvSpPr/>
+          <p:nvPr/>
+        </p:nvSpPr>
+        <p:spPr>
+          <a:xfrm>
+            <a:off x="1005840" y="2798064"/>
+            <a:ext cx="4892040" cy="658368"/>
+          </a:xfrm>
+          <a:prstGeom prst="roundRect">
+            <a:avLst/>
+          </a:prstGeom>
+          <a:solidFill>
+            <a:srgbClr val="FFFFFF"/>
+          </a:solidFill>
+          <a:ln w="12700">
+            <a:solidFill>
+              <a:srgbClr val="6F42C1"/>
+            </a:solidFill>
+          </a:ln>
+        </p:spPr>
+        <p:style>
+          <a:lnRef idx="1">
+            <a:schemeClr val="accent1"/>
+          </a:lnRef>
+          <a:fillRef idx="3">
+            <a:schemeClr val="accent1"/>
+          </a:fillRef>
+          <a:effectRef idx="2">
+            <a:schemeClr val="accent1"/>
+          </a:effectRef>
+          <a:fontRef idx="minor">
+            <a:schemeClr val="lt1"/>
+          </a:fontRef>
+        </p:style>
+        <p:txBody>
+          <a:bodyPr rtlCol="0" anchor="ctr"/>
+          <a:lstStyle/>
+          <a:p>
+            <a:pPr algn="ctr"/>
+          </a:p>
+        </p:txBody>
+      </p:sp>
+      <p:sp>
+        <p:nvSpPr>
+          <p:cNvPr id="20" name="TextBox 19"/>
+          <p:cNvSpPr txBox="1"/>
+          <p:nvPr/>
+        </p:nvSpPr>
+        <p:spPr>
+          <a:xfrm>
+            <a:off x="1143000" y="2852928"/>
+            <a:ext cx="4663440" cy="256032"/>
+          </a:xfrm>
+          <a:prstGeom prst="rect">
+            <a:avLst/>
+          </a:prstGeom>
+          <a:noFill/>
+        </p:spPr>
+        <p:txBody>
+          <a:bodyPr wrap="square">
+            <a:spAutoFit/>
+          </a:bodyPr>
+          <a:lstStyle/>
+          <a:p>
+            <a:pPr algn="l">
+              <a:defRPr sz="1200" b="1">
+                <a:solidFill>
+                  <a:srgbClr val="6F42C1"/>
+                </a:solidFill>
+              </a:defRPr>
+            </a:pPr>
+            <a:r>
+              <a:t>Módulo que lo usa</a:t>
+            </a:r>
+          </a:p>
+        </p:txBody>
+      </p:sp>
+      <p:sp>
+        <p:nvSpPr>
+          <p:cNvPr id="21" name="TextBox 20"/>
+          <p:cNvSpPr txBox="1"/>
+          <p:nvPr/>
+        </p:nvSpPr>
+        <p:spPr>
+          <a:xfrm>
+            <a:off x="1143000" y="3090672"/>
+            <a:ext cx="4663440" cy="320040"/>
+          </a:xfrm>
+          <a:prstGeom prst="rect">
+            <a:avLst/>
+          </a:prstGeom>
+          <a:noFill/>
+        </p:spPr>
+        <p:txBody>
+          <a:bodyPr wrap="square">
+            <a:spAutoFit/>
+          </a:bodyPr>
+          <a:lstStyle/>
+          <a:p>
+            <a:pPr algn="l">
+              <a:defRPr sz="1000" b="0">
+                <a:solidFill>
+                  <a:srgbClr val="1F2328"/>
+                </a:solidFill>
+              </a:defRPr>
+            </a:pPr>
+            <a:r>
+              <a:t>Portal MOVA, ERP, AXON, RRHH, documentos…</a:t>
+            </a:r>
+          </a:p>
+        </p:txBody>
+      </p:sp>
+      <p:sp>
+        <p:nvSpPr>
+          <p:cNvPr id="22" name="Oval 21"/>
+          <p:cNvSpPr/>
+          <p:nvPr/>
+        </p:nvSpPr>
+        <p:spPr>
+          <a:xfrm>
+            <a:off x="548640" y="3584448"/>
+            <a:ext cx="347472" cy="347472"/>
+          </a:xfrm>
+          <a:prstGeom prst="ellipse">
+            <a:avLst/>
+          </a:prstGeom>
+          <a:solidFill>
+            <a:srgbClr val="6F42C1"/>
+          </a:solidFill>
+          <a:ln>
+            <a:noFill/>
+          </a:ln>
+        </p:spPr>
+        <p:style>
+          <a:lnRef idx="1">
+            <a:schemeClr val="accent1"/>
+          </a:lnRef>
+          <a:fillRef idx="3">
+            <a:schemeClr val="accent1"/>
+          </a:fillRef>
+          <a:effectRef idx="2">
+            <a:schemeClr val="accent1"/>
+          </a:effectRef>
+          <a:fontRef idx="minor">
+            <a:schemeClr val="lt1"/>
+          </a:fontRef>
+        </p:style>
+        <p:txBody>
+          <a:bodyPr rtlCol="0" anchor="ctr"/>
+          <a:lstStyle/>
+          <a:p>
+            <a:pPr algn="ctr"/>
+          </a:p>
+        </p:txBody>
+      </p:sp>
+      <p:sp>
+        <p:nvSpPr>
+          <p:cNvPr id="23" name="TextBox 22"/>
+          <p:cNvSpPr txBox="1"/>
+          <p:nvPr/>
+        </p:nvSpPr>
+        <p:spPr>
+          <a:xfrm>
+            <a:off x="548640" y="3621024"/>
+            <a:ext cx="347472" cy="274320"/>
+          </a:xfrm>
+          <a:prstGeom prst="rect">
+            <a:avLst/>
+          </a:prstGeom>
+          <a:noFill/>
+        </p:spPr>
+        <p:txBody>
+          <a:bodyPr wrap="square">
+            <a:spAutoFit/>
+          </a:bodyPr>
+          <a:lstStyle/>
+          <a:p>
+            <a:pPr algn="ctr">
+              <a:defRPr sz="1200" b="1">
+                <a:solidFill>
+                  <a:srgbClr val="FFFFFF"/>
+                </a:solidFill>
+              </a:defRPr>
+            </a:pPr>
+            <a:r>
+              <a:t>4</a:t>
+            </a:r>
+          </a:p>
+        </p:txBody>
+      </p:sp>
+      <p:sp>
+        <p:nvSpPr>
+          <p:cNvPr id="24" name="Rounded Rectangle 23"/>
+          <p:cNvSpPr/>
+          <p:nvPr/>
+        </p:nvSpPr>
+        <p:spPr>
+          <a:xfrm>
+            <a:off x="1005840" y="3547872"/>
+            <a:ext cx="4892040" cy="658368"/>
+          </a:xfrm>
+          <a:prstGeom prst="roundRect">
+            <a:avLst/>
+          </a:prstGeom>
+          <a:solidFill>
+            <a:srgbClr val="FFFFFF"/>
+          </a:solidFill>
+          <a:ln w="12700">
+            <a:solidFill>
+              <a:srgbClr val="6F42C1"/>
+            </a:solidFill>
+          </a:ln>
+        </p:spPr>
+        <p:style>
+          <a:lnRef idx="1">
+            <a:schemeClr val="accent1"/>
+          </a:lnRef>
+          <a:fillRef idx="3">
+            <a:schemeClr val="accent1"/>
+          </a:fillRef>
+          <a:effectRef idx="2">
+            <a:schemeClr val="accent1"/>
+          </a:effectRef>
+          <a:fontRef idx="minor">
+            <a:schemeClr val="lt1"/>
+          </a:fontRef>
+        </p:style>
+        <p:txBody>
+          <a:bodyPr rtlCol="0" anchor="ctr"/>
+          <a:lstStyle/>
+          <a:p>
+            <a:pPr algn="ctr"/>
+          </a:p>
+        </p:txBody>
+      </p:sp>
+      <p:sp>
+        <p:nvSpPr>
+          <p:cNvPr id="25" name="TextBox 24"/>
+          <p:cNvSpPr txBox="1"/>
+          <p:nvPr/>
+        </p:nvSpPr>
+        <p:spPr>
+          <a:xfrm>
+            <a:off x="1143000" y="3602736"/>
+            <a:ext cx="4663440" cy="256032"/>
+          </a:xfrm>
+          <a:prstGeom prst="rect">
+            <a:avLst/>
+          </a:prstGeom>
+          <a:noFill/>
+        </p:spPr>
+        <p:txBody>
+          <a:bodyPr wrap="square">
+            <a:spAutoFit/>
+          </a:bodyPr>
+          <a:lstStyle/>
+          <a:p>
+            <a:pPr algn="l">
+              <a:defRPr sz="1200" b="1">
+                <a:solidFill>
+                  <a:srgbClr val="6F42C1"/>
+                </a:solidFill>
+              </a:defRPr>
+            </a:pPr>
+            <a:r>
+              <a:t>¿Requiere auth?</a:t>
+            </a:r>
+          </a:p>
+        </p:txBody>
+      </p:sp>
+      <p:sp>
+        <p:nvSpPr>
+          <p:cNvPr id="26" name="TextBox 25"/>
+          <p:cNvSpPr txBox="1"/>
+          <p:nvPr/>
+        </p:nvSpPr>
+        <p:spPr>
+          <a:xfrm>
+            <a:off x="1143000" y="3840480"/>
+            <a:ext cx="4663440" cy="320040"/>
+          </a:xfrm>
+          <a:prstGeom prst="rect">
+            <a:avLst/>
+          </a:prstGeom>
+          <a:noFill/>
+        </p:spPr>
+        <p:txBody>
+          <a:bodyPr wrap="square">
+            <a:spAutoFit/>
+          </a:bodyPr>
+          <a:lstStyle/>
+          <a:p>
+            <a:pPr algn="l">
+              <a:defRPr sz="1000" b="0">
+                <a:solidFill>
+                  <a:srgbClr val="1F2328"/>
+                </a:solidFill>
+              </a:defRPr>
+            </a:pPr>
+            <a:r>
+              <a:t>Token, API key, whitelist Google o sin validación.</a:t>
+            </a:r>
+          </a:p>
+        </p:txBody>
+      </p:sp>
+      <p:sp>
+        <p:nvSpPr>
+          <p:cNvPr id="27" name="Oval 26"/>
+          <p:cNvSpPr/>
+          <p:nvPr/>
+        </p:nvSpPr>
+        <p:spPr>
+          <a:xfrm>
+            <a:off x="548640" y="4334256"/>
+            <a:ext cx="347472" cy="347472"/>
+          </a:xfrm>
+          <a:prstGeom prst="ellipse">
+            <a:avLst/>
+          </a:prstGeom>
+          <a:solidFill>
+            <a:srgbClr val="6F42C1"/>
+          </a:solidFill>
+          <a:ln>
+            <a:noFill/>
+          </a:ln>
+        </p:spPr>
+        <p:style>
+          <a:lnRef idx="1">
+            <a:schemeClr val="accent1"/>
+          </a:lnRef>
+          <a:fillRef idx="3">
+            <a:schemeClr val="accent1"/>
+          </a:fillRef>
+          <a:effectRef idx="2">
+            <a:schemeClr val="accent1"/>
+          </a:effectRef>
+          <a:fontRef idx="minor">
+            <a:schemeClr val="lt1"/>
+          </a:fontRef>
+        </p:style>
+        <p:txBody>
+          <a:bodyPr rtlCol="0" anchor="ctr"/>
+          <a:lstStyle/>
+          <a:p>
+            <a:pPr algn="ctr"/>
+          </a:p>
+        </p:txBody>
+      </p:sp>
+      <p:sp>
+        <p:nvSpPr>
+          <p:cNvPr id="28" name="TextBox 27"/>
+          <p:cNvSpPr txBox="1"/>
+          <p:nvPr/>
+        </p:nvSpPr>
+        <p:spPr>
+          <a:xfrm>
+            <a:off x="548640" y="4370832"/>
+            <a:ext cx="347472" cy="274320"/>
+          </a:xfrm>
+          <a:prstGeom prst="rect">
+            <a:avLst/>
+          </a:prstGeom>
+          <a:noFill/>
+        </p:spPr>
+        <p:txBody>
+          <a:bodyPr wrap="square">
+            <a:spAutoFit/>
+          </a:bodyPr>
+          <a:lstStyle/>
+          <a:p>
+            <a:pPr algn="ctr">
+              <a:defRPr sz="1200" b="1">
+                <a:solidFill>
+                  <a:srgbClr val="FFFFFF"/>
+                </a:solidFill>
+              </a:defRPr>
+            </a:pPr>
+            <a:r>
+              <a:t>5</a:t>
+            </a:r>
+          </a:p>
+        </p:txBody>
+      </p:sp>
+      <p:sp>
+        <p:nvSpPr>
+          <p:cNvPr id="29" name="Rounded Rectangle 28"/>
+          <p:cNvSpPr/>
+          <p:nvPr/>
+        </p:nvSpPr>
+        <p:spPr>
+          <a:xfrm>
+            <a:off x="1005840" y="4297680"/>
+            <a:ext cx="4892040" cy="658368"/>
+          </a:xfrm>
+          <a:prstGeom prst="roundRect">
+            <a:avLst/>
+          </a:prstGeom>
+          <a:solidFill>
+            <a:srgbClr val="FFFFFF"/>
+          </a:solidFill>
+          <a:ln w="12700">
+            <a:solidFill>
+              <a:srgbClr val="6F42C1"/>
+            </a:solidFill>
+          </a:ln>
+        </p:spPr>
+        <p:style>
+          <a:lnRef idx="1">
+            <a:schemeClr val="accent1"/>
+          </a:lnRef>
+          <a:fillRef idx="3">
+            <a:schemeClr val="accent1"/>
+          </a:fillRef>
+          <a:effectRef idx="2">
+            <a:schemeClr val="accent1"/>
+          </a:effectRef>
+          <a:fontRef idx="minor">
+            <a:schemeClr val="lt1"/>
+          </a:fontRef>
+        </p:style>
+        <p:txBody>
+          <a:bodyPr rtlCol="0" anchor="ctr"/>
+          <a:lstStyle/>
+          <a:p>
+            <a:pPr algn="ctr"/>
+          </a:p>
+        </p:txBody>
+      </p:sp>
+      <p:sp>
+        <p:nvSpPr>
+          <p:cNvPr id="30" name="TextBox 29"/>
+          <p:cNvSpPr txBox="1"/>
+          <p:nvPr/>
+        </p:nvSpPr>
+        <p:spPr>
+          <a:xfrm>
+            <a:off x="1143000" y="4352544"/>
+            <a:ext cx="4663440" cy="256032"/>
+          </a:xfrm>
+          <a:prstGeom prst="rect">
+            <a:avLst/>
+          </a:prstGeom>
+          <a:noFill/>
+        </p:spPr>
+        <p:txBody>
+          <a:bodyPr wrap="square">
+            <a:spAutoFit/>
+          </a:bodyPr>
+          <a:lstStyle/>
+          <a:p>
+            <a:pPr algn="l">
+              <a:defRPr sz="1200" b="1">
+                <a:solidFill>
+                  <a:srgbClr val="6F42C1"/>
+                </a:solidFill>
+              </a:defRPr>
+            </a:pPr>
+            <a:r>
+              <a:t>Enviar tabla a MOVA</a:t>
+            </a:r>
+          </a:p>
+        </p:txBody>
+      </p:sp>
+      <p:sp>
+        <p:nvSpPr>
+          <p:cNvPr id="31" name="TextBox 30"/>
+          <p:cNvSpPr txBox="1"/>
+          <p:nvPr/>
+        </p:nvSpPr>
+        <p:spPr>
+          <a:xfrm>
+            <a:off x="1143000" y="4590288"/>
+            <a:ext cx="4663440" cy="320040"/>
+          </a:xfrm>
+          <a:prstGeom prst="rect">
+            <a:avLst/>
+          </a:prstGeom>
+          <a:noFill/>
+        </p:spPr>
+        <p:txBody>
+          <a:bodyPr wrap="square">
+            <a:spAutoFit/>
+          </a:bodyPr>
+          <a:lstStyle/>
+          <a:p>
+            <a:pPr algn="l">
+              <a:defRPr sz="1000" b="0">
+                <a:solidFill>
+                  <a:srgbClr val="1F2328"/>
+                </a:solidFill>
+              </a:defRPr>
+            </a:pPr>
+            <a:r>
+              <a:t>Correo o carpeta compartida con el equipo técnico.</a:t>
+            </a:r>
+          </a:p>
+        </p:txBody>
+      </p:sp>
+      <p:sp>
+        <p:nvSpPr>
+          <p:cNvPr id="32" name="Rounded Rectangle 31"/>
+          <p:cNvSpPr/>
+          <p:nvPr/>
+        </p:nvSpPr>
+        <p:spPr>
+          <a:xfrm>
+            <a:off x="6172200" y="1298448"/>
+            <a:ext cx="5532120" cy="4434840"/>
+          </a:xfrm>
+          <a:prstGeom prst="roundRect">
+            <a:avLst/>
+          </a:prstGeom>
+          <a:solidFill>
+            <a:srgbClr val="E8E0F8"/>
+          </a:solidFill>
+          <a:ln w="25400">
+            <a:solidFill>
+              <a:srgbClr val="6F42C1"/>
+            </a:solidFill>
+          </a:ln>
+        </p:spPr>
+        <p:style>
+          <a:lnRef idx="1">
+            <a:schemeClr val="accent1"/>
+          </a:lnRef>
+          <a:fillRef idx="3">
+            <a:schemeClr val="accent1"/>
+          </a:fillRef>
+          <a:effectRef idx="2">
+            <a:schemeClr val="accent1"/>
+          </a:effectRef>
+          <a:fontRef idx="minor">
+            <a:schemeClr val="lt1"/>
+          </a:fontRef>
+        </p:style>
+        <p:txBody>
+          <a:bodyPr rtlCol="0" anchor="ctr"/>
+          <a:lstStyle/>
+          <a:p>
+            <a:pPr algn="ctr"/>
+          </a:p>
+        </p:txBody>
+      </p:sp>
+      <p:sp>
+        <p:nvSpPr>
+          <p:cNvPr id="33" name="TextBox 32"/>
+          <p:cNvSpPr txBox="1"/>
+          <p:nvPr/>
+        </p:nvSpPr>
+        <p:spPr>
+          <a:xfrm>
+            <a:off x="6355080" y="1417320"/>
+            <a:ext cx="5120640" cy="274320"/>
+          </a:xfrm>
+          <a:prstGeom prst="rect">
+            <a:avLst/>
+          </a:prstGeom>
+          <a:noFill/>
+        </p:spPr>
+        <p:txBody>
+          <a:bodyPr wrap="square">
+            <a:spAutoFit/>
+          </a:bodyPr>
+          <a:lstStyle/>
+          <a:p>
+            <a:pPr algn="l">
+              <a:defRPr sz="1300" b="1">
+                <a:solidFill>
+                  <a:srgbClr val="6F42C1"/>
+                </a:solidFill>
+              </a:defRPr>
+            </a:pPr>
+            <a:r>
+              <a:t>Flujo visual</a:t>
+            </a:r>
+          </a:p>
+        </p:txBody>
+      </p:sp>
+      <p:sp>
+        <p:nvSpPr>
+          <p:cNvPr id="34" name="Rounded Rectangle 33"/>
+          <p:cNvSpPr/>
+          <p:nvPr/>
+        </p:nvSpPr>
+        <p:spPr>
+          <a:xfrm>
+            <a:off x="6400800" y="1828800"/>
+            <a:ext cx="868680" cy="411480"/>
+          </a:xfrm>
+          <a:prstGeom prst="roundRect">
+            <a:avLst/>
+          </a:prstGeom>
+          <a:solidFill>
+            <a:srgbClr val="FFFFFF"/>
+          </a:solidFill>
+          <a:ln w="12700">
+            <a:solidFill>
+              <a:srgbClr val="4A7A80"/>
+            </a:solidFill>
+          </a:ln>
+        </p:spPr>
+        <p:style>
+          <a:lnRef idx="1">
+            <a:schemeClr val="accent1"/>
+          </a:lnRef>
+          <a:fillRef idx="3">
+            <a:schemeClr val="accent1"/>
+          </a:fillRef>
+          <a:effectRef idx="2">
+            <a:schemeClr val="accent1"/>
+          </a:effectRef>
+          <a:fontRef idx="minor">
+            <a:schemeClr val="lt1"/>
+          </a:fontRef>
+        </p:style>
+        <p:txBody>
+          <a:bodyPr rtlCol="0" anchor="ctr"/>
+          <a:lstStyle/>
+          <a:p>
+            <a:pPr algn="ctr"/>
+          </a:p>
+        </p:txBody>
+      </p:sp>
+      <p:sp>
+        <p:nvSpPr>
+          <p:cNvPr id="35" name="TextBox 34"/>
+          <p:cNvSpPr txBox="1"/>
+          <p:nvPr/>
+        </p:nvSpPr>
+        <p:spPr>
+          <a:xfrm>
+            <a:off x="6400800" y="1901952"/>
+            <a:ext cx="868680" cy="274320"/>
+          </a:xfrm>
+          <a:prstGeom prst="rect">
+            <a:avLst/>
+          </a:prstGeom>
+          <a:noFill/>
+        </p:spPr>
+        <p:txBody>
+          <a:bodyPr wrap="square">
+            <a:spAutoFit/>
+          </a:bodyPr>
+          <a:lstStyle/>
+          <a:p>
+            <a:pPr algn="ctr">
+              <a:defRPr sz="900" b="1">
+                <a:solidFill>
+                  <a:srgbClr val="2A4A4E"/>
+                </a:solidFill>
+              </a:defRPr>
+            </a:pPr>
+            <a:r>
+              <a:t>Portal</a:t>
+            </a:r>
+          </a:p>
+        </p:txBody>
+      </p:sp>
+      <p:sp>
+        <p:nvSpPr>
+          <p:cNvPr id="36" name="Rounded Rectangle 35"/>
+          <p:cNvSpPr/>
+          <p:nvPr/>
+        </p:nvSpPr>
+        <p:spPr>
+          <a:xfrm>
+            <a:off x="7452360" y="1828800"/>
+            <a:ext cx="868680" cy="411480"/>
+          </a:xfrm>
+          <a:prstGeom prst="roundRect">
+            <a:avLst/>
+          </a:prstGeom>
+          <a:solidFill>
+            <a:srgbClr val="FFFFFF"/>
+          </a:solidFill>
+          <a:ln w="12700">
+            <a:solidFill>
+              <a:srgbClr val="4A7A80"/>
+            </a:solidFill>
+          </a:ln>
+        </p:spPr>
+        <p:style>
+          <a:lnRef idx="1">
+            <a:schemeClr val="accent1"/>
+          </a:lnRef>
+          <a:fillRef idx="3">
+            <a:schemeClr val="accent1"/>
+          </a:fillRef>
+          <a:effectRef idx="2">
+            <a:schemeClr val="accent1"/>
+          </a:effectRef>
+          <a:fontRef idx="minor">
+            <a:schemeClr val="lt1"/>
+          </a:fontRef>
+        </p:style>
+        <p:txBody>
+          <a:bodyPr rtlCol="0" anchor="ctr"/>
+          <a:lstStyle/>
+          <a:p>
+            <a:pPr algn="ctr"/>
+          </a:p>
+        </p:txBody>
+      </p:sp>
+      <p:sp>
+        <p:nvSpPr>
+          <p:cNvPr id="37" name="TextBox 36"/>
+          <p:cNvSpPr txBox="1"/>
+          <p:nvPr/>
+        </p:nvSpPr>
+        <p:spPr>
+          <a:xfrm>
+            <a:off x="7452360" y="1901952"/>
+            <a:ext cx="868680" cy="274320"/>
+          </a:xfrm>
+          <a:prstGeom prst="rect">
+            <a:avLst/>
+          </a:prstGeom>
+          <a:noFill/>
+        </p:spPr>
+        <p:txBody>
+          <a:bodyPr wrap="square">
+            <a:spAutoFit/>
+          </a:bodyPr>
+          <a:lstStyle/>
+          <a:p>
+            <a:pPr algn="ctr">
+              <a:defRPr sz="900" b="1">
+                <a:solidFill>
+                  <a:srgbClr val="2A4A4E"/>
+                </a:solidFill>
+              </a:defRPr>
+            </a:pPr>
+            <a:r>
+              <a:t>ERP</a:t>
+            </a:r>
+          </a:p>
+        </p:txBody>
+      </p:sp>
+      <p:sp>
+        <p:nvSpPr>
+          <p:cNvPr id="38" name="Rounded Rectangle 37"/>
+          <p:cNvSpPr/>
+          <p:nvPr/>
+        </p:nvSpPr>
+        <p:spPr>
+          <a:xfrm>
+            <a:off x="8503920" y="1828800"/>
+            <a:ext cx="868680" cy="411480"/>
+          </a:xfrm>
+          <a:prstGeom prst="roundRect">
+            <a:avLst/>
+          </a:prstGeom>
+          <a:solidFill>
+            <a:srgbClr val="FFFFFF"/>
+          </a:solidFill>
+          <a:ln w="12700">
+            <a:solidFill>
+              <a:srgbClr val="4A7A80"/>
+            </a:solidFill>
+          </a:ln>
+        </p:spPr>
+        <p:style>
+          <a:lnRef idx="1">
+            <a:schemeClr val="accent1"/>
+          </a:lnRef>
+          <a:fillRef idx="3">
+            <a:schemeClr val="accent1"/>
+          </a:fillRef>
+          <a:effectRef idx="2">
+            <a:schemeClr val="accent1"/>
+          </a:effectRef>
+          <a:fontRef idx="minor">
+            <a:schemeClr val="lt1"/>
+          </a:fontRef>
+        </p:style>
+        <p:txBody>
+          <a:bodyPr rtlCol="0" anchor="ctr"/>
+          <a:lstStyle/>
+          <a:p>
+            <a:pPr algn="ctr"/>
+          </a:p>
+        </p:txBody>
+      </p:sp>
+      <p:sp>
+        <p:nvSpPr>
+          <p:cNvPr id="39" name="TextBox 38"/>
+          <p:cNvSpPr txBox="1"/>
+          <p:nvPr/>
+        </p:nvSpPr>
+        <p:spPr>
+          <a:xfrm>
+            <a:off x="8503920" y="1901952"/>
+            <a:ext cx="868680" cy="274320"/>
+          </a:xfrm>
+          <a:prstGeom prst="rect">
+            <a:avLst/>
+          </a:prstGeom>
+          <a:noFill/>
+        </p:spPr>
+        <p:txBody>
+          <a:bodyPr wrap="square">
+            <a:spAutoFit/>
+          </a:bodyPr>
+          <a:lstStyle/>
+          <a:p>
+            <a:pPr algn="ctr">
+              <a:defRPr sz="900" b="1">
+                <a:solidFill>
+                  <a:srgbClr val="2A4A4E"/>
+                </a:solidFill>
+              </a:defRPr>
+            </a:pPr>
+            <a:r>
+              <a:t>AXON</a:t>
+            </a:r>
+          </a:p>
+        </p:txBody>
+      </p:sp>
+      <p:sp>
+        <p:nvSpPr>
+          <p:cNvPr id="40" name="Rounded Rectangle 39"/>
+          <p:cNvSpPr/>
+          <p:nvPr/>
+        </p:nvSpPr>
+        <p:spPr>
+          <a:xfrm>
+            <a:off x="7315200" y="2514600"/>
+            <a:ext cx="3200400" cy="594360"/>
+          </a:xfrm>
+          <a:prstGeom prst="roundRect">
+            <a:avLst/>
+          </a:prstGeom>
+          <a:solidFill>
+            <a:srgbClr val="6F42C1"/>
+          </a:solidFill>
+          <a:ln>
+            <a:noFill/>
+          </a:ln>
+        </p:spPr>
+        <p:style>
+          <a:lnRef idx="1">
+            <a:schemeClr val="accent1"/>
+          </a:lnRef>
+          <a:fillRef idx="3">
+            <a:schemeClr val="accent1"/>
+          </a:fillRef>
+          <a:effectRef idx="2">
+            <a:schemeClr val="accent1"/>
+          </a:effectRef>
+          <a:fontRef idx="minor">
+            <a:schemeClr val="lt1"/>
+          </a:fontRef>
+        </p:style>
+        <p:txBody>
+          <a:bodyPr rtlCol="0" anchor="ctr"/>
+          <a:lstStyle/>
+          <a:p>
+            <a:pPr algn="ctr"/>
+          </a:p>
+        </p:txBody>
+      </p:sp>
+      <p:sp>
+        <p:nvSpPr>
+          <p:cNvPr id="41" name="TextBox 40"/>
+          <p:cNvSpPr txBox="1"/>
+          <p:nvPr/>
+        </p:nvSpPr>
+        <p:spPr>
+          <a:xfrm>
+            <a:off x="7315200" y="2651760"/>
+            <a:ext cx="3200400" cy="320040"/>
+          </a:xfrm>
+          <a:prstGeom prst="rect">
+            <a:avLst/>
+          </a:prstGeom>
+          <a:noFill/>
+        </p:spPr>
+        <p:txBody>
+          <a:bodyPr wrap="square">
+            <a:spAutoFit/>
+          </a:bodyPr>
+          <a:lstStyle/>
+          <a:p>
+            <a:pPr algn="ctr">
+              <a:defRPr sz="1400" b="1">
+                <a:solidFill>
+                  <a:srgbClr val="FFFFFF"/>
+                </a:solidFill>
+              </a:defRPr>
+            </a:pPr>
+            <a:r>
+              <a:t>n8n · webhooks</a:t>
+            </a:r>
+          </a:p>
+        </p:txBody>
+      </p:sp>
+      <p:cxnSp>
+        <p:nvCxnSpPr>
+          <p:cNvPr id="42" name="Connector 41"/>
+          <p:cNvCxnSpPr/>
+          <p:nvPr/>
+        </p:nvCxnSpPr>
+        <p:spPr>
+          <a:xfrm>
+            <a:off x="7242048" y="2240280"/>
+            <a:ext cx="1673352" cy="274320"/>
+          </a:xfrm>
+          <a:prstGeom prst="line">
+            <a:avLst/>
+          </a:prstGeom>
+          <a:ln w="19050">
+            <a:solidFill>
+              <a:srgbClr val="6F42C1"/>
+            </a:solidFill>
+          </a:ln>
+        </p:spPr>
+        <p:style>
+          <a:lnRef idx="2">
+            <a:schemeClr val="accent1"/>
+          </a:lnRef>
+          <a:fillRef idx="0">
+            <a:schemeClr val="accent1"/>
+          </a:fillRef>
+          <a:effectRef idx="1">
+            <a:schemeClr val="accent1"/>
+          </a:effectRef>
+          <a:fontRef idx="minor">
+            <a:schemeClr val="tx1"/>
+          </a:fontRef>
+        </p:style>
+      </p:cxnSp>
+      <p:cxnSp>
+        <p:nvCxnSpPr>
+          <p:cNvPr id="43" name="Connector 42"/>
+          <p:cNvCxnSpPr/>
+          <p:nvPr/>
+        </p:nvCxnSpPr>
+        <p:spPr>
+          <a:xfrm>
+            <a:off x="8293608" y="2240280"/>
+            <a:ext cx="621792" cy="274320"/>
+          </a:xfrm>
+          <a:prstGeom prst="line">
+            <a:avLst/>
+          </a:prstGeom>
+          <a:ln w="19050">
+            <a:solidFill>
+              <a:srgbClr val="6F42C1"/>
+            </a:solidFill>
+          </a:ln>
+        </p:spPr>
+        <p:style>
+          <a:lnRef idx="2">
+            <a:schemeClr val="accent1"/>
+          </a:lnRef>
+          <a:fillRef idx="0">
+            <a:schemeClr val="accent1"/>
+          </a:fillRef>
+          <a:effectRef idx="1">
+            <a:schemeClr val="accent1"/>
+          </a:effectRef>
+          <a:fontRef idx="minor">
+            <a:schemeClr val="tx1"/>
+          </a:fontRef>
+        </p:style>
+      </p:cxnSp>
+      <p:cxnSp>
+        <p:nvCxnSpPr>
+          <p:cNvPr id="44" name="Connector 43"/>
+          <p:cNvCxnSpPr/>
+          <p:nvPr/>
+        </p:nvCxnSpPr>
+        <p:spPr>
+          <a:xfrm flipH="1">
+            <a:off x="8915400" y="2240280"/>
+            <a:ext cx="429768" cy="274320"/>
+          </a:xfrm>
+          <a:prstGeom prst="line">
+            <a:avLst/>
+          </a:prstGeom>
+          <a:ln w="19050">
+            <a:solidFill>
+              <a:srgbClr val="6F42C1"/>
+            </a:solidFill>
+          </a:ln>
+        </p:spPr>
+        <p:style>
+          <a:lnRef idx="2">
+            <a:schemeClr val="accent1"/>
+          </a:lnRef>
+          <a:fillRef idx="0">
+            <a:schemeClr val="accent1"/>
+          </a:fillRef>
+          <a:effectRef idx="1">
+            <a:schemeClr val="accent1"/>
+          </a:effectRef>
+          <a:fontRef idx="minor">
+            <a:schemeClr val="tx1"/>
+          </a:fontRef>
+        </p:style>
+      </p:cxnSp>
+      <p:sp>
+        <p:nvSpPr>
+          <p:cNvPr id="45" name="Down Arrow 44"/>
+          <p:cNvSpPr/>
+          <p:nvPr/>
+        </p:nvSpPr>
+        <p:spPr>
+          <a:xfrm>
+            <a:off x="8732520" y="3200400"/>
+            <a:ext cx="320040" cy="320040"/>
+          </a:xfrm>
+          <a:prstGeom prst="downArrow">
+            <a:avLst/>
+          </a:prstGeom>
+          <a:solidFill>
+            <a:srgbClr val="6F42C1"/>
+          </a:solidFill>
+          <a:ln>
+            <a:noFill/>
+          </a:ln>
+        </p:spPr>
+        <p:style>
+          <a:lnRef idx="1">
+            <a:schemeClr val="accent1"/>
+          </a:lnRef>
+          <a:fillRef idx="3">
+            <a:schemeClr val="accent1"/>
+          </a:fillRef>
+          <a:effectRef idx="2">
+            <a:schemeClr val="accent1"/>
+          </a:effectRef>
+          <a:fontRef idx="minor">
+            <a:schemeClr val="lt1"/>
+          </a:fontRef>
+        </p:style>
+        <p:txBody>
+          <a:bodyPr rtlCol="0" anchor="ctr"/>
+          <a:lstStyle/>
+          <a:p>
+            <a:pPr algn="ctr"/>
+          </a:p>
+        </p:txBody>
+      </p:sp>
+      <p:sp>
+        <p:nvSpPr>
+          <p:cNvPr id="46" name="Rounded Rectangle 45"/>
+          <p:cNvSpPr/>
+          <p:nvPr/>
+        </p:nvSpPr>
+        <p:spPr>
+          <a:xfrm>
+            <a:off x="7178040" y="3611880"/>
+            <a:ext cx="3474720" cy="457200"/>
+          </a:xfrm>
+          <a:prstGeom prst="roundRect">
+            <a:avLst/>
+          </a:prstGeom>
+          <a:solidFill>
+            <a:srgbClr val="FFFFFF"/>
+          </a:solidFill>
+          <a:ln w="12700">
+            <a:solidFill>
+              <a:srgbClr val="6F42C1"/>
+            </a:solidFill>
+          </a:ln>
+        </p:spPr>
+        <p:style>
+          <a:lnRef idx="1">
+            <a:schemeClr val="accent1"/>
+          </a:lnRef>
+          <a:fillRef idx="3">
+            <a:schemeClr val="accent1"/>
+          </a:fillRef>
+          <a:effectRef idx="2">
+            <a:schemeClr val="accent1"/>
+          </a:effectRef>
+          <a:fontRef idx="minor">
+            <a:schemeClr val="lt1"/>
+          </a:fontRef>
+        </p:style>
+        <p:txBody>
+          <a:bodyPr rtlCol="0" anchor="ctr"/>
+          <a:lstStyle/>
+          <a:p>
+            <a:pPr algn="ctr"/>
+          </a:p>
+        </p:txBody>
+      </p:sp>
+      <p:sp>
+        <p:nvSpPr>
+          <p:cNvPr id="47" name="TextBox 46"/>
+          <p:cNvSpPr txBox="1"/>
+          <p:nvPr/>
+        </p:nvSpPr>
+        <p:spPr>
+          <a:xfrm>
+            <a:off x="7178040" y="3703320"/>
+            <a:ext cx="3474720" cy="274320"/>
+          </a:xfrm>
+          <a:prstGeom prst="rect">
+            <a:avLst/>
+          </a:prstGeom>
+          <a:noFill/>
+        </p:spPr>
+        <p:txBody>
+          <a:bodyPr wrap="square">
+            <a:spAutoFit/>
+          </a:bodyPr>
+          <a:lstStyle/>
+          <a:p>
+            <a:pPr algn="ctr">
+              <a:defRPr sz="1000" b="1">
+                <a:solidFill>
+                  <a:srgbClr val="6F42C1"/>
+                </a:solidFill>
+              </a:defRPr>
+            </a:pPr>
+            <a:r>
+              <a:t>Respuesta al módulo (datos / validación)</a:t>
+            </a:r>
+          </a:p>
+        </p:txBody>
+      </p:sp>
+      <p:sp>
+        <p:nvSpPr>
+          <p:cNvPr id="48" name="TextBox 47"/>
+          <p:cNvSpPr txBox="1"/>
+          <p:nvPr/>
+        </p:nvSpPr>
+        <p:spPr>
+          <a:xfrm>
+            <a:off x="6355080" y="4251960"/>
+            <a:ext cx="5120640" cy="256032"/>
+          </a:xfrm>
+          <a:prstGeom prst="rect">
+            <a:avLst/>
+          </a:prstGeom>
+          <a:noFill/>
+        </p:spPr>
+        <p:txBody>
+          <a:bodyPr wrap="square">
+            <a:spAutoFit/>
+          </a:bodyPr>
+          <a:lstStyle/>
+          <a:p>
+            <a:pPr algn="l">
+              <a:defRPr sz="1100" b="1">
+                <a:solidFill>
+                  <a:srgbClr val="6F42C1"/>
+                </a:solidFill>
+              </a:defRPr>
+            </a:pPr>
+            <a:r>
+              <a:t>Plantilla a completar</a:t>
+            </a:r>
+          </a:p>
+        </p:txBody>
+      </p:sp>
+      <p:sp>
+        <p:nvSpPr>
+          <p:cNvPr id="49" name="Rounded Rectangle 48"/>
+          <p:cNvSpPr/>
+          <p:nvPr/>
+        </p:nvSpPr>
+        <p:spPr>
+          <a:xfrm>
+            <a:off x="6355080" y="4572000"/>
+            <a:ext cx="914400" cy="292608"/>
+          </a:xfrm>
+          <a:prstGeom prst="roundRect">
+            <a:avLst/>
+          </a:prstGeom>
+          <a:solidFill>
+            <a:srgbClr val="6F42C1"/>
+          </a:solidFill>
+          <a:ln w="12700">
+            <a:solidFill>
+              <a:srgbClr val="6F42C1"/>
+            </a:solidFill>
+          </a:ln>
+        </p:spPr>
+        <p:style>
+          <a:lnRef idx="1">
+            <a:schemeClr val="accent1"/>
+          </a:lnRef>
+          <a:fillRef idx="3">
+            <a:schemeClr val="accent1"/>
+          </a:fillRef>
+          <a:effectRef idx="2">
+            <a:schemeClr val="accent1"/>
+          </a:effectRef>
+          <a:fontRef idx="minor">
+            <a:schemeClr val="lt1"/>
+          </a:fontRef>
+        </p:style>
+        <p:txBody>
+          <a:bodyPr rtlCol="0" anchor="ctr"/>
+          <a:lstStyle/>
+          <a:p>
+            <a:pPr algn="ctr"/>
+          </a:p>
+        </p:txBody>
+      </p:sp>
+      <p:sp>
+        <p:nvSpPr>
+          <p:cNvPr id="50" name="TextBox 49"/>
+          <p:cNvSpPr txBox="1"/>
+          <p:nvPr/>
+        </p:nvSpPr>
+        <p:spPr>
+          <a:xfrm>
+            <a:off x="6355080" y="4608576"/>
+            <a:ext cx="914400" cy="228600"/>
+          </a:xfrm>
+          <a:prstGeom prst="rect">
+            <a:avLst/>
+          </a:prstGeom>
+          <a:noFill/>
+        </p:spPr>
+        <p:txBody>
+          <a:bodyPr wrap="square">
+            <a:spAutoFit/>
+          </a:bodyPr>
+          <a:lstStyle/>
+          <a:p>
+            <a:pPr algn="ctr">
+              <a:defRPr sz="700" b="1">
+                <a:solidFill>
+                  <a:srgbClr val="FFFFFF"/>
+                </a:solidFill>
+              </a:defRPr>
+            </a:pPr>
+            <a:r>
+              <a:t>Webhook URL</a:t>
+            </a:r>
+          </a:p>
+        </p:txBody>
+      </p:sp>
+      <p:sp>
+        <p:nvSpPr>
+          <p:cNvPr id="51" name="Rounded Rectangle 50"/>
+          <p:cNvSpPr/>
+          <p:nvPr/>
+        </p:nvSpPr>
+        <p:spPr>
+          <a:xfrm>
+            <a:off x="8275320" y="4572000"/>
+            <a:ext cx="914400" cy="292608"/>
+          </a:xfrm>
+          <a:prstGeom prst="roundRect">
+            <a:avLst/>
+          </a:prstGeom>
+          <a:solidFill>
+            <a:srgbClr val="6F42C1"/>
+          </a:solidFill>
+          <a:ln w="12700">
+            <a:solidFill>
+              <a:srgbClr val="6F42C1"/>
+            </a:solidFill>
+          </a:ln>
+        </p:spPr>
+        <p:style>
+          <a:lnRef idx="1">
+            <a:schemeClr val="accent1"/>
+          </a:lnRef>
+          <a:fillRef idx="3">
+            <a:schemeClr val="accent1"/>
+          </a:fillRef>
+          <a:effectRef idx="2">
+            <a:schemeClr val="accent1"/>
+          </a:effectRef>
+          <a:fontRef idx="minor">
+            <a:schemeClr val="lt1"/>
+          </a:fontRef>
+        </p:style>
+        <p:txBody>
+          <a:bodyPr rtlCol="0" anchor="ctr"/>
+          <a:lstStyle/>
+          <a:p>
+            <a:pPr algn="ctr"/>
+          </a:p>
+        </p:txBody>
+      </p:sp>
+      <p:sp>
+        <p:nvSpPr>
+          <p:cNvPr id="52" name="TextBox 51"/>
+          <p:cNvSpPr txBox="1"/>
+          <p:nvPr/>
+        </p:nvSpPr>
+        <p:spPr>
+          <a:xfrm>
+            <a:off x="8275320" y="4608576"/>
+            <a:ext cx="914400" cy="228600"/>
+          </a:xfrm>
+          <a:prstGeom prst="rect">
+            <a:avLst/>
+          </a:prstGeom>
+          <a:noFill/>
+        </p:spPr>
+        <p:txBody>
+          <a:bodyPr wrap="square">
+            <a:spAutoFit/>
+          </a:bodyPr>
+          <a:lstStyle/>
+          <a:p>
+            <a:pPr algn="ctr">
+              <a:defRPr sz="700" b="1">
+                <a:solidFill>
+                  <a:srgbClr val="FFFFFF"/>
+                </a:solidFill>
+              </a:defRPr>
+            </a:pPr>
+            <a:r>
+              <a:t>Módulo</a:t>
+            </a:r>
+          </a:p>
+        </p:txBody>
+      </p:sp>
+      <p:sp>
+        <p:nvSpPr>
+          <p:cNvPr id="53" name="Rounded Rectangle 52"/>
+          <p:cNvSpPr/>
+          <p:nvPr/>
+        </p:nvSpPr>
+        <p:spPr>
+          <a:xfrm>
+            <a:off x="9464040" y="4572000"/>
+            <a:ext cx="914400" cy="292608"/>
+          </a:xfrm>
+          <a:prstGeom prst="roundRect">
+            <a:avLst/>
+          </a:prstGeom>
+          <a:solidFill>
+            <a:srgbClr val="6F42C1"/>
+          </a:solidFill>
+          <a:ln w="12700">
+            <a:solidFill>
+              <a:srgbClr val="6F42C1"/>
+            </a:solidFill>
+          </a:ln>
+        </p:spPr>
+        <p:style>
+          <a:lnRef idx="1">
+            <a:schemeClr val="accent1"/>
+          </a:lnRef>
+          <a:fillRef idx="3">
+            <a:schemeClr val="accent1"/>
+          </a:fillRef>
+          <a:effectRef idx="2">
+            <a:schemeClr val="accent1"/>
+          </a:effectRef>
+          <a:fontRef idx="minor">
+            <a:schemeClr val="lt1"/>
+          </a:fontRef>
+        </p:style>
+        <p:txBody>
+          <a:bodyPr rtlCol="0" anchor="ctr"/>
+          <a:lstStyle/>
+          <a:p>
+            <a:pPr algn="ctr"/>
+          </a:p>
+        </p:txBody>
+      </p:sp>
+      <p:sp>
+        <p:nvSpPr>
+          <p:cNvPr id="54" name="TextBox 53"/>
+          <p:cNvSpPr txBox="1"/>
+          <p:nvPr/>
+        </p:nvSpPr>
+        <p:spPr>
+          <a:xfrm>
+            <a:off x="9464040" y="4608576"/>
+            <a:ext cx="914400" cy="228600"/>
+          </a:xfrm>
+          <a:prstGeom prst="rect">
+            <a:avLst/>
+          </a:prstGeom>
+          <a:noFill/>
+        </p:spPr>
+        <p:txBody>
+          <a:bodyPr wrap="square">
+            <a:spAutoFit/>
+          </a:bodyPr>
+          <a:lstStyle/>
+          <a:p>
+            <a:pPr algn="ctr">
+              <a:defRPr sz="700" b="1">
+                <a:solidFill>
+                  <a:srgbClr val="FFFFFF"/>
+                </a:solidFill>
+              </a:defRPr>
+            </a:pPr>
+            <a:r>
+              <a:t>Auth</a:t>
+            </a:r>
+          </a:p>
+        </p:txBody>
+      </p:sp>
+      <p:sp>
+        <p:nvSpPr>
+          <p:cNvPr id="55" name="Rounded Rectangle 54"/>
+          <p:cNvSpPr/>
+          <p:nvPr/>
+        </p:nvSpPr>
+        <p:spPr>
+          <a:xfrm>
+            <a:off x="10378440" y="4572000"/>
+            <a:ext cx="1234440" cy="292608"/>
+          </a:xfrm>
+          <a:prstGeom prst="roundRect">
+            <a:avLst/>
+          </a:prstGeom>
+          <a:solidFill>
+            <a:srgbClr val="6F42C1"/>
+          </a:solidFill>
+          <a:ln w="12700">
+            <a:solidFill>
+              <a:srgbClr val="6F42C1"/>
+            </a:solidFill>
+          </a:ln>
+        </p:spPr>
+        <p:style>
+          <a:lnRef idx="1">
+            <a:schemeClr val="accent1"/>
+          </a:lnRef>
+          <a:fillRef idx="3">
+            <a:schemeClr val="accent1"/>
+          </a:fillRef>
+          <a:effectRef idx="2">
+            <a:schemeClr val="accent1"/>
+          </a:effectRef>
+          <a:fontRef idx="minor">
+            <a:schemeClr val="lt1"/>
+          </a:fontRef>
+        </p:style>
+        <p:txBody>
+          <a:bodyPr rtlCol="0" anchor="ctr"/>
+          <a:lstStyle/>
+          <a:p>
+            <a:pPr algn="ctr"/>
+          </a:p>
+        </p:txBody>
+      </p:sp>
+      <p:sp>
+        <p:nvSpPr>
+          <p:cNvPr id="56" name="TextBox 55"/>
+          <p:cNvSpPr txBox="1"/>
+          <p:nvPr/>
+        </p:nvSpPr>
+        <p:spPr>
+          <a:xfrm>
+            <a:off x="10378440" y="4608576"/>
+            <a:ext cx="1234440" cy="228600"/>
+          </a:xfrm>
+          <a:prstGeom prst="rect">
+            <a:avLst/>
+          </a:prstGeom>
+          <a:noFill/>
+        </p:spPr>
+        <p:txBody>
+          <a:bodyPr wrap="square">
+            <a:spAutoFit/>
+          </a:bodyPr>
+          <a:lstStyle/>
+          <a:p>
+            <a:pPr algn="ctr">
+              <a:defRPr sz="700" b="1">
+                <a:solidFill>
+                  <a:srgbClr val="FFFFFF"/>
+                </a:solidFill>
+              </a:defRPr>
+            </a:pPr>
+            <a:r>
+              <a:t>Notas</a:t>
+            </a:r>
+          </a:p>
+        </p:txBody>
+      </p:sp>
+      <p:sp>
+        <p:nvSpPr>
+          <p:cNvPr id="57" name="Rounded Rectangle 56"/>
+          <p:cNvSpPr/>
+          <p:nvPr/>
+        </p:nvSpPr>
+        <p:spPr>
+          <a:xfrm>
+            <a:off x="6355080" y="4919472"/>
+            <a:ext cx="914400" cy="256032"/>
+          </a:xfrm>
+          <a:prstGeom prst="roundRect">
+            <a:avLst/>
+          </a:prstGeom>
+          <a:solidFill>
+            <a:srgbClr val="FFFFFF"/>
+          </a:solidFill>
+          <a:ln w="12700">
+            <a:solidFill>
+              <a:srgbClr val="656D76"/>
+            </a:solidFill>
+          </a:ln>
+        </p:spPr>
+        <p:style>
+          <a:lnRef idx="1">
+            <a:schemeClr val="accent1"/>
+          </a:lnRef>
+          <a:fillRef idx="3">
+            <a:schemeClr val="accent1"/>
+          </a:fillRef>
+          <a:effectRef idx="2">
+            <a:schemeClr val="accent1"/>
+          </a:effectRef>
+          <a:fontRef idx="minor">
+            <a:schemeClr val="lt1"/>
+          </a:fontRef>
+        </p:style>
+        <p:txBody>
+          <a:bodyPr rtlCol="0" anchor="ctr"/>
+          <a:lstStyle/>
+          <a:p>
+            <a:pPr algn="ctr"/>
+          </a:p>
+        </p:txBody>
+      </p:sp>
+      <p:sp>
+        <p:nvSpPr>
+          <p:cNvPr id="58" name="TextBox 57"/>
+          <p:cNvSpPr txBox="1"/>
+          <p:nvPr/>
+        </p:nvSpPr>
+        <p:spPr>
+          <a:xfrm>
+            <a:off x="6355080" y="4956048"/>
+            <a:ext cx="914400" cy="182880"/>
+          </a:xfrm>
+          <a:prstGeom prst="rect">
+            <a:avLst/>
+          </a:prstGeom>
+          <a:noFill/>
+        </p:spPr>
+        <p:txBody>
+          <a:bodyPr wrap="square">
+            <a:spAutoFit/>
+          </a:bodyPr>
+          <a:lstStyle/>
+          <a:p>
+            <a:pPr algn="ctr">
+              <a:defRPr sz="800" b="0">
+                <a:solidFill>
+                  <a:srgbClr val="656D76"/>
+                </a:solidFill>
+              </a:defRPr>
+            </a:pPr>
+            <a:r>
+              <a:t>…</a:t>
+            </a:r>
+          </a:p>
+        </p:txBody>
+      </p:sp>
+      <p:sp>
+        <p:nvSpPr>
+          <p:cNvPr id="59" name="Rounded Rectangle 58"/>
+          <p:cNvSpPr/>
+          <p:nvPr/>
+        </p:nvSpPr>
+        <p:spPr>
+          <a:xfrm>
+            <a:off x="8275320" y="4919472"/>
+            <a:ext cx="914400" cy="256032"/>
+          </a:xfrm>
+          <a:prstGeom prst="roundRect">
+            <a:avLst/>
+          </a:prstGeom>
+          <a:solidFill>
+            <a:srgbClr val="FFFFFF"/>
+          </a:solidFill>
+          <a:ln w="12700">
+            <a:solidFill>
+              <a:srgbClr val="656D76"/>
+            </a:solidFill>
+          </a:ln>
+        </p:spPr>
+        <p:style>
+          <a:lnRef idx="1">
+            <a:schemeClr val="accent1"/>
+          </a:lnRef>
+          <a:fillRef idx="3">
+            <a:schemeClr val="accent1"/>
+          </a:fillRef>
+          <a:effectRef idx="2">
+            <a:schemeClr val="accent1"/>
+          </a:effectRef>
+          <a:fontRef idx="minor">
+            <a:schemeClr val="lt1"/>
+          </a:fontRef>
+        </p:style>
+        <p:txBody>
+          <a:bodyPr rtlCol="0" anchor="ctr"/>
+          <a:lstStyle/>
+          <a:p>
+            <a:pPr algn="ctr"/>
+          </a:p>
+        </p:txBody>
+      </p:sp>
+      <p:sp>
+        <p:nvSpPr>
+          <p:cNvPr id="60" name="TextBox 59"/>
+          <p:cNvSpPr txBox="1"/>
+          <p:nvPr/>
+        </p:nvSpPr>
+        <p:spPr>
+          <a:xfrm>
+            <a:off x="8275320" y="4956048"/>
+            <a:ext cx="914400" cy="182880"/>
+          </a:xfrm>
+          <a:prstGeom prst="rect">
+            <a:avLst/>
+          </a:prstGeom>
+          <a:noFill/>
+        </p:spPr>
+        <p:txBody>
+          <a:bodyPr wrap="square">
+            <a:spAutoFit/>
+          </a:bodyPr>
+          <a:lstStyle/>
+          <a:p>
+            <a:pPr algn="ctr">
+              <a:defRPr sz="800" b="0">
+                <a:solidFill>
+                  <a:srgbClr val="656D76"/>
+                </a:solidFill>
+              </a:defRPr>
+            </a:pPr>
+            <a:r>
+              <a:t>…</a:t>
+            </a:r>
+          </a:p>
+        </p:txBody>
+      </p:sp>
+      <p:sp>
+        <p:nvSpPr>
+          <p:cNvPr id="61" name="Rounded Rectangle 60"/>
+          <p:cNvSpPr/>
+          <p:nvPr/>
+        </p:nvSpPr>
+        <p:spPr>
+          <a:xfrm>
+            <a:off x="9464040" y="4919472"/>
+            <a:ext cx="914400" cy="256032"/>
+          </a:xfrm>
+          <a:prstGeom prst="roundRect">
+            <a:avLst/>
+          </a:prstGeom>
+          <a:solidFill>
+            <a:srgbClr val="FFFFFF"/>
+          </a:solidFill>
+          <a:ln w="12700">
+            <a:solidFill>
+              <a:srgbClr val="656D76"/>
+            </a:solidFill>
+          </a:ln>
+        </p:spPr>
+        <p:style>
+          <a:lnRef idx="1">
+            <a:schemeClr val="accent1"/>
+          </a:lnRef>
+          <a:fillRef idx="3">
+            <a:schemeClr val="accent1"/>
+          </a:fillRef>
+          <a:effectRef idx="2">
+            <a:schemeClr val="accent1"/>
+          </a:effectRef>
+          <a:fontRef idx="minor">
+            <a:schemeClr val="lt1"/>
+          </a:fontRef>
+        </p:style>
+        <p:txBody>
+          <a:bodyPr rtlCol="0" anchor="ctr"/>
+          <a:lstStyle/>
+          <a:p>
+            <a:pPr algn="ctr"/>
+          </a:p>
+        </p:txBody>
+      </p:sp>
+      <p:sp>
+        <p:nvSpPr>
+          <p:cNvPr id="62" name="TextBox 61"/>
+          <p:cNvSpPr txBox="1"/>
+          <p:nvPr/>
+        </p:nvSpPr>
+        <p:spPr>
+          <a:xfrm>
+            <a:off x="9464040" y="4956048"/>
+            <a:ext cx="914400" cy="182880"/>
+          </a:xfrm>
+          <a:prstGeom prst="rect">
+            <a:avLst/>
+          </a:prstGeom>
+          <a:noFill/>
+        </p:spPr>
+        <p:txBody>
+          <a:bodyPr wrap="square">
+            <a:spAutoFit/>
+          </a:bodyPr>
+          <a:lstStyle/>
+          <a:p>
+            <a:pPr algn="ctr">
+              <a:defRPr sz="800" b="0">
+                <a:solidFill>
+                  <a:srgbClr val="656D76"/>
+                </a:solidFill>
+              </a:defRPr>
+            </a:pPr>
+            <a:r>
+              <a:t>…</a:t>
+            </a:r>
+          </a:p>
+        </p:txBody>
+      </p:sp>
+      <p:sp>
+        <p:nvSpPr>
+          <p:cNvPr id="63" name="Rounded Rectangle 62"/>
+          <p:cNvSpPr/>
+          <p:nvPr/>
+        </p:nvSpPr>
+        <p:spPr>
+          <a:xfrm>
+            <a:off x="10378440" y="4919472"/>
+            <a:ext cx="1234440" cy="256032"/>
+          </a:xfrm>
+          <a:prstGeom prst="roundRect">
+            <a:avLst/>
+          </a:prstGeom>
+          <a:solidFill>
+            <a:srgbClr val="FFFFFF"/>
+          </a:solidFill>
+          <a:ln w="12700">
+            <a:solidFill>
+              <a:srgbClr val="656D76"/>
+            </a:solidFill>
+          </a:ln>
+        </p:spPr>
+        <p:style>
+          <a:lnRef idx="1">
+            <a:schemeClr val="accent1"/>
+          </a:lnRef>
+          <a:fillRef idx="3">
+            <a:schemeClr val="accent1"/>
+          </a:fillRef>
+          <a:effectRef idx="2">
+            <a:schemeClr val="accent1"/>
+          </a:effectRef>
+          <a:fontRef idx="minor">
+            <a:schemeClr val="lt1"/>
+          </a:fontRef>
+        </p:style>
+        <p:txBody>
+          <a:bodyPr rtlCol="0" anchor="ctr"/>
+          <a:lstStyle/>
+          <a:p>
+            <a:pPr algn="ctr"/>
+          </a:p>
+        </p:txBody>
+      </p:sp>
+      <p:sp>
+        <p:nvSpPr>
+          <p:cNvPr id="64" name="TextBox 63"/>
+          <p:cNvSpPr txBox="1"/>
+          <p:nvPr/>
+        </p:nvSpPr>
+        <p:spPr>
+          <a:xfrm>
+            <a:off x="10378440" y="4956048"/>
+            <a:ext cx="1234440" cy="182880"/>
+          </a:xfrm>
+          <a:prstGeom prst="rect">
+            <a:avLst/>
+          </a:prstGeom>
+          <a:noFill/>
+        </p:spPr>
+        <p:txBody>
+          <a:bodyPr wrap="square">
+            <a:spAutoFit/>
+          </a:bodyPr>
+          <a:lstStyle/>
+          <a:p>
+            <a:pPr algn="ctr">
+              <a:defRPr sz="800" b="0">
+                <a:solidFill>
+                  <a:srgbClr val="656D76"/>
+                </a:solidFill>
+              </a:defRPr>
+            </a:pPr>
+            <a:r>
+              <a:t>…</a:t>
+            </a:r>
+          </a:p>
+        </p:txBody>
+      </p:sp>
+      <p:sp>
+        <p:nvSpPr>
+          <p:cNvPr id="65" name="Rounded Rectangle 64"/>
+          <p:cNvSpPr/>
+          <p:nvPr/>
+        </p:nvSpPr>
+        <p:spPr>
+          <a:xfrm>
+            <a:off x="6355080" y="5230368"/>
+            <a:ext cx="914400" cy="256032"/>
+          </a:xfrm>
+          <a:prstGeom prst="roundRect">
+            <a:avLst/>
+          </a:prstGeom>
+          <a:solidFill>
+            <a:srgbClr val="FFFFFF"/>
+          </a:solidFill>
+          <a:ln w="12700">
+            <a:solidFill>
+              <a:srgbClr val="656D76"/>
+            </a:solidFill>
+          </a:ln>
+        </p:spPr>
+        <p:style>
+          <a:lnRef idx="1">
+            <a:schemeClr val="accent1"/>
+          </a:lnRef>
+          <a:fillRef idx="3">
+            <a:schemeClr val="accent1"/>
+          </a:fillRef>
+          <a:effectRef idx="2">
+            <a:schemeClr val="accent1"/>
+          </a:effectRef>
+          <a:fontRef idx="minor">
+            <a:schemeClr val="lt1"/>
+          </a:fontRef>
+        </p:style>
+        <p:txBody>
+          <a:bodyPr rtlCol="0" anchor="ctr"/>
+          <a:lstStyle/>
+          <a:p>
+            <a:pPr algn="ctr"/>
+          </a:p>
+        </p:txBody>
+      </p:sp>
+      <p:sp>
+        <p:nvSpPr>
+          <p:cNvPr id="66" name="TextBox 65"/>
+          <p:cNvSpPr txBox="1"/>
+          <p:nvPr/>
+        </p:nvSpPr>
+        <p:spPr>
+          <a:xfrm>
+            <a:off x="6355080" y="5266944"/>
+            <a:ext cx="914400" cy="182880"/>
+          </a:xfrm>
+          <a:prstGeom prst="rect">
+            <a:avLst/>
+          </a:prstGeom>
+          <a:noFill/>
+        </p:spPr>
+        <p:txBody>
+          <a:bodyPr wrap="square">
+            <a:spAutoFit/>
+          </a:bodyPr>
+          <a:lstStyle/>
+          <a:p>
+            <a:pPr algn="ctr">
+              <a:defRPr sz="800" b="0">
+                <a:solidFill>
+                  <a:srgbClr val="656D76"/>
+                </a:solidFill>
+              </a:defRPr>
+            </a:pPr>
+            <a:r>
+              <a:t>…</a:t>
+            </a:r>
+          </a:p>
+        </p:txBody>
+      </p:sp>
+      <p:sp>
+        <p:nvSpPr>
+          <p:cNvPr id="67" name="Rounded Rectangle 66"/>
+          <p:cNvSpPr/>
+          <p:nvPr/>
+        </p:nvSpPr>
+        <p:spPr>
+          <a:xfrm>
+            <a:off x="8275320" y="5230368"/>
+            <a:ext cx="914400" cy="256032"/>
+          </a:xfrm>
+          <a:prstGeom prst="roundRect">
+            <a:avLst/>
+          </a:prstGeom>
+          <a:solidFill>
+            <a:srgbClr val="FFFFFF"/>
+          </a:solidFill>
+          <a:ln w="12700">
+            <a:solidFill>
+              <a:srgbClr val="656D76"/>
+            </a:solidFill>
+          </a:ln>
+        </p:spPr>
+        <p:style>
+          <a:lnRef idx="1">
+            <a:schemeClr val="accent1"/>
+          </a:lnRef>
+          <a:fillRef idx="3">
+            <a:schemeClr val="accent1"/>
+          </a:fillRef>
+          <a:effectRef idx="2">
+            <a:schemeClr val="accent1"/>
+          </a:effectRef>
+          <a:fontRef idx="minor">
+            <a:schemeClr val="lt1"/>
+          </a:fontRef>
+        </p:style>
+        <p:txBody>
+          <a:bodyPr rtlCol="0" anchor="ctr"/>
+          <a:lstStyle/>
+          <a:p>
+            <a:pPr algn="ctr"/>
+          </a:p>
+        </p:txBody>
+      </p:sp>
+      <p:sp>
+        <p:nvSpPr>
+          <p:cNvPr id="68" name="TextBox 67"/>
+          <p:cNvSpPr txBox="1"/>
+          <p:nvPr/>
+        </p:nvSpPr>
+        <p:spPr>
+          <a:xfrm>
+            <a:off x="8275320" y="5266944"/>
+            <a:ext cx="914400" cy="182880"/>
+          </a:xfrm>
+          <a:prstGeom prst="rect">
+            <a:avLst/>
+          </a:prstGeom>
+          <a:noFill/>
+        </p:spPr>
+        <p:txBody>
+          <a:bodyPr wrap="square">
+            <a:spAutoFit/>
+          </a:bodyPr>
+          <a:lstStyle/>
+          <a:p>
+            <a:pPr algn="ctr">
+              <a:defRPr sz="800" b="0">
+                <a:solidFill>
+                  <a:srgbClr val="656D76"/>
+                </a:solidFill>
+              </a:defRPr>
+            </a:pPr>
+            <a:r>
+              <a:t>…</a:t>
+            </a:r>
+          </a:p>
+        </p:txBody>
+      </p:sp>
+      <p:sp>
+        <p:nvSpPr>
+          <p:cNvPr id="69" name="Rounded Rectangle 68"/>
+          <p:cNvSpPr/>
+          <p:nvPr/>
+        </p:nvSpPr>
+        <p:spPr>
+          <a:xfrm>
+            <a:off x="9464040" y="5230368"/>
+            <a:ext cx="914400" cy="256032"/>
+          </a:xfrm>
+          <a:prstGeom prst="roundRect">
+            <a:avLst/>
+          </a:prstGeom>
+          <a:solidFill>
+            <a:srgbClr val="FFFFFF"/>
+          </a:solidFill>
+          <a:ln w="12700">
+            <a:solidFill>
+              <a:srgbClr val="656D76"/>
+            </a:solidFill>
+          </a:ln>
+        </p:spPr>
+        <p:style>
+          <a:lnRef idx="1">
+            <a:schemeClr val="accent1"/>
+          </a:lnRef>
+          <a:fillRef idx="3">
+            <a:schemeClr val="accent1"/>
+          </a:fillRef>
+          <a:effectRef idx="2">
+            <a:schemeClr val="accent1"/>
+          </a:effectRef>
+          <a:fontRef idx="minor">
+            <a:schemeClr val="lt1"/>
+          </a:fontRef>
+        </p:style>
+        <p:txBody>
+          <a:bodyPr rtlCol="0" anchor="ctr"/>
+          <a:lstStyle/>
+          <a:p>
+            <a:pPr algn="ctr"/>
+          </a:p>
+        </p:txBody>
+      </p:sp>
+      <p:sp>
+        <p:nvSpPr>
+          <p:cNvPr id="70" name="TextBox 69"/>
+          <p:cNvSpPr txBox="1"/>
+          <p:nvPr/>
+        </p:nvSpPr>
+        <p:spPr>
+          <a:xfrm>
+            <a:off x="9464040" y="5266944"/>
+            <a:ext cx="914400" cy="182880"/>
+          </a:xfrm>
+          <a:prstGeom prst="rect">
+            <a:avLst/>
+          </a:prstGeom>
+          <a:noFill/>
+        </p:spPr>
+        <p:txBody>
+          <a:bodyPr wrap="square">
+            <a:spAutoFit/>
+          </a:bodyPr>
+          <a:lstStyle/>
+          <a:p>
+            <a:pPr algn="ctr">
+              <a:defRPr sz="800" b="0">
+                <a:solidFill>
+                  <a:srgbClr val="656D76"/>
+                </a:solidFill>
+              </a:defRPr>
+            </a:pPr>
+            <a:r>
+              <a:t>…</a:t>
+            </a:r>
+          </a:p>
+        </p:txBody>
+      </p:sp>
+      <p:sp>
+        <p:nvSpPr>
+          <p:cNvPr id="71" name="Rounded Rectangle 70"/>
+          <p:cNvSpPr/>
+          <p:nvPr/>
+        </p:nvSpPr>
+        <p:spPr>
+          <a:xfrm>
+            <a:off x="10378440" y="5230368"/>
+            <a:ext cx="1234440" cy="256032"/>
+          </a:xfrm>
+          <a:prstGeom prst="roundRect">
+            <a:avLst/>
+          </a:prstGeom>
+          <a:solidFill>
+            <a:srgbClr val="FFFFFF"/>
+          </a:solidFill>
+          <a:ln w="12700">
+            <a:solidFill>
+              <a:srgbClr val="656D76"/>
+            </a:solidFill>
+          </a:ln>
+        </p:spPr>
+        <p:style>
+          <a:lnRef idx="1">
+            <a:schemeClr val="accent1"/>
+          </a:lnRef>
+          <a:fillRef idx="3">
+            <a:schemeClr val="accent1"/>
+          </a:fillRef>
+          <a:effectRef idx="2">
+            <a:schemeClr val="accent1"/>
+          </a:effectRef>
+          <a:fontRef idx="minor">
+            <a:schemeClr val="lt1"/>
+          </a:fontRef>
+        </p:style>
+        <p:txBody>
+          <a:bodyPr rtlCol="0" anchor="ctr"/>
+          <a:lstStyle/>
+          <a:p>
+            <a:pPr algn="ctr"/>
+          </a:p>
+        </p:txBody>
+      </p:sp>
+      <p:sp>
+        <p:nvSpPr>
+          <p:cNvPr id="72" name="TextBox 71"/>
+          <p:cNvSpPr txBox="1"/>
+          <p:nvPr/>
+        </p:nvSpPr>
+        <p:spPr>
+          <a:xfrm>
+            <a:off x="10378440" y="5266944"/>
+            <a:ext cx="1234440" cy="182880"/>
+          </a:xfrm>
+          <a:prstGeom prst="rect">
+            <a:avLst/>
+          </a:prstGeom>
+          <a:noFill/>
+        </p:spPr>
+        <p:txBody>
+          <a:bodyPr wrap="square">
+            <a:spAutoFit/>
+          </a:bodyPr>
+          <a:lstStyle/>
+          <a:p>
+            <a:pPr algn="ctr">
+              <a:defRPr sz="800" b="0">
+                <a:solidFill>
+                  <a:srgbClr val="656D76"/>
+                </a:solidFill>
+              </a:defRPr>
+            </a:pPr>
+            <a:r>
+              <a:t>…</a:t>
+            </a:r>
+          </a:p>
+        </p:txBody>
+      </p:sp>
+      <p:sp>
+        <p:nvSpPr>
+          <p:cNvPr id="73" name="Rounded Rectangle 72"/>
+          <p:cNvSpPr/>
+          <p:nvPr/>
+        </p:nvSpPr>
+        <p:spPr>
+          <a:xfrm>
+            <a:off x="502920" y="5806440"/>
+            <a:ext cx="11155680" cy="658368"/>
+          </a:xfrm>
+          <a:prstGeom prst="roundRect">
+            <a:avLst/>
+          </a:prstGeom>
+          <a:solidFill>
+            <a:srgbClr val="FFF8C5"/>
+          </a:solidFill>
+          <a:ln w="12700">
+            <a:solidFill>
+              <a:srgbClr val="6F42C1"/>
+            </a:solidFill>
+          </a:ln>
+        </p:spPr>
+        <p:style>
+          <a:lnRef idx="1">
+            <a:schemeClr val="accent1"/>
+          </a:lnRef>
+          <a:fillRef idx="3">
+            <a:schemeClr val="accent1"/>
+          </a:fillRef>
+          <a:effectRef idx="2">
+            <a:schemeClr val="accent1"/>
+          </a:effectRef>
+          <a:fontRef idx="minor">
+            <a:schemeClr val="lt1"/>
+          </a:fontRef>
+        </p:style>
+        <p:txBody>
+          <a:bodyPr rtlCol="0" anchor="ctr"/>
+          <a:lstStyle/>
+          <a:p>
+            <a:pPr algn="ctr"/>
+          </a:p>
+        </p:txBody>
+      </p:sp>
+      <p:sp>
+        <p:nvSpPr>
+          <p:cNvPr id="74" name="TextBox 73"/>
+          <p:cNvSpPr txBox="1"/>
+          <p:nvPr/>
+        </p:nvSpPr>
+        <p:spPr>
+          <a:xfrm>
+            <a:off x="685800" y="5925312"/>
+            <a:ext cx="10789920" cy="411480"/>
+          </a:xfrm>
+          <a:prstGeom prst="rect">
+            <a:avLst/>
+          </a:prstGeom>
+          <a:noFill/>
+        </p:spPr>
+        <p:txBody>
+          <a:bodyPr wrap="square">
+            <a:spAutoFit/>
+          </a:bodyPr>
+          <a:lstStyle/>
+          <a:p>
+            <a:pPr algn="l">
+              <a:defRPr sz="1100" b="1">
+                <a:solidFill>
+                  <a:srgbClr val="2A4A4E"/>
+                </a:solidFill>
+              </a:defRPr>
+            </a:pPr>
+            <a:r>
+              <a:t>Hito paralelo (opcional): backup semanal de workflows → repo privado mova-n8n-workflows en GitHub.</a:t>
+            </a:r>
+            <a:br/>
+            <a:r>
+              <a:t>Tú puedes seguir con mova_auth (Días 2–7) sin entrar a n8n.</a:t>
             </a:r>
           </a:p>
         </p:txBody>

</xml_diff>